<commit_message>
Leave text below 30 px per em to the browser's hinted rendering
PowerPoint draws text up to 22 pt hinted, with crisp horizontal edges on whole-pixel baselines, and smooth from
23 pt (new size sweep in the text-snap deck). Small text is now browser text again, which matches PowerPoint's
hinted rendering closely (Arial exactly); embedded fonts are no longer patched. Fidelity overall 98.5 %.

Co-Authored-By: Claude Opus 5.5 <noreply@anthropic.com>
</commit_message>
<xml_diff>
--- a/tests/corpus/pptx/generated/text-snap.pptx
+++ b/tests/corpus/pptx/generated/text-snap.pptx
@@ -9,6 +9,7 @@
     <p:sldId id="257" r:id="rId3"/>
     <p:sldId id="258" r:id="rId4"/>
     <p:sldId id="259" r:id="rId5"/>
+    <p:sldId id="260" r:id="rId6"/>
   </p:sldIdLst>
   <p:sldSz cx="12192000" cy="6858000"/>
   <p:notesSz cx="6858000" cy="9144000"/>
@@ -132,7 +133,7 @@
           <p:cNvPr id="2" name="Titel 1">
             <a:extLst>
               <a:ext uri="{FF2B5EF4-FFF2-40B4-BE49-F238E27FC236}">
-                <a16:creationId xmlns:a16="http://schemas.microsoft.com/office/drawing/2014/main" id="{BDB1D38E-7C7A-C5A4-EE57-D64CA814C7C4}"/>
+                <a16:creationId xmlns:a16="http://schemas.microsoft.com/office/drawing/2014/main" id="{948B568C-0091-DC9F-D440-F2F20450158C}"/>
               </a:ext>
             </a:extLst>
           </p:cNvPr>
@@ -169,7 +170,7 @@
           <p:cNvPr id="3" name="Untertitel 2">
             <a:extLst>
               <a:ext uri="{FF2B5EF4-FFF2-40B4-BE49-F238E27FC236}">
-                <a16:creationId xmlns:a16="http://schemas.microsoft.com/office/drawing/2014/main" id="{09DC187B-C492-F93A-0C71-9F34AA48C779}"/>
+                <a16:creationId xmlns:a16="http://schemas.microsoft.com/office/drawing/2014/main" id="{927A0728-5811-6083-0D37-18906AD36794}"/>
               </a:ext>
             </a:extLst>
           </p:cNvPr>
@@ -239,7 +240,7 @@
           <p:cNvPr id="4" name="Datumsplatzhalter 3">
             <a:extLst>
               <a:ext uri="{FF2B5EF4-FFF2-40B4-BE49-F238E27FC236}">
-                <a16:creationId xmlns:a16="http://schemas.microsoft.com/office/drawing/2014/main" id="{E54DA151-5236-C6AE-7421-305CFB524613}"/>
+                <a16:creationId xmlns:a16="http://schemas.microsoft.com/office/drawing/2014/main" id="{9D25C88B-E95D-0112-255F-DDC3D3BA0795}"/>
               </a:ext>
             </a:extLst>
           </p:cNvPr>
@@ -255,7 +256,7 @@
           <a:bodyPr/>
           <a:lstStyle/>
           <a:p>
-            <a:fld id="{4BA8EA37-AF8A-4F4B-8A94-E78695846435}" type="datetimeFigureOut">
+            <a:fld id="{ED4BFDCA-C350-438F-96BC-278A18682A11}" type="datetimeFigureOut">
               <a:rPr lang="de-DE" smtClean="0"/>
               <a:t>08.10.2026</a:t>
             </a:fld>
@@ -268,7 +269,7 @@
           <p:cNvPr id="5" name="Fußzeilenplatzhalter 4">
             <a:extLst>
               <a:ext uri="{FF2B5EF4-FFF2-40B4-BE49-F238E27FC236}">
-                <a16:creationId xmlns:a16="http://schemas.microsoft.com/office/drawing/2014/main" id="{46FF668A-3368-6B41-980C-8CD579DD41DB}"/>
+                <a16:creationId xmlns:a16="http://schemas.microsoft.com/office/drawing/2014/main" id="{60488C7F-9CD3-5FB0-EC57-62DCF2A3B201}"/>
               </a:ext>
             </a:extLst>
           </p:cNvPr>
@@ -293,7 +294,7 @@
           <p:cNvPr id="6" name="Foliennummernplatzhalter 5">
             <a:extLst>
               <a:ext uri="{FF2B5EF4-FFF2-40B4-BE49-F238E27FC236}">
-                <a16:creationId xmlns:a16="http://schemas.microsoft.com/office/drawing/2014/main" id="{E3024A15-573F-1CA1-7F9B-BFBB2695D848}"/>
+                <a16:creationId xmlns:a16="http://schemas.microsoft.com/office/drawing/2014/main" id="{7F6D6DF9-17E2-36FB-6F88-0D5A39F22497}"/>
               </a:ext>
             </a:extLst>
           </p:cNvPr>
@@ -309,7 +310,7 @@
           <a:bodyPr/>
           <a:lstStyle/>
           <a:p>
-            <a:fld id="{709359BE-745B-4215-9DBF-4AAEB7BEE5E4}" type="slidenum">
+            <a:fld id="{3323FF0A-FBC4-4B75-81F2-FAECE708117C}" type="slidenum">
               <a:rPr lang="de-DE" smtClean="0"/>
               <a:t>‹Nr.›</a:t>
             </a:fld>
@@ -320,7 +321,7 @@
     </p:spTree>
     <p:extLst>
       <p:ext uri="{BB962C8B-B14F-4D97-AF65-F5344CB8AC3E}">
-        <p14:creationId xmlns:p14="http://schemas.microsoft.com/office/powerpoint/2010/main" val="2525552327"/>
+        <p14:creationId xmlns:p14="http://schemas.microsoft.com/office/powerpoint/2010/main" val="1013246639"/>
       </p:ext>
     </p:extLst>
   </p:cSld>
@@ -352,7 +353,7 @@
           <p:cNvPr id="2" name="Titel 1">
             <a:extLst>
               <a:ext uri="{FF2B5EF4-FFF2-40B4-BE49-F238E27FC236}">
-                <a16:creationId xmlns:a16="http://schemas.microsoft.com/office/drawing/2014/main" id="{EF5D42A0-C559-1525-2DF2-13FCE5221BDF}"/>
+                <a16:creationId xmlns:a16="http://schemas.microsoft.com/office/drawing/2014/main" id="{B27906B2-4C91-E78B-0494-A09C1B873FAC}"/>
               </a:ext>
             </a:extLst>
           </p:cNvPr>
@@ -380,7 +381,7 @@
           <p:cNvPr id="3" name="Vertikaler Textplatzhalter 2">
             <a:extLst>
               <a:ext uri="{FF2B5EF4-FFF2-40B4-BE49-F238E27FC236}">
-                <a16:creationId xmlns:a16="http://schemas.microsoft.com/office/drawing/2014/main" id="{CD51427A-D06D-685C-3664-73BE8578E6B2}"/>
+                <a16:creationId xmlns:a16="http://schemas.microsoft.com/office/drawing/2014/main" id="{61C21512-E0EE-336C-0595-357C4FBA15E5}"/>
               </a:ext>
             </a:extLst>
           </p:cNvPr>
@@ -437,7 +438,7 @@
           <p:cNvPr id="4" name="Datumsplatzhalter 3">
             <a:extLst>
               <a:ext uri="{FF2B5EF4-FFF2-40B4-BE49-F238E27FC236}">
-                <a16:creationId xmlns:a16="http://schemas.microsoft.com/office/drawing/2014/main" id="{4B685A37-3105-ECF2-4399-6DC5D6D799D1}"/>
+                <a16:creationId xmlns:a16="http://schemas.microsoft.com/office/drawing/2014/main" id="{11CBABDF-F91F-972E-1975-BA179FD64B2D}"/>
               </a:ext>
             </a:extLst>
           </p:cNvPr>
@@ -453,7 +454,7 @@
           <a:bodyPr/>
           <a:lstStyle/>
           <a:p>
-            <a:fld id="{4BA8EA37-AF8A-4F4B-8A94-E78695846435}" type="datetimeFigureOut">
+            <a:fld id="{ED4BFDCA-C350-438F-96BC-278A18682A11}" type="datetimeFigureOut">
               <a:rPr lang="de-DE" smtClean="0"/>
               <a:t>08.10.2026</a:t>
             </a:fld>
@@ -466,7 +467,7 @@
           <p:cNvPr id="5" name="Fußzeilenplatzhalter 4">
             <a:extLst>
               <a:ext uri="{FF2B5EF4-FFF2-40B4-BE49-F238E27FC236}">
-                <a16:creationId xmlns:a16="http://schemas.microsoft.com/office/drawing/2014/main" id="{810A2C92-271A-0FFB-37BE-F42634DA2890}"/>
+                <a16:creationId xmlns:a16="http://schemas.microsoft.com/office/drawing/2014/main" id="{719853D2-C2C7-6D14-1A6D-7EB629BD2756}"/>
               </a:ext>
             </a:extLst>
           </p:cNvPr>
@@ -491,7 +492,7 @@
           <p:cNvPr id="6" name="Foliennummernplatzhalter 5">
             <a:extLst>
               <a:ext uri="{FF2B5EF4-FFF2-40B4-BE49-F238E27FC236}">
-                <a16:creationId xmlns:a16="http://schemas.microsoft.com/office/drawing/2014/main" id="{78181D0B-C1A4-A862-A528-F4B43D31E5C4}"/>
+                <a16:creationId xmlns:a16="http://schemas.microsoft.com/office/drawing/2014/main" id="{6C91249B-4A0E-854C-9911-BFD0A878EE74}"/>
               </a:ext>
             </a:extLst>
           </p:cNvPr>
@@ -507,7 +508,7 @@
           <a:bodyPr/>
           <a:lstStyle/>
           <a:p>
-            <a:fld id="{709359BE-745B-4215-9DBF-4AAEB7BEE5E4}" type="slidenum">
+            <a:fld id="{3323FF0A-FBC4-4B75-81F2-FAECE708117C}" type="slidenum">
               <a:rPr lang="de-DE" smtClean="0"/>
               <a:t>‹Nr.›</a:t>
             </a:fld>
@@ -518,7 +519,7 @@
     </p:spTree>
     <p:extLst>
       <p:ext uri="{BB962C8B-B14F-4D97-AF65-F5344CB8AC3E}">
-        <p14:creationId xmlns:p14="http://schemas.microsoft.com/office/powerpoint/2010/main" val="2784315613"/>
+        <p14:creationId xmlns:p14="http://schemas.microsoft.com/office/powerpoint/2010/main" val="998993685"/>
       </p:ext>
     </p:extLst>
   </p:cSld>
@@ -550,7 +551,7 @@
           <p:cNvPr id="2" name="Vertikaler Titel 1">
             <a:extLst>
               <a:ext uri="{FF2B5EF4-FFF2-40B4-BE49-F238E27FC236}">
-                <a16:creationId xmlns:a16="http://schemas.microsoft.com/office/drawing/2014/main" id="{93874F7D-9F7E-794A-A8E6-52C04BC7DED8}"/>
+                <a16:creationId xmlns:a16="http://schemas.microsoft.com/office/drawing/2014/main" id="{16D3A74E-186C-0D98-7B24-C37196E2ACBD}"/>
               </a:ext>
             </a:extLst>
           </p:cNvPr>
@@ -583,7 +584,7 @@
           <p:cNvPr id="3" name="Vertikaler Textplatzhalter 2">
             <a:extLst>
               <a:ext uri="{FF2B5EF4-FFF2-40B4-BE49-F238E27FC236}">
-                <a16:creationId xmlns:a16="http://schemas.microsoft.com/office/drawing/2014/main" id="{73300942-98F2-4346-B366-CFD7B4298684}"/>
+                <a16:creationId xmlns:a16="http://schemas.microsoft.com/office/drawing/2014/main" id="{B9C086AE-C981-1DCF-4F13-E1D14D2A9E1F}"/>
               </a:ext>
             </a:extLst>
           </p:cNvPr>
@@ -645,7 +646,7 @@
           <p:cNvPr id="4" name="Datumsplatzhalter 3">
             <a:extLst>
               <a:ext uri="{FF2B5EF4-FFF2-40B4-BE49-F238E27FC236}">
-                <a16:creationId xmlns:a16="http://schemas.microsoft.com/office/drawing/2014/main" id="{C9BF18E1-110F-F319-3E6B-B35931A20BB3}"/>
+                <a16:creationId xmlns:a16="http://schemas.microsoft.com/office/drawing/2014/main" id="{E0DA5B00-51F8-1E34-62C4-E9F1129597DA}"/>
               </a:ext>
             </a:extLst>
           </p:cNvPr>
@@ -661,7 +662,7 @@
           <a:bodyPr/>
           <a:lstStyle/>
           <a:p>
-            <a:fld id="{4BA8EA37-AF8A-4F4B-8A94-E78695846435}" type="datetimeFigureOut">
+            <a:fld id="{ED4BFDCA-C350-438F-96BC-278A18682A11}" type="datetimeFigureOut">
               <a:rPr lang="de-DE" smtClean="0"/>
               <a:t>08.10.2026</a:t>
             </a:fld>
@@ -674,7 +675,7 @@
           <p:cNvPr id="5" name="Fußzeilenplatzhalter 4">
             <a:extLst>
               <a:ext uri="{FF2B5EF4-FFF2-40B4-BE49-F238E27FC236}">
-                <a16:creationId xmlns:a16="http://schemas.microsoft.com/office/drawing/2014/main" id="{3CF25FB6-9FB8-0C7C-80F1-A618ADABD602}"/>
+                <a16:creationId xmlns:a16="http://schemas.microsoft.com/office/drawing/2014/main" id="{8CB2D423-74A1-C5DA-27A0-6E22FEE72E41}"/>
               </a:ext>
             </a:extLst>
           </p:cNvPr>
@@ -699,7 +700,7 @@
           <p:cNvPr id="6" name="Foliennummernplatzhalter 5">
             <a:extLst>
               <a:ext uri="{FF2B5EF4-FFF2-40B4-BE49-F238E27FC236}">
-                <a16:creationId xmlns:a16="http://schemas.microsoft.com/office/drawing/2014/main" id="{42D20720-D796-AD99-30C8-C8A2C9566212}"/>
+                <a16:creationId xmlns:a16="http://schemas.microsoft.com/office/drawing/2014/main" id="{D74B6488-8D7F-E0D4-9CAF-ED96012C2C65}"/>
               </a:ext>
             </a:extLst>
           </p:cNvPr>
@@ -715,7 +716,7 @@
           <a:bodyPr/>
           <a:lstStyle/>
           <a:p>
-            <a:fld id="{709359BE-745B-4215-9DBF-4AAEB7BEE5E4}" type="slidenum">
+            <a:fld id="{3323FF0A-FBC4-4B75-81F2-FAECE708117C}" type="slidenum">
               <a:rPr lang="de-DE" smtClean="0"/>
               <a:t>‹Nr.›</a:t>
             </a:fld>
@@ -726,7 +727,7 @@
     </p:spTree>
     <p:extLst>
       <p:ext uri="{BB962C8B-B14F-4D97-AF65-F5344CB8AC3E}">
-        <p14:creationId xmlns:p14="http://schemas.microsoft.com/office/powerpoint/2010/main" val="443156895"/>
+        <p14:creationId xmlns:p14="http://schemas.microsoft.com/office/powerpoint/2010/main" val="2497730005"/>
       </p:ext>
     </p:extLst>
   </p:cSld>
@@ -758,7 +759,7 @@
           <p:cNvPr id="2" name="Titel 1">
             <a:extLst>
               <a:ext uri="{FF2B5EF4-FFF2-40B4-BE49-F238E27FC236}">
-                <a16:creationId xmlns:a16="http://schemas.microsoft.com/office/drawing/2014/main" id="{41E14802-0415-4AA8-FF00-834556B9E860}"/>
+                <a16:creationId xmlns:a16="http://schemas.microsoft.com/office/drawing/2014/main" id="{98454A47-0961-66C1-AD90-794C311EF3A9}"/>
               </a:ext>
             </a:extLst>
           </p:cNvPr>
@@ -786,7 +787,7 @@
           <p:cNvPr id="3" name="Inhaltsplatzhalter 2">
             <a:extLst>
               <a:ext uri="{FF2B5EF4-FFF2-40B4-BE49-F238E27FC236}">
-                <a16:creationId xmlns:a16="http://schemas.microsoft.com/office/drawing/2014/main" id="{FD477F1E-EB18-FD49-3407-16CDE381C383}"/>
+                <a16:creationId xmlns:a16="http://schemas.microsoft.com/office/drawing/2014/main" id="{D1E09089-ABEF-BC92-817A-99B545A17F50}"/>
               </a:ext>
             </a:extLst>
           </p:cNvPr>
@@ -843,7 +844,7 @@
           <p:cNvPr id="4" name="Datumsplatzhalter 3">
             <a:extLst>
               <a:ext uri="{FF2B5EF4-FFF2-40B4-BE49-F238E27FC236}">
-                <a16:creationId xmlns:a16="http://schemas.microsoft.com/office/drawing/2014/main" id="{593B5642-1D57-E6B4-1C69-CECB7AD96323}"/>
+                <a16:creationId xmlns:a16="http://schemas.microsoft.com/office/drawing/2014/main" id="{4E2F3F2F-D873-996E-B1D5-FE356CBAF8E8}"/>
               </a:ext>
             </a:extLst>
           </p:cNvPr>
@@ -859,7 +860,7 @@
           <a:bodyPr/>
           <a:lstStyle/>
           <a:p>
-            <a:fld id="{4BA8EA37-AF8A-4F4B-8A94-E78695846435}" type="datetimeFigureOut">
+            <a:fld id="{ED4BFDCA-C350-438F-96BC-278A18682A11}" type="datetimeFigureOut">
               <a:rPr lang="de-DE" smtClean="0"/>
               <a:t>08.10.2026</a:t>
             </a:fld>
@@ -872,7 +873,7 @@
           <p:cNvPr id="5" name="Fußzeilenplatzhalter 4">
             <a:extLst>
               <a:ext uri="{FF2B5EF4-FFF2-40B4-BE49-F238E27FC236}">
-                <a16:creationId xmlns:a16="http://schemas.microsoft.com/office/drawing/2014/main" id="{720B44DC-106D-396F-0C20-EDBB3DE60587}"/>
+                <a16:creationId xmlns:a16="http://schemas.microsoft.com/office/drawing/2014/main" id="{E8AFABC3-FAEA-5585-5426-12A7F4AB8F83}"/>
               </a:ext>
             </a:extLst>
           </p:cNvPr>
@@ -897,7 +898,7 @@
           <p:cNvPr id="6" name="Foliennummernplatzhalter 5">
             <a:extLst>
               <a:ext uri="{FF2B5EF4-FFF2-40B4-BE49-F238E27FC236}">
-                <a16:creationId xmlns:a16="http://schemas.microsoft.com/office/drawing/2014/main" id="{78E6AC47-0301-F3D0-4250-61A82371F43D}"/>
+                <a16:creationId xmlns:a16="http://schemas.microsoft.com/office/drawing/2014/main" id="{AC0B6213-806D-9945-65D3-6B6664F68AAA}"/>
               </a:ext>
             </a:extLst>
           </p:cNvPr>
@@ -913,7 +914,7 @@
           <a:bodyPr/>
           <a:lstStyle/>
           <a:p>
-            <a:fld id="{709359BE-745B-4215-9DBF-4AAEB7BEE5E4}" type="slidenum">
+            <a:fld id="{3323FF0A-FBC4-4B75-81F2-FAECE708117C}" type="slidenum">
               <a:rPr lang="de-DE" smtClean="0"/>
               <a:t>‹Nr.›</a:t>
             </a:fld>
@@ -924,7 +925,7 @@
     </p:spTree>
     <p:extLst>
       <p:ext uri="{BB962C8B-B14F-4D97-AF65-F5344CB8AC3E}">
-        <p14:creationId xmlns:p14="http://schemas.microsoft.com/office/powerpoint/2010/main" val="3032762017"/>
+        <p14:creationId xmlns:p14="http://schemas.microsoft.com/office/powerpoint/2010/main" val="1804507638"/>
       </p:ext>
     </p:extLst>
   </p:cSld>
@@ -956,7 +957,7 @@
           <p:cNvPr id="2" name="Titel 1">
             <a:extLst>
               <a:ext uri="{FF2B5EF4-FFF2-40B4-BE49-F238E27FC236}">
-                <a16:creationId xmlns:a16="http://schemas.microsoft.com/office/drawing/2014/main" id="{CF078D0A-A80A-821D-81C1-497C85DACCDD}"/>
+                <a16:creationId xmlns:a16="http://schemas.microsoft.com/office/drawing/2014/main" id="{6D22C7C6-460D-A056-C865-B47C3C099619}"/>
               </a:ext>
             </a:extLst>
           </p:cNvPr>
@@ -993,7 +994,7 @@
           <p:cNvPr id="3" name="Textplatzhalter 2">
             <a:extLst>
               <a:ext uri="{FF2B5EF4-FFF2-40B4-BE49-F238E27FC236}">
-                <a16:creationId xmlns:a16="http://schemas.microsoft.com/office/drawing/2014/main" id="{6579C6B3-9121-EA7F-4B6F-F86C28AF64C0}"/>
+                <a16:creationId xmlns:a16="http://schemas.microsoft.com/office/drawing/2014/main" id="{E092F449-A221-259C-E29B-2E2E3F31DF7A}"/>
               </a:ext>
             </a:extLst>
           </p:cNvPr>
@@ -1118,7 +1119,7 @@
           <p:cNvPr id="4" name="Datumsplatzhalter 3">
             <a:extLst>
               <a:ext uri="{FF2B5EF4-FFF2-40B4-BE49-F238E27FC236}">
-                <a16:creationId xmlns:a16="http://schemas.microsoft.com/office/drawing/2014/main" id="{905A4BE0-F956-5AEC-DF51-7935B58C1347}"/>
+                <a16:creationId xmlns:a16="http://schemas.microsoft.com/office/drawing/2014/main" id="{E84EC874-301F-EA9E-73E9-C2E36C1672F2}"/>
               </a:ext>
             </a:extLst>
           </p:cNvPr>
@@ -1134,7 +1135,7 @@
           <a:bodyPr/>
           <a:lstStyle/>
           <a:p>
-            <a:fld id="{4BA8EA37-AF8A-4F4B-8A94-E78695846435}" type="datetimeFigureOut">
+            <a:fld id="{ED4BFDCA-C350-438F-96BC-278A18682A11}" type="datetimeFigureOut">
               <a:rPr lang="de-DE" smtClean="0"/>
               <a:t>08.10.2026</a:t>
             </a:fld>
@@ -1147,7 +1148,7 @@
           <p:cNvPr id="5" name="Fußzeilenplatzhalter 4">
             <a:extLst>
               <a:ext uri="{FF2B5EF4-FFF2-40B4-BE49-F238E27FC236}">
-                <a16:creationId xmlns:a16="http://schemas.microsoft.com/office/drawing/2014/main" id="{BC1F89B0-3B3D-71F9-9DDE-033FF37039FF}"/>
+                <a16:creationId xmlns:a16="http://schemas.microsoft.com/office/drawing/2014/main" id="{F0DFBEA4-B032-B0D3-9A02-DF10E9705A8F}"/>
               </a:ext>
             </a:extLst>
           </p:cNvPr>
@@ -1172,7 +1173,7 @@
           <p:cNvPr id="6" name="Foliennummernplatzhalter 5">
             <a:extLst>
               <a:ext uri="{FF2B5EF4-FFF2-40B4-BE49-F238E27FC236}">
-                <a16:creationId xmlns:a16="http://schemas.microsoft.com/office/drawing/2014/main" id="{E356FEA9-C7D8-5463-F511-1FAAAD27310B}"/>
+                <a16:creationId xmlns:a16="http://schemas.microsoft.com/office/drawing/2014/main" id="{A14E67D6-A19E-2DE7-E541-D109C1C8D3E0}"/>
               </a:ext>
             </a:extLst>
           </p:cNvPr>
@@ -1188,7 +1189,7 @@
           <a:bodyPr/>
           <a:lstStyle/>
           <a:p>
-            <a:fld id="{709359BE-745B-4215-9DBF-4AAEB7BEE5E4}" type="slidenum">
+            <a:fld id="{3323FF0A-FBC4-4B75-81F2-FAECE708117C}" type="slidenum">
               <a:rPr lang="de-DE" smtClean="0"/>
               <a:t>‹Nr.›</a:t>
             </a:fld>
@@ -1199,7 +1200,7 @@
     </p:spTree>
     <p:extLst>
       <p:ext uri="{BB962C8B-B14F-4D97-AF65-F5344CB8AC3E}">
-        <p14:creationId xmlns:p14="http://schemas.microsoft.com/office/powerpoint/2010/main" val="2032499780"/>
+        <p14:creationId xmlns:p14="http://schemas.microsoft.com/office/powerpoint/2010/main" val="1404505217"/>
       </p:ext>
     </p:extLst>
   </p:cSld>
@@ -1231,7 +1232,7 @@
           <p:cNvPr id="2" name="Titel 1">
             <a:extLst>
               <a:ext uri="{FF2B5EF4-FFF2-40B4-BE49-F238E27FC236}">
-                <a16:creationId xmlns:a16="http://schemas.microsoft.com/office/drawing/2014/main" id="{9C96728B-D671-FAF4-50F0-B4410352AF7B}"/>
+                <a16:creationId xmlns:a16="http://schemas.microsoft.com/office/drawing/2014/main" id="{900E94D5-7056-AB9A-8736-55D1CAE25DFC}"/>
               </a:ext>
             </a:extLst>
           </p:cNvPr>
@@ -1259,7 +1260,7 @@
           <p:cNvPr id="3" name="Inhaltsplatzhalter 2">
             <a:extLst>
               <a:ext uri="{FF2B5EF4-FFF2-40B4-BE49-F238E27FC236}">
-                <a16:creationId xmlns:a16="http://schemas.microsoft.com/office/drawing/2014/main" id="{F0E9B86A-12E6-72AF-6C25-F6C3D8B81A59}"/>
+                <a16:creationId xmlns:a16="http://schemas.microsoft.com/office/drawing/2014/main" id="{603EC161-D93E-F37C-DAF9-F85D9B5D12DF}"/>
               </a:ext>
             </a:extLst>
           </p:cNvPr>
@@ -1321,7 +1322,7 @@
           <p:cNvPr id="4" name="Inhaltsplatzhalter 3">
             <a:extLst>
               <a:ext uri="{FF2B5EF4-FFF2-40B4-BE49-F238E27FC236}">
-                <a16:creationId xmlns:a16="http://schemas.microsoft.com/office/drawing/2014/main" id="{74A12E54-7643-6A95-B565-809E6D205214}"/>
+                <a16:creationId xmlns:a16="http://schemas.microsoft.com/office/drawing/2014/main" id="{BCFE12CC-8710-509B-B90E-98E0AC5461BA}"/>
               </a:ext>
             </a:extLst>
           </p:cNvPr>
@@ -1383,7 +1384,7 @@
           <p:cNvPr id="5" name="Datumsplatzhalter 4">
             <a:extLst>
               <a:ext uri="{FF2B5EF4-FFF2-40B4-BE49-F238E27FC236}">
-                <a16:creationId xmlns:a16="http://schemas.microsoft.com/office/drawing/2014/main" id="{C322F48A-9F30-1C94-3E88-15700ADD1AF8}"/>
+                <a16:creationId xmlns:a16="http://schemas.microsoft.com/office/drawing/2014/main" id="{1A9DD643-C134-08FE-DD0C-BA08B6E4D069}"/>
               </a:ext>
             </a:extLst>
           </p:cNvPr>
@@ -1399,7 +1400,7 @@
           <a:bodyPr/>
           <a:lstStyle/>
           <a:p>
-            <a:fld id="{4BA8EA37-AF8A-4F4B-8A94-E78695846435}" type="datetimeFigureOut">
+            <a:fld id="{ED4BFDCA-C350-438F-96BC-278A18682A11}" type="datetimeFigureOut">
               <a:rPr lang="de-DE" smtClean="0"/>
               <a:t>08.10.2026</a:t>
             </a:fld>
@@ -1412,7 +1413,7 @@
           <p:cNvPr id="6" name="Fußzeilenplatzhalter 5">
             <a:extLst>
               <a:ext uri="{FF2B5EF4-FFF2-40B4-BE49-F238E27FC236}">
-                <a16:creationId xmlns:a16="http://schemas.microsoft.com/office/drawing/2014/main" id="{876A78B7-87F9-95BD-F17A-8BBE889C8EFF}"/>
+                <a16:creationId xmlns:a16="http://schemas.microsoft.com/office/drawing/2014/main" id="{2EA94696-8857-58EB-8C1C-4E28016C5E51}"/>
               </a:ext>
             </a:extLst>
           </p:cNvPr>
@@ -1437,7 +1438,7 @@
           <p:cNvPr id="7" name="Foliennummernplatzhalter 6">
             <a:extLst>
               <a:ext uri="{FF2B5EF4-FFF2-40B4-BE49-F238E27FC236}">
-                <a16:creationId xmlns:a16="http://schemas.microsoft.com/office/drawing/2014/main" id="{CE833BBD-1BFB-E378-1540-99CD326193FF}"/>
+                <a16:creationId xmlns:a16="http://schemas.microsoft.com/office/drawing/2014/main" id="{F0D5CF7B-6A39-1F60-9681-536D84E3F065}"/>
               </a:ext>
             </a:extLst>
           </p:cNvPr>
@@ -1453,7 +1454,7 @@
           <a:bodyPr/>
           <a:lstStyle/>
           <a:p>
-            <a:fld id="{709359BE-745B-4215-9DBF-4AAEB7BEE5E4}" type="slidenum">
+            <a:fld id="{3323FF0A-FBC4-4B75-81F2-FAECE708117C}" type="slidenum">
               <a:rPr lang="de-DE" smtClean="0"/>
               <a:t>‹Nr.›</a:t>
             </a:fld>
@@ -1464,7 +1465,7 @@
     </p:spTree>
     <p:extLst>
       <p:ext uri="{BB962C8B-B14F-4D97-AF65-F5344CB8AC3E}">
-        <p14:creationId xmlns:p14="http://schemas.microsoft.com/office/powerpoint/2010/main" val="2564701143"/>
+        <p14:creationId xmlns:p14="http://schemas.microsoft.com/office/powerpoint/2010/main" val="1805573737"/>
       </p:ext>
     </p:extLst>
   </p:cSld>
@@ -1496,7 +1497,7 @@
           <p:cNvPr id="2" name="Titel 1">
             <a:extLst>
               <a:ext uri="{FF2B5EF4-FFF2-40B4-BE49-F238E27FC236}">
-                <a16:creationId xmlns:a16="http://schemas.microsoft.com/office/drawing/2014/main" id="{926B6628-684B-7943-4AC0-3FD6B18D7ADF}"/>
+                <a16:creationId xmlns:a16="http://schemas.microsoft.com/office/drawing/2014/main" id="{A3FFB93C-093F-3551-A0F7-0167C47C60E1}"/>
               </a:ext>
             </a:extLst>
           </p:cNvPr>
@@ -1529,7 +1530,7 @@
           <p:cNvPr id="3" name="Textplatzhalter 2">
             <a:extLst>
               <a:ext uri="{FF2B5EF4-FFF2-40B4-BE49-F238E27FC236}">
-                <a16:creationId xmlns:a16="http://schemas.microsoft.com/office/drawing/2014/main" id="{C0158839-9842-1958-BCF8-8ADAD8202D0E}"/>
+                <a16:creationId xmlns:a16="http://schemas.microsoft.com/office/drawing/2014/main" id="{E1447F1E-68B5-4C65-EC9C-55FBEEEC45DC}"/>
               </a:ext>
             </a:extLst>
           </p:cNvPr>
@@ -1600,7 +1601,7 @@
           <p:cNvPr id="4" name="Inhaltsplatzhalter 3">
             <a:extLst>
               <a:ext uri="{FF2B5EF4-FFF2-40B4-BE49-F238E27FC236}">
-                <a16:creationId xmlns:a16="http://schemas.microsoft.com/office/drawing/2014/main" id="{EC0EB048-364D-3391-12F8-16C420FB7650}"/>
+                <a16:creationId xmlns:a16="http://schemas.microsoft.com/office/drawing/2014/main" id="{183C0A5E-484D-68C9-A961-247795FCA1B9}"/>
               </a:ext>
             </a:extLst>
           </p:cNvPr>
@@ -1662,7 +1663,7 @@
           <p:cNvPr id="5" name="Textplatzhalter 4">
             <a:extLst>
               <a:ext uri="{FF2B5EF4-FFF2-40B4-BE49-F238E27FC236}">
-                <a16:creationId xmlns:a16="http://schemas.microsoft.com/office/drawing/2014/main" id="{F5F9AD3F-BF12-8CC8-5730-54599B0A1442}"/>
+                <a16:creationId xmlns:a16="http://schemas.microsoft.com/office/drawing/2014/main" id="{F13C37A8-7F13-DD57-4E1D-4D104EEFCCAB}"/>
               </a:ext>
             </a:extLst>
           </p:cNvPr>
@@ -1733,7 +1734,7 @@
           <p:cNvPr id="6" name="Inhaltsplatzhalter 5">
             <a:extLst>
               <a:ext uri="{FF2B5EF4-FFF2-40B4-BE49-F238E27FC236}">
-                <a16:creationId xmlns:a16="http://schemas.microsoft.com/office/drawing/2014/main" id="{77643324-5C69-5902-D00A-B267FAD2ED8B}"/>
+                <a16:creationId xmlns:a16="http://schemas.microsoft.com/office/drawing/2014/main" id="{666F09B7-AFFA-3095-5C86-795CAE3FE8AE}"/>
               </a:ext>
             </a:extLst>
           </p:cNvPr>
@@ -1795,7 +1796,7 @@
           <p:cNvPr id="7" name="Datumsplatzhalter 6">
             <a:extLst>
               <a:ext uri="{FF2B5EF4-FFF2-40B4-BE49-F238E27FC236}">
-                <a16:creationId xmlns:a16="http://schemas.microsoft.com/office/drawing/2014/main" id="{59E5A4CA-0B93-D67F-8388-43D3C8A21AE2}"/>
+                <a16:creationId xmlns:a16="http://schemas.microsoft.com/office/drawing/2014/main" id="{A9F7DDB1-1ED3-0386-C884-DC7357F19F56}"/>
               </a:ext>
             </a:extLst>
           </p:cNvPr>
@@ -1811,7 +1812,7 @@
           <a:bodyPr/>
           <a:lstStyle/>
           <a:p>
-            <a:fld id="{4BA8EA37-AF8A-4F4B-8A94-E78695846435}" type="datetimeFigureOut">
+            <a:fld id="{ED4BFDCA-C350-438F-96BC-278A18682A11}" type="datetimeFigureOut">
               <a:rPr lang="de-DE" smtClean="0"/>
               <a:t>08.10.2026</a:t>
             </a:fld>
@@ -1824,7 +1825,7 @@
           <p:cNvPr id="8" name="Fußzeilenplatzhalter 7">
             <a:extLst>
               <a:ext uri="{FF2B5EF4-FFF2-40B4-BE49-F238E27FC236}">
-                <a16:creationId xmlns:a16="http://schemas.microsoft.com/office/drawing/2014/main" id="{DA4EAEFB-11B3-473A-4B4B-B350098DD68F}"/>
+                <a16:creationId xmlns:a16="http://schemas.microsoft.com/office/drawing/2014/main" id="{7D1FA0EB-1547-0D84-FB27-1346141527C7}"/>
               </a:ext>
             </a:extLst>
           </p:cNvPr>
@@ -1849,7 +1850,7 @@
           <p:cNvPr id="9" name="Foliennummernplatzhalter 8">
             <a:extLst>
               <a:ext uri="{FF2B5EF4-FFF2-40B4-BE49-F238E27FC236}">
-                <a16:creationId xmlns:a16="http://schemas.microsoft.com/office/drawing/2014/main" id="{32E5F4EC-6715-41A8-84FD-1481ED1781B2}"/>
+                <a16:creationId xmlns:a16="http://schemas.microsoft.com/office/drawing/2014/main" id="{B92B4F96-166B-600E-49BE-8E7DFC56822F}"/>
               </a:ext>
             </a:extLst>
           </p:cNvPr>
@@ -1865,7 +1866,7 @@
           <a:bodyPr/>
           <a:lstStyle/>
           <a:p>
-            <a:fld id="{709359BE-745B-4215-9DBF-4AAEB7BEE5E4}" type="slidenum">
+            <a:fld id="{3323FF0A-FBC4-4B75-81F2-FAECE708117C}" type="slidenum">
               <a:rPr lang="de-DE" smtClean="0"/>
               <a:t>‹Nr.›</a:t>
             </a:fld>
@@ -1876,7 +1877,7 @@
     </p:spTree>
     <p:extLst>
       <p:ext uri="{BB962C8B-B14F-4D97-AF65-F5344CB8AC3E}">
-        <p14:creationId xmlns:p14="http://schemas.microsoft.com/office/powerpoint/2010/main" val="1362709517"/>
+        <p14:creationId xmlns:p14="http://schemas.microsoft.com/office/powerpoint/2010/main" val="2798859071"/>
       </p:ext>
     </p:extLst>
   </p:cSld>
@@ -1908,7 +1909,7 @@
           <p:cNvPr id="2" name="Titel 1">
             <a:extLst>
               <a:ext uri="{FF2B5EF4-FFF2-40B4-BE49-F238E27FC236}">
-                <a16:creationId xmlns:a16="http://schemas.microsoft.com/office/drawing/2014/main" id="{1449846A-B924-523C-57E6-7731CA938A0E}"/>
+                <a16:creationId xmlns:a16="http://schemas.microsoft.com/office/drawing/2014/main" id="{6DE3990F-97E4-0235-840F-56782EEEA9F0}"/>
               </a:ext>
             </a:extLst>
           </p:cNvPr>
@@ -1936,7 +1937,7 @@
           <p:cNvPr id="3" name="Datumsplatzhalter 2">
             <a:extLst>
               <a:ext uri="{FF2B5EF4-FFF2-40B4-BE49-F238E27FC236}">
-                <a16:creationId xmlns:a16="http://schemas.microsoft.com/office/drawing/2014/main" id="{E96180C2-0109-BE1C-E5D4-34523547FA13}"/>
+                <a16:creationId xmlns:a16="http://schemas.microsoft.com/office/drawing/2014/main" id="{69E85CAF-EA3D-4B8A-4F38-B410BD7DC1B2}"/>
               </a:ext>
             </a:extLst>
           </p:cNvPr>
@@ -1952,7 +1953,7 @@
           <a:bodyPr/>
           <a:lstStyle/>
           <a:p>
-            <a:fld id="{4BA8EA37-AF8A-4F4B-8A94-E78695846435}" type="datetimeFigureOut">
+            <a:fld id="{ED4BFDCA-C350-438F-96BC-278A18682A11}" type="datetimeFigureOut">
               <a:rPr lang="de-DE" smtClean="0"/>
               <a:t>08.10.2026</a:t>
             </a:fld>
@@ -1965,7 +1966,7 @@
           <p:cNvPr id="4" name="Fußzeilenplatzhalter 3">
             <a:extLst>
               <a:ext uri="{FF2B5EF4-FFF2-40B4-BE49-F238E27FC236}">
-                <a16:creationId xmlns:a16="http://schemas.microsoft.com/office/drawing/2014/main" id="{DD0DFCF8-CB63-2FBD-C2E8-E59D749E6581}"/>
+                <a16:creationId xmlns:a16="http://schemas.microsoft.com/office/drawing/2014/main" id="{4B80422F-5C9F-CF3B-14F9-D7425D5BEF37}"/>
               </a:ext>
             </a:extLst>
           </p:cNvPr>
@@ -1990,7 +1991,7 @@
           <p:cNvPr id="5" name="Foliennummernplatzhalter 4">
             <a:extLst>
               <a:ext uri="{FF2B5EF4-FFF2-40B4-BE49-F238E27FC236}">
-                <a16:creationId xmlns:a16="http://schemas.microsoft.com/office/drawing/2014/main" id="{A8E2DD1D-4D37-7699-53DA-3FDF584CE5BD}"/>
+                <a16:creationId xmlns:a16="http://schemas.microsoft.com/office/drawing/2014/main" id="{11DA0311-9F11-869E-B4B8-C986DC90B887}"/>
               </a:ext>
             </a:extLst>
           </p:cNvPr>
@@ -2006,7 +2007,7 @@
           <a:bodyPr/>
           <a:lstStyle/>
           <a:p>
-            <a:fld id="{709359BE-745B-4215-9DBF-4AAEB7BEE5E4}" type="slidenum">
+            <a:fld id="{3323FF0A-FBC4-4B75-81F2-FAECE708117C}" type="slidenum">
               <a:rPr lang="de-DE" smtClean="0"/>
               <a:t>‹Nr.›</a:t>
             </a:fld>
@@ -2017,7 +2018,7 @@
     </p:spTree>
     <p:extLst>
       <p:ext uri="{BB962C8B-B14F-4D97-AF65-F5344CB8AC3E}">
-        <p14:creationId xmlns:p14="http://schemas.microsoft.com/office/powerpoint/2010/main" val="1872321780"/>
+        <p14:creationId xmlns:p14="http://schemas.microsoft.com/office/powerpoint/2010/main" val="2328846925"/>
       </p:ext>
     </p:extLst>
   </p:cSld>
@@ -2049,7 +2050,7 @@
           <p:cNvPr id="2" name="Datumsplatzhalter 1">
             <a:extLst>
               <a:ext uri="{FF2B5EF4-FFF2-40B4-BE49-F238E27FC236}">
-                <a16:creationId xmlns:a16="http://schemas.microsoft.com/office/drawing/2014/main" id="{FCFCAE41-893F-D198-6255-C2FBFAE74B4D}"/>
+                <a16:creationId xmlns:a16="http://schemas.microsoft.com/office/drawing/2014/main" id="{C6C65A23-727C-0E0B-CBC7-74436FE7495D}"/>
               </a:ext>
             </a:extLst>
           </p:cNvPr>
@@ -2065,7 +2066,7 @@
           <a:bodyPr/>
           <a:lstStyle/>
           <a:p>
-            <a:fld id="{4BA8EA37-AF8A-4F4B-8A94-E78695846435}" type="datetimeFigureOut">
+            <a:fld id="{ED4BFDCA-C350-438F-96BC-278A18682A11}" type="datetimeFigureOut">
               <a:rPr lang="de-DE" smtClean="0"/>
               <a:t>08.10.2026</a:t>
             </a:fld>
@@ -2078,7 +2079,7 @@
           <p:cNvPr id="3" name="Fußzeilenplatzhalter 2">
             <a:extLst>
               <a:ext uri="{FF2B5EF4-FFF2-40B4-BE49-F238E27FC236}">
-                <a16:creationId xmlns:a16="http://schemas.microsoft.com/office/drawing/2014/main" id="{4609DD15-C35A-6544-234C-39D9F821F953}"/>
+                <a16:creationId xmlns:a16="http://schemas.microsoft.com/office/drawing/2014/main" id="{3535308E-485C-5A7A-1145-D20E3CDFD5D2}"/>
               </a:ext>
             </a:extLst>
           </p:cNvPr>
@@ -2103,7 +2104,7 @@
           <p:cNvPr id="4" name="Foliennummernplatzhalter 3">
             <a:extLst>
               <a:ext uri="{FF2B5EF4-FFF2-40B4-BE49-F238E27FC236}">
-                <a16:creationId xmlns:a16="http://schemas.microsoft.com/office/drawing/2014/main" id="{7DA8D15F-1FF8-477E-B64A-0FED7920825A}"/>
+                <a16:creationId xmlns:a16="http://schemas.microsoft.com/office/drawing/2014/main" id="{BBA402A3-16B3-451C-454B-C878E58AA38C}"/>
               </a:ext>
             </a:extLst>
           </p:cNvPr>
@@ -2119,7 +2120,7 @@
           <a:bodyPr/>
           <a:lstStyle/>
           <a:p>
-            <a:fld id="{709359BE-745B-4215-9DBF-4AAEB7BEE5E4}" type="slidenum">
+            <a:fld id="{3323FF0A-FBC4-4B75-81F2-FAECE708117C}" type="slidenum">
               <a:rPr lang="de-DE" smtClean="0"/>
               <a:t>‹Nr.›</a:t>
             </a:fld>
@@ -2130,7 +2131,7 @@
     </p:spTree>
     <p:extLst>
       <p:ext uri="{BB962C8B-B14F-4D97-AF65-F5344CB8AC3E}">
-        <p14:creationId xmlns:p14="http://schemas.microsoft.com/office/powerpoint/2010/main" val="2683444479"/>
+        <p14:creationId xmlns:p14="http://schemas.microsoft.com/office/powerpoint/2010/main" val="2636168213"/>
       </p:ext>
     </p:extLst>
   </p:cSld>
@@ -2162,7 +2163,7 @@
           <p:cNvPr id="2" name="Titel 1">
             <a:extLst>
               <a:ext uri="{FF2B5EF4-FFF2-40B4-BE49-F238E27FC236}">
-                <a16:creationId xmlns:a16="http://schemas.microsoft.com/office/drawing/2014/main" id="{4EB39287-4D1C-A850-63D4-7AAEB66B4419}"/>
+                <a16:creationId xmlns:a16="http://schemas.microsoft.com/office/drawing/2014/main" id="{D08A5904-CF2D-B82F-9B32-F855E7A74311}"/>
               </a:ext>
             </a:extLst>
           </p:cNvPr>
@@ -2199,7 +2200,7 @@
           <p:cNvPr id="3" name="Inhaltsplatzhalter 2">
             <a:extLst>
               <a:ext uri="{FF2B5EF4-FFF2-40B4-BE49-F238E27FC236}">
-                <a16:creationId xmlns:a16="http://schemas.microsoft.com/office/drawing/2014/main" id="{60D1521C-685F-D7DE-4895-ABE3EC89B686}"/>
+                <a16:creationId xmlns:a16="http://schemas.microsoft.com/office/drawing/2014/main" id="{5B05723C-566F-60F5-11F5-C8099A0B0029}"/>
               </a:ext>
             </a:extLst>
           </p:cNvPr>
@@ -2289,7 +2290,7 @@
           <p:cNvPr id="4" name="Textplatzhalter 3">
             <a:extLst>
               <a:ext uri="{FF2B5EF4-FFF2-40B4-BE49-F238E27FC236}">
-                <a16:creationId xmlns:a16="http://schemas.microsoft.com/office/drawing/2014/main" id="{081C9EE6-5C9F-FD3B-97EE-9CD6E4E8D312}"/>
+                <a16:creationId xmlns:a16="http://schemas.microsoft.com/office/drawing/2014/main" id="{EDD2B2D9-E333-C860-C969-292F5EA30C66}"/>
               </a:ext>
             </a:extLst>
           </p:cNvPr>
@@ -2360,7 +2361,7 @@
           <p:cNvPr id="5" name="Datumsplatzhalter 4">
             <a:extLst>
               <a:ext uri="{FF2B5EF4-FFF2-40B4-BE49-F238E27FC236}">
-                <a16:creationId xmlns:a16="http://schemas.microsoft.com/office/drawing/2014/main" id="{122E8E15-5732-D16F-BBB3-AFD5A391BDED}"/>
+                <a16:creationId xmlns:a16="http://schemas.microsoft.com/office/drawing/2014/main" id="{C5716925-BCC1-6711-A7BD-53FBC8AD1C1B}"/>
               </a:ext>
             </a:extLst>
           </p:cNvPr>
@@ -2376,7 +2377,7 @@
           <a:bodyPr/>
           <a:lstStyle/>
           <a:p>
-            <a:fld id="{4BA8EA37-AF8A-4F4B-8A94-E78695846435}" type="datetimeFigureOut">
+            <a:fld id="{ED4BFDCA-C350-438F-96BC-278A18682A11}" type="datetimeFigureOut">
               <a:rPr lang="de-DE" smtClean="0"/>
               <a:t>08.10.2026</a:t>
             </a:fld>
@@ -2389,7 +2390,7 @@
           <p:cNvPr id="6" name="Fußzeilenplatzhalter 5">
             <a:extLst>
               <a:ext uri="{FF2B5EF4-FFF2-40B4-BE49-F238E27FC236}">
-                <a16:creationId xmlns:a16="http://schemas.microsoft.com/office/drawing/2014/main" id="{340FF7E0-7123-46FA-4CC3-9120C92B62B7}"/>
+                <a16:creationId xmlns:a16="http://schemas.microsoft.com/office/drawing/2014/main" id="{B4A3063D-55E6-0F62-3C8B-D27563802E71}"/>
               </a:ext>
             </a:extLst>
           </p:cNvPr>
@@ -2414,7 +2415,7 @@
           <p:cNvPr id="7" name="Foliennummernplatzhalter 6">
             <a:extLst>
               <a:ext uri="{FF2B5EF4-FFF2-40B4-BE49-F238E27FC236}">
-                <a16:creationId xmlns:a16="http://schemas.microsoft.com/office/drawing/2014/main" id="{F250A4DE-9554-F3BE-A6E4-DCC9B2000F8D}"/>
+                <a16:creationId xmlns:a16="http://schemas.microsoft.com/office/drawing/2014/main" id="{D077D9DA-6641-C935-F5F8-D1F9A4C6F81C}"/>
               </a:ext>
             </a:extLst>
           </p:cNvPr>
@@ -2430,7 +2431,7 @@
           <a:bodyPr/>
           <a:lstStyle/>
           <a:p>
-            <a:fld id="{709359BE-745B-4215-9DBF-4AAEB7BEE5E4}" type="slidenum">
+            <a:fld id="{3323FF0A-FBC4-4B75-81F2-FAECE708117C}" type="slidenum">
               <a:rPr lang="de-DE" smtClean="0"/>
               <a:t>‹Nr.›</a:t>
             </a:fld>
@@ -2441,7 +2442,7 @@
     </p:spTree>
     <p:extLst>
       <p:ext uri="{BB962C8B-B14F-4D97-AF65-F5344CB8AC3E}">
-        <p14:creationId xmlns:p14="http://schemas.microsoft.com/office/powerpoint/2010/main" val="2801882130"/>
+        <p14:creationId xmlns:p14="http://schemas.microsoft.com/office/powerpoint/2010/main" val="186418774"/>
       </p:ext>
     </p:extLst>
   </p:cSld>
@@ -2473,7 +2474,7 @@
           <p:cNvPr id="2" name="Titel 1">
             <a:extLst>
               <a:ext uri="{FF2B5EF4-FFF2-40B4-BE49-F238E27FC236}">
-                <a16:creationId xmlns:a16="http://schemas.microsoft.com/office/drawing/2014/main" id="{28B77140-73CF-679C-DA97-9617D210D3C9}"/>
+                <a16:creationId xmlns:a16="http://schemas.microsoft.com/office/drawing/2014/main" id="{B0CCC9A7-6DD5-3D8E-B4B6-F5551635DE6F}"/>
               </a:ext>
             </a:extLst>
           </p:cNvPr>
@@ -2510,7 +2511,7 @@
           <p:cNvPr id="3" name="Bildplatzhalter 2">
             <a:extLst>
               <a:ext uri="{FF2B5EF4-FFF2-40B4-BE49-F238E27FC236}">
-                <a16:creationId xmlns:a16="http://schemas.microsoft.com/office/drawing/2014/main" id="{092D4932-AB5A-EDE4-217F-CD8124F02669}"/>
+                <a16:creationId xmlns:a16="http://schemas.microsoft.com/office/drawing/2014/main" id="{DB4297C7-5915-6315-35AB-6C5E20A0F614}"/>
               </a:ext>
             </a:extLst>
           </p:cNvPr>
@@ -2577,7 +2578,7 @@
           <p:cNvPr id="4" name="Textplatzhalter 3">
             <a:extLst>
               <a:ext uri="{FF2B5EF4-FFF2-40B4-BE49-F238E27FC236}">
-                <a16:creationId xmlns:a16="http://schemas.microsoft.com/office/drawing/2014/main" id="{F4035BA4-2BD0-1323-9789-1ED08B61B478}"/>
+                <a16:creationId xmlns:a16="http://schemas.microsoft.com/office/drawing/2014/main" id="{BBFF91BF-2A3B-FF30-4CD1-ED68D830C3D8}"/>
               </a:ext>
             </a:extLst>
           </p:cNvPr>
@@ -2648,7 +2649,7 @@
           <p:cNvPr id="5" name="Datumsplatzhalter 4">
             <a:extLst>
               <a:ext uri="{FF2B5EF4-FFF2-40B4-BE49-F238E27FC236}">
-                <a16:creationId xmlns:a16="http://schemas.microsoft.com/office/drawing/2014/main" id="{E59A0616-9634-9E18-5109-5A75782E5CBA}"/>
+                <a16:creationId xmlns:a16="http://schemas.microsoft.com/office/drawing/2014/main" id="{FB0E3395-0E8B-1D77-D8EF-9AC0CD3DB1BD}"/>
               </a:ext>
             </a:extLst>
           </p:cNvPr>
@@ -2664,7 +2665,7 @@
           <a:bodyPr/>
           <a:lstStyle/>
           <a:p>
-            <a:fld id="{4BA8EA37-AF8A-4F4B-8A94-E78695846435}" type="datetimeFigureOut">
+            <a:fld id="{ED4BFDCA-C350-438F-96BC-278A18682A11}" type="datetimeFigureOut">
               <a:rPr lang="de-DE" smtClean="0"/>
               <a:t>08.10.2026</a:t>
             </a:fld>
@@ -2677,7 +2678,7 @@
           <p:cNvPr id="6" name="Fußzeilenplatzhalter 5">
             <a:extLst>
               <a:ext uri="{FF2B5EF4-FFF2-40B4-BE49-F238E27FC236}">
-                <a16:creationId xmlns:a16="http://schemas.microsoft.com/office/drawing/2014/main" id="{D7B4F9F3-E5CE-277D-BD2C-41FEA9CB50E2}"/>
+                <a16:creationId xmlns:a16="http://schemas.microsoft.com/office/drawing/2014/main" id="{242C0212-30D6-01A4-CCCB-F57F4EA55969}"/>
               </a:ext>
             </a:extLst>
           </p:cNvPr>
@@ -2702,7 +2703,7 @@
           <p:cNvPr id="7" name="Foliennummernplatzhalter 6">
             <a:extLst>
               <a:ext uri="{FF2B5EF4-FFF2-40B4-BE49-F238E27FC236}">
-                <a16:creationId xmlns:a16="http://schemas.microsoft.com/office/drawing/2014/main" id="{36B87C86-83A7-423D-7780-32B90ED10F0B}"/>
+                <a16:creationId xmlns:a16="http://schemas.microsoft.com/office/drawing/2014/main" id="{9AB24A12-BACC-5A94-A898-0ACCCA6AF19D}"/>
               </a:ext>
             </a:extLst>
           </p:cNvPr>
@@ -2718,7 +2719,7 @@
           <a:bodyPr/>
           <a:lstStyle/>
           <a:p>
-            <a:fld id="{709359BE-745B-4215-9DBF-4AAEB7BEE5E4}" type="slidenum">
+            <a:fld id="{3323FF0A-FBC4-4B75-81F2-FAECE708117C}" type="slidenum">
               <a:rPr lang="de-DE" smtClean="0"/>
               <a:t>‹Nr.›</a:t>
             </a:fld>
@@ -2729,7 +2730,7 @@
     </p:spTree>
     <p:extLst>
       <p:ext uri="{BB962C8B-B14F-4D97-AF65-F5344CB8AC3E}">
-        <p14:creationId xmlns:p14="http://schemas.microsoft.com/office/powerpoint/2010/main" val="2705939582"/>
+        <p14:creationId xmlns:p14="http://schemas.microsoft.com/office/powerpoint/2010/main" val="2204047866"/>
       </p:ext>
     </p:extLst>
   </p:cSld>
@@ -2766,7 +2767,7 @@
           <p:cNvPr id="2" name="Titelplatzhalter 1">
             <a:extLst>
               <a:ext uri="{FF2B5EF4-FFF2-40B4-BE49-F238E27FC236}">
-                <a16:creationId xmlns:a16="http://schemas.microsoft.com/office/drawing/2014/main" id="{53A54D83-C0AE-1F8C-2251-E5E500149ABF}"/>
+                <a16:creationId xmlns:a16="http://schemas.microsoft.com/office/drawing/2014/main" id="{88B8DF61-3161-AB77-8D48-18DC1868F80D}"/>
               </a:ext>
             </a:extLst>
           </p:cNvPr>
@@ -2804,7 +2805,7 @@
           <p:cNvPr id="3" name="Textplatzhalter 2">
             <a:extLst>
               <a:ext uri="{FF2B5EF4-FFF2-40B4-BE49-F238E27FC236}">
-                <a16:creationId xmlns:a16="http://schemas.microsoft.com/office/drawing/2014/main" id="{CA98F083-4E64-F001-4216-9BC5B87C86F9}"/>
+                <a16:creationId xmlns:a16="http://schemas.microsoft.com/office/drawing/2014/main" id="{7AAD0A00-76FD-BE2B-77F8-CC92CDCD3F48}"/>
               </a:ext>
             </a:extLst>
           </p:cNvPr>
@@ -2871,7 +2872,7 @@
           <p:cNvPr id="4" name="Datumsplatzhalter 3">
             <a:extLst>
               <a:ext uri="{FF2B5EF4-FFF2-40B4-BE49-F238E27FC236}">
-                <a16:creationId xmlns:a16="http://schemas.microsoft.com/office/drawing/2014/main" id="{BDE94619-B656-16ED-DFC6-7A5EDBFC2F05}"/>
+                <a16:creationId xmlns:a16="http://schemas.microsoft.com/office/drawing/2014/main" id="{81DC8F33-01E0-AA05-FFE1-A8F621E8282C}"/>
               </a:ext>
             </a:extLst>
           </p:cNvPr>
@@ -2905,7 +2906,7 @@
             </a:lvl1pPr>
           </a:lstStyle>
           <a:p>
-            <a:fld id="{4BA8EA37-AF8A-4F4B-8A94-E78695846435}" type="datetimeFigureOut">
+            <a:fld id="{ED4BFDCA-C350-438F-96BC-278A18682A11}" type="datetimeFigureOut">
               <a:rPr lang="de-DE" smtClean="0"/>
               <a:t>08.10.2026</a:t>
             </a:fld>
@@ -2918,7 +2919,7 @@
           <p:cNvPr id="5" name="Fußzeilenplatzhalter 4">
             <a:extLst>
               <a:ext uri="{FF2B5EF4-FFF2-40B4-BE49-F238E27FC236}">
-                <a16:creationId xmlns:a16="http://schemas.microsoft.com/office/drawing/2014/main" id="{DCBEFC8E-A872-879C-575E-0A0F49E61C82}"/>
+                <a16:creationId xmlns:a16="http://schemas.microsoft.com/office/drawing/2014/main" id="{23F33BBB-A2C4-760E-155D-F74C793B9CB1}"/>
               </a:ext>
             </a:extLst>
           </p:cNvPr>
@@ -2961,7 +2962,7 @@
           <p:cNvPr id="6" name="Foliennummernplatzhalter 5">
             <a:extLst>
               <a:ext uri="{FF2B5EF4-FFF2-40B4-BE49-F238E27FC236}">
-                <a16:creationId xmlns:a16="http://schemas.microsoft.com/office/drawing/2014/main" id="{890338D2-C159-E9ED-B210-2D7333F14D44}"/>
+                <a16:creationId xmlns:a16="http://schemas.microsoft.com/office/drawing/2014/main" id="{1430E3CC-E293-CADF-A5C2-C1C063E354D2}"/>
               </a:ext>
             </a:extLst>
           </p:cNvPr>
@@ -2995,7 +2996,7 @@
             </a:lvl1pPr>
           </a:lstStyle>
           <a:p>
-            <a:fld id="{709359BE-745B-4215-9DBF-4AAEB7BEE5E4}" type="slidenum">
+            <a:fld id="{3323FF0A-FBC4-4B75-81F2-FAECE708117C}" type="slidenum">
               <a:rPr lang="de-DE" smtClean="0"/>
               <a:t>‹Nr.›</a:t>
             </a:fld>
@@ -3006,7 +3007,7 @@
     </p:spTree>
     <p:extLst>
       <p:ext uri="{BB962C8B-B14F-4D97-AF65-F5344CB8AC3E}">
-        <p14:creationId xmlns:p14="http://schemas.microsoft.com/office/powerpoint/2010/main" val="55217914"/>
+        <p14:creationId xmlns:p14="http://schemas.microsoft.com/office/powerpoint/2010/main" val="1386767838"/>
       </p:ext>
     </p:extLst>
   </p:cSld>
@@ -3329,7 +3330,7 @@
           <p:cNvPr id="2" name="Textfeld 1">
             <a:extLst>
               <a:ext uri="{FF2B5EF4-FFF2-40B4-BE49-F238E27FC236}">
-                <a16:creationId xmlns:a16="http://schemas.microsoft.com/office/drawing/2014/main" id="{4AB3B349-D046-D75E-7B26-206C37DE9CE4}"/>
+                <a16:creationId xmlns:a16="http://schemas.microsoft.com/office/drawing/2014/main" id="{3BC812DF-CB40-D6EA-15A5-A096FBB58973}"/>
               </a:ext>
             </a:extLst>
           </p:cNvPr>
@@ -3369,7 +3370,7 @@
           <p:cNvPr id="3" name="Textfeld 2">
             <a:extLst>
               <a:ext uri="{FF2B5EF4-FFF2-40B4-BE49-F238E27FC236}">
-                <a16:creationId xmlns:a16="http://schemas.microsoft.com/office/drawing/2014/main" id="{D5D41E8B-467F-7236-0C69-C4DBE7DC6DAD}"/>
+                <a16:creationId xmlns:a16="http://schemas.microsoft.com/office/drawing/2014/main" id="{2D6332E2-B1A7-341B-BB27-34E48F8964C6}"/>
               </a:ext>
             </a:extLst>
           </p:cNvPr>
@@ -3409,7 +3410,7 @@
           <p:cNvPr id="4" name="Textfeld 3">
             <a:extLst>
               <a:ext uri="{FF2B5EF4-FFF2-40B4-BE49-F238E27FC236}">
-                <a16:creationId xmlns:a16="http://schemas.microsoft.com/office/drawing/2014/main" id="{942F61C0-5422-7F65-0431-3937EE64C221}"/>
+                <a16:creationId xmlns:a16="http://schemas.microsoft.com/office/drawing/2014/main" id="{AFA94B58-D66F-3E59-B2E8-5E002165371E}"/>
               </a:ext>
             </a:extLst>
           </p:cNvPr>
@@ -3449,7 +3450,7 @@
           <p:cNvPr id="5" name="Textfeld 4">
             <a:extLst>
               <a:ext uri="{FF2B5EF4-FFF2-40B4-BE49-F238E27FC236}">
-                <a16:creationId xmlns:a16="http://schemas.microsoft.com/office/drawing/2014/main" id="{E04C9648-47AF-3544-861D-775ED2BD3ED2}"/>
+                <a16:creationId xmlns:a16="http://schemas.microsoft.com/office/drawing/2014/main" id="{B0A29B3F-A163-DCFB-7AAF-E831DD7B77CE}"/>
               </a:ext>
             </a:extLst>
           </p:cNvPr>
@@ -3489,7 +3490,7 @@
           <p:cNvPr id="6" name="Textfeld 5">
             <a:extLst>
               <a:ext uri="{FF2B5EF4-FFF2-40B4-BE49-F238E27FC236}">
-                <a16:creationId xmlns:a16="http://schemas.microsoft.com/office/drawing/2014/main" id="{94C4BB4D-8C80-6682-081F-D4141C58FE07}"/>
+                <a16:creationId xmlns:a16="http://schemas.microsoft.com/office/drawing/2014/main" id="{7011C715-E0EC-987E-F876-9E8CB2F33D5E}"/>
               </a:ext>
             </a:extLst>
           </p:cNvPr>
@@ -3529,7 +3530,7 @@
           <p:cNvPr id="7" name="Textfeld 6">
             <a:extLst>
               <a:ext uri="{FF2B5EF4-FFF2-40B4-BE49-F238E27FC236}">
-                <a16:creationId xmlns:a16="http://schemas.microsoft.com/office/drawing/2014/main" id="{F0BBE5A0-9571-B690-984F-BDD23D2BA2F8}"/>
+                <a16:creationId xmlns:a16="http://schemas.microsoft.com/office/drawing/2014/main" id="{82163F79-545D-0FFA-97C9-4E1477251249}"/>
               </a:ext>
             </a:extLst>
           </p:cNvPr>
@@ -3569,7 +3570,7 @@
           <p:cNvPr id="8" name="Textfeld 7">
             <a:extLst>
               <a:ext uri="{FF2B5EF4-FFF2-40B4-BE49-F238E27FC236}">
-                <a16:creationId xmlns:a16="http://schemas.microsoft.com/office/drawing/2014/main" id="{513C7CA7-E4C5-E863-9087-0AD45635DEF1}"/>
+                <a16:creationId xmlns:a16="http://schemas.microsoft.com/office/drawing/2014/main" id="{653958E1-9993-F09C-2A83-3B5D6737B75E}"/>
               </a:ext>
             </a:extLst>
           </p:cNvPr>
@@ -3609,7 +3610,7 @@
           <p:cNvPr id="9" name="Textfeld 8">
             <a:extLst>
               <a:ext uri="{FF2B5EF4-FFF2-40B4-BE49-F238E27FC236}">
-                <a16:creationId xmlns:a16="http://schemas.microsoft.com/office/drawing/2014/main" id="{8429FC98-D612-376A-9B2F-79D49867E77E}"/>
+                <a16:creationId xmlns:a16="http://schemas.microsoft.com/office/drawing/2014/main" id="{7BFA602B-A5E3-8679-DDE1-697C0A465113}"/>
               </a:ext>
             </a:extLst>
           </p:cNvPr>
@@ -3649,7 +3650,7 @@
           <p:cNvPr id="10" name="Textfeld 9">
             <a:extLst>
               <a:ext uri="{FF2B5EF4-FFF2-40B4-BE49-F238E27FC236}">
-                <a16:creationId xmlns:a16="http://schemas.microsoft.com/office/drawing/2014/main" id="{555FAA45-3092-295B-CA0A-0A670C52981C}"/>
+                <a16:creationId xmlns:a16="http://schemas.microsoft.com/office/drawing/2014/main" id="{501AA4E8-C0D9-5A93-2EDE-CC93088B9A9B}"/>
               </a:ext>
             </a:extLst>
           </p:cNvPr>
@@ -3689,7 +3690,7 @@
           <p:cNvPr id="11" name="Textfeld 10">
             <a:extLst>
               <a:ext uri="{FF2B5EF4-FFF2-40B4-BE49-F238E27FC236}">
-                <a16:creationId xmlns:a16="http://schemas.microsoft.com/office/drawing/2014/main" id="{B4F0FD91-CF93-EEB5-8FEC-F1FA9B8BC58B}"/>
+                <a16:creationId xmlns:a16="http://schemas.microsoft.com/office/drawing/2014/main" id="{0DDC583F-C6E4-139D-2F10-0683AEC9932E}"/>
               </a:ext>
             </a:extLst>
           </p:cNvPr>
@@ -3729,7 +3730,7 @@
           <p:cNvPr id="12" name="Textfeld 11">
             <a:extLst>
               <a:ext uri="{FF2B5EF4-FFF2-40B4-BE49-F238E27FC236}">
-                <a16:creationId xmlns:a16="http://schemas.microsoft.com/office/drawing/2014/main" id="{B4553589-FAE5-CA5E-FA71-F321AA64309D}"/>
+                <a16:creationId xmlns:a16="http://schemas.microsoft.com/office/drawing/2014/main" id="{8414CDDB-4CD7-279A-A078-63493761D7D1}"/>
               </a:ext>
             </a:extLst>
           </p:cNvPr>
@@ -3769,7 +3770,7 @@
           <p:cNvPr id="13" name="Textfeld 12">
             <a:extLst>
               <a:ext uri="{FF2B5EF4-FFF2-40B4-BE49-F238E27FC236}">
-                <a16:creationId xmlns:a16="http://schemas.microsoft.com/office/drawing/2014/main" id="{3628A5A4-FFC2-61FC-CE92-E81EFC8A310C}"/>
+                <a16:creationId xmlns:a16="http://schemas.microsoft.com/office/drawing/2014/main" id="{FC30D99E-6CB7-DC75-6DD6-C41B82601DF2}"/>
               </a:ext>
             </a:extLst>
           </p:cNvPr>
@@ -3809,7 +3810,7 @@
           <p:cNvPr id="14" name="Textfeld 13">
             <a:extLst>
               <a:ext uri="{FF2B5EF4-FFF2-40B4-BE49-F238E27FC236}">
-                <a16:creationId xmlns:a16="http://schemas.microsoft.com/office/drawing/2014/main" id="{5D11A45C-8E00-21CD-E7B7-E0C686BA1207}"/>
+                <a16:creationId xmlns:a16="http://schemas.microsoft.com/office/drawing/2014/main" id="{B0DFC5C8-A1CD-81B5-9A78-12E7429D5608}"/>
               </a:ext>
             </a:extLst>
           </p:cNvPr>
@@ -3849,7 +3850,7 @@
           <p:cNvPr id="15" name="Textfeld 14">
             <a:extLst>
               <a:ext uri="{FF2B5EF4-FFF2-40B4-BE49-F238E27FC236}">
-                <a16:creationId xmlns:a16="http://schemas.microsoft.com/office/drawing/2014/main" id="{3DAE5DE7-0390-D121-6AF3-18819B08106E}"/>
+                <a16:creationId xmlns:a16="http://schemas.microsoft.com/office/drawing/2014/main" id="{46A2CA89-3330-8BE0-8A32-8E22C698CC02}"/>
               </a:ext>
             </a:extLst>
           </p:cNvPr>
@@ -3889,7 +3890,7 @@
           <p:cNvPr id="16" name="Textfeld 15">
             <a:extLst>
               <a:ext uri="{FF2B5EF4-FFF2-40B4-BE49-F238E27FC236}">
-                <a16:creationId xmlns:a16="http://schemas.microsoft.com/office/drawing/2014/main" id="{31B902DA-D8D5-72A5-E7D5-38E6611170B6}"/>
+                <a16:creationId xmlns:a16="http://schemas.microsoft.com/office/drawing/2014/main" id="{84D1E949-CFFE-860B-F4DC-54CE84D74CB9}"/>
               </a:ext>
             </a:extLst>
           </p:cNvPr>
@@ -3929,7 +3930,7 @@
           <p:cNvPr id="17" name="Textfeld 16">
             <a:extLst>
               <a:ext uri="{FF2B5EF4-FFF2-40B4-BE49-F238E27FC236}">
-                <a16:creationId xmlns:a16="http://schemas.microsoft.com/office/drawing/2014/main" id="{224A2475-1657-E4EB-FAC5-D57DB13212FD}"/>
+                <a16:creationId xmlns:a16="http://schemas.microsoft.com/office/drawing/2014/main" id="{92BF4DDF-67F7-C0AC-1F29-5B1966C87325}"/>
               </a:ext>
             </a:extLst>
           </p:cNvPr>
@@ -3969,7 +3970,7 @@
           <p:cNvPr id="18" name="Textfeld 17">
             <a:extLst>
               <a:ext uri="{FF2B5EF4-FFF2-40B4-BE49-F238E27FC236}">
-                <a16:creationId xmlns:a16="http://schemas.microsoft.com/office/drawing/2014/main" id="{8CF2CE0B-70A4-C6D3-B9F4-C030887B5CB8}"/>
+                <a16:creationId xmlns:a16="http://schemas.microsoft.com/office/drawing/2014/main" id="{4BB7EC15-5942-13B8-C61E-04272DE72213}"/>
               </a:ext>
             </a:extLst>
           </p:cNvPr>
@@ -4009,7 +4010,7 @@
           <p:cNvPr id="19" name="Textfeld 18">
             <a:extLst>
               <a:ext uri="{FF2B5EF4-FFF2-40B4-BE49-F238E27FC236}">
-                <a16:creationId xmlns:a16="http://schemas.microsoft.com/office/drawing/2014/main" id="{7F294B96-1090-7C68-8E76-A22BE199DAFB}"/>
+                <a16:creationId xmlns:a16="http://schemas.microsoft.com/office/drawing/2014/main" id="{5DB41A5C-7889-2180-163E-4C8D8B4FA3B9}"/>
               </a:ext>
             </a:extLst>
           </p:cNvPr>
@@ -4049,7 +4050,7 @@
           <p:cNvPr id="20" name="Textfeld 19">
             <a:extLst>
               <a:ext uri="{FF2B5EF4-FFF2-40B4-BE49-F238E27FC236}">
-                <a16:creationId xmlns:a16="http://schemas.microsoft.com/office/drawing/2014/main" id="{EBE0F4C8-1545-6C4A-19F7-03109BF851FF}"/>
+                <a16:creationId xmlns:a16="http://schemas.microsoft.com/office/drawing/2014/main" id="{E5E15991-1523-2DF7-4FF2-0D63999F6AC4}"/>
               </a:ext>
             </a:extLst>
           </p:cNvPr>
@@ -4089,7 +4090,7 @@
           <p:cNvPr id="21" name="Textfeld 20">
             <a:extLst>
               <a:ext uri="{FF2B5EF4-FFF2-40B4-BE49-F238E27FC236}">
-                <a16:creationId xmlns:a16="http://schemas.microsoft.com/office/drawing/2014/main" id="{9DA4C69F-C57F-17AF-1CA6-F263CC8975DA}"/>
+                <a16:creationId xmlns:a16="http://schemas.microsoft.com/office/drawing/2014/main" id="{9C4530C5-9D92-8FE5-450B-BF77F91AE311}"/>
               </a:ext>
             </a:extLst>
           </p:cNvPr>
@@ -4129,7 +4130,7 @@
           <p:cNvPr id="22" name="Textfeld 21">
             <a:extLst>
               <a:ext uri="{FF2B5EF4-FFF2-40B4-BE49-F238E27FC236}">
-                <a16:creationId xmlns:a16="http://schemas.microsoft.com/office/drawing/2014/main" id="{1DE9C560-3DB0-9A65-A087-CD20F6D9E358}"/>
+                <a16:creationId xmlns:a16="http://schemas.microsoft.com/office/drawing/2014/main" id="{B3A2116D-56F0-848D-7F20-879D343CDB90}"/>
               </a:ext>
             </a:extLst>
           </p:cNvPr>
@@ -4169,7 +4170,7 @@
           <p:cNvPr id="23" name="Textfeld 22">
             <a:extLst>
               <a:ext uri="{FF2B5EF4-FFF2-40B4-BE49-F238E27FC236}">
-                <a16:creationId xmlns:a16="http://schemas.microsoft.com/office/drawing/2014/main" id="{ED0787F4-FC7E-91F7-47DA-C4FCE5F9CBE3}"/>
+                <a16:creationId xmlns:a16="http://schemas.microsoft.com/office/drawing/2014/main" id="{D1FF7432-AC66-0951-F126-42D27FAAFD72}"/>
               </a:ext>
             </a:extLst>
           </p:cNvPr>
@@ -4209,7 +4210,7 @@
           <p:cNvPr id="24" name="Textfeld 23">
             <a:extLst>
               <a:ext uri="{FF2B5EF4-FFF2-40B4-BE49-F238E27FC236}">
-                <a16:creationId xmlns:a16="http://schemas.microsoft.com/office/drawing/2014/main" id="{6E562ECC-B547-30F5-347B-AE43BA182FA9}"/>
+                <a16:creationId xmlns:a16="http://schemas.microsoft.com/office/drawing/2014/main" id="{30AA67E4-3204-6231-B11A-DFC28C3D6D31}"/>
               </a:ext>
             </a:extLst>
           </p:cNvPr>
@@ -4249,7 +4250,7 @@
           <p:cNvPr id="25" name="Textfeld 24">
             <a:extLst>
               <a:ext uri="{FF2B5EF4-FFF2-40B4-BE49-F238E27FC236}">
-                <a16:creationId xmlns:a16="http://schemas.microsoft.com/office/drawing/2014/main" id="{45513FDA-1A8C-659A-3741-03B8E90E4FAD}"/>
+                <a16:creationId xmlns:a16="http://schemas.microsoft.com/office/drawing/2014/main" id="{041AF89C-8BA6-6A98-0D76-0E3BC830505D}"/>
               </a:ext>
             </a:extLst>
           </p:cNvPr>
@@ -4289,7 +4290,7 @@
           <p:cNvPr id="26" name="Textfeld 25">
             <a:extLst>
               <a:ext uri="{FF2B5EF4-FFF2-40B4-BE49-F238E27FC236}">
-                <a16:creationId xmlns:a16="http://schemas.microsoft.com/office/drawing/2014/main" id="{FF3C4AD5-B2DB-F5B9-39DF-A3AEA723C222}"/>
+                <a16:creationId xmlns:a16="http://schemas.microsoft.com/office/drawing/2014/main" id="{514457BB-CC83-8AC5-4897-E87ACF4E4AAC}"/>
               </a:ext>
             </a:extLst>
           </p:cNvPr>
@@ -4329,7 +4330,7 @@
           <p:cNvPr id="27" name="Textfeld 26">
             <a:extLst>
               <a:ext uri="{FF2B5EF4-FFF2-40B4-BE49-F238E27FC236}">
-                <a16:creationId xmlns:a16="http://schemas.microsoft.com/office/drawing/2014/main" id="{8441CFE2-8DEE-258A-0DB1-DC0E50236D2E}"/>
+                <a16:creationId xmlns:a16="http://schemas.microsoft.com/office/drawing/2014/main" id="{9DD1400B-8246-57F7-69A7-6BD28099C494}"/>
               </a:ext>
             </a:extLst>
           </p:cNvPr>
@@ -4369,7 +4370,7 @@
           <p:cNvPr id="28" name="Textfeld 27">
             <a:extLst>
               <a:ext uri="{FF2B5EF4-FFF2-40B4-BE49-F238E27FC236}">
-                <a16:creationId xmlns:a16="http://schemas.microsoft.com/office/drawing/2014/main" id="{00273603-1282-33CD-BD05-C96CF9B5B860}"/>
+                <a16:creationId xmlns:a16="http://schemas.microsoft.com/office/drawing/2014/main" id="{F304593D-B5E8-287F-97C4-94184043EE0A}"/>
               </a:ext>
             </a:extLst>
           </p:cNvPr>
@@ -4409,7 +4410,7 @@
           <p:cNvPr id="29" name="Textfeld 28">
             <a:extLst>
               <a:ext uri="{FF2B5EF4-FFF2-40B4-BE49-F238E27FC236}">
-                <a16:creationId xmlns:a16="http://schemas.microsoft.com/office/drawing/2014/main" id="{D3AC9DD3-2478-0425-EF1A-3E7DD99166EF}"/>
+                <a16:creationId xmlns:a16="http://schemas.microsoft.com/office/drawing/2014/main" id="{3E5A4B33-CE9D-B6C6-7313-659DC5995D6A}"/>
               </a:ext>
             </a:extLst>
           </p:cNvPr>
@@ -4449,7 +4450,7 @@
           <p:cNvPr id="30" name="Textfeld 29">
             <a:extLst>
               <a:ext uri="{FF2B5EF4-FFF2-40B4-BE49-F238E27FC236}">
-                <a16:creationId xmlns:a16="http://schemas.microsoft.com/office/drawing/2014/main" id="{E1254918-BA10-6DEE-3A16-3F146F128C3C}"/>
+                <a16:creationId xmlns:a16="http://schemas.microsoft.com/office/drawing/2014/main" id="{9A4C692A-1E35-0D10-6F45-D3A730464B28}"/>
               </a:ext>
             </a:extLst>
           </p:cNvPr>
@@ -4489,7 +4490,7 @@
           <p:cNvPr id="31" name="Textfeld 30">
             <a:extLst>
               <a:ext uri="{FF2B5EF4-FFF2-40B4-BE49-F238E27FC236}">
-                <a16:creationId xmlns:a16="http://schemas.microsoft.com/office/drawing/2014/main" id="{3E4F25BB-B14A-D1E3-E6E1-BE507FFC71BC}"/>
+                <a16:creationId xmlns:a16="http://schemas.microsoft.com/office/drawing/2014/main" id="{166C40E4-236A-5AD6-6CBE-7D9F5C30FB6B}"/>
               </a:ext>
             </a:extLst>
           </p:cNvPr>
@@ -4529,7 +4530,7 @@
           <p:cNvPr id="32" name="Textfeld 31">
             <a:extLst>
               <a:ext uri="{FF2B5EF4-FFF2-40B4-BE49-F238E27FC236}">
-                <a16:creationId xmlns:a16="http://schemas.microsoft.com/office/drawing/2014/main" id="{59943854-F7E6-8E0C-B025-D5FF02C38EE8}"/>
+                <a16:creationId xmlns:a16="http://schemas.microsoft.com/office/drawing/2014/main" id="{C166F4B1-1A3A-B88A-3147-B40777F14788}"/>
               </a:ext>
             </a:extLst>
           </p:cNvPr>
@@ -4569,7 +4570,7 @@
           <p:cNvPr id="33" name="Textfeld 32">
             <a:extLst>
               <a:ext uri="{FF2B5EF4-FFF2-40B4-BE49-F238E27FC236}">
-                <a16:creationId xmlns:a16="http://schemas.microsoft.com/office/drawing/2014/main" id="{AA190C80-3E31-0C0B-520F-E4D4F5A4614F}"/>
+                <a16:creationId xmlns:a16="http://schemas.microsoft.com/office/drawing/2014/main" id="{2D22C006-1881-1C6B-8DF0-883780D1BC9A}"/>
               </a:ext>
             </a:extLst>
           </p:cNvPr>
@@ -4609,7 +4610,7 @@
           <p:cNvPr id="34" name="Textfeld 33">
             <a:extLst>
               <a:ext uri="{FF2B5EF4-FFF2-40B4-BE49-F238E27FC236}">
-                <a16:creationId xmlns:a16="http://schemas.microsoft.com/office/drawing/2014/main" id="{2BA0BC14-AF53-BB0F-9362-8901876E40E3}"/>
+                <a16:creationId xmlns:a16="http://schemas.microsoft.com/office/drawing/2014/main" id="{B251FB9E-A4E5-4D68-2A74-BCD942CEA22D}"/>
               </a:ext>
             </a:extLst>
           </p:cNvPr>
@@ -4649,7 +4650,7 @@
           <p:cNvPr id="35" name="Textfeld 34">
             <a:extLst>
               <a:ext uri="{FF2B5EF4-FFF2-40B4-BE49-F238E27FC236}">
-                <a16:creationId xmlns:a16="http://schemas.microsoft.com/office/drawing/2014/main" id="{D2272812-7FB3-1517-1A5C-E3D9EF4FBFDD}"/>
+                <a16:creationId xmlns:a16="http://schemas.microsoft.com/office/drawing/2014/main" id="{36B93BF7-5B00-CF40-9217-FE90033CBE68}"/>
               </a:ext>
             </a:extLst>
           </p:cNvPr>
@@ -4689,7 +4690,7 @@
           <p:cNvPr id="36" name="Textfeld 35">
             <a:extLst>
               <a:ext uri="{FF2B5EF4-FFF2-40B4-BE49-F238E27FC236}">
-                <a16:creationId xmlns:a16="http://schemas.microsoft.com/office/drawing/2014/main" id="{4ABC9390-CD80-DEEB-8A42-C3A26A4C116D}"/>
+                <a16:creationId xmlns:a16="http://schemas.microsoft.com/office/drawing/2014/main" id="{B34845EF-D757-CF31-8CB9-895E4DD853B5}"/>
               </a:ext>
             </a:extLst>
           </p:cNvPr>
@@ -4729,7 +4730,7 @@
           <p:cNvPr id="37" name="Textfeld 36">
             <a:extLst>
               <a:ext uri="{FF2B5EF4-FFF2-40B4-BE49-F238E27FC236}">
-                <a16:creationId xmlns:a16="http://schemas.microsoft.com/office/drawing/2014/main" id="{83161633-752A-A2BC-82B6-4C991E84AB76}"/>
+                <a16:creationId xmlns:a16="http://schemas.microsoft.com/office/drawing/2014/main" id="{2FAC8A2A-7A7F-AB6C-DF26-B85C4F8C979B}"/>
               </a:ext>
             </a:extLst>
           </p:cNvPr>
@@ -4769,7 +4770,7 @@
           <p:cNvPr id="38" name="Textfeld 37">
             <a:extLst>
               <a:ext uri="{FF2B5EF4-FFF2-40B4-BE49-F238E27FC236}">
-                <a16:creationId xmlns:a16="http://schemas.microsoft.com/office/drawing/2014/main" id="{45338131-C524-8497-461B-480F1851ECD2}"/>
+                <a16:creationId xmlns:a16="http://schemas.microsoft.com/office/drawing/2014/main" id="{B2616089-8DF4-3978-258C-10FE61B9367C}"/>
               </a:ext>
             </a:extLst>
           </p:cNvPr>
@@ -4809,7 +4810,7 @@
           <p:cNvPr id="39" name="Textfeld 38">
             <a:extLst>
               <a:ext uri="{FF2B5EF4-FFF2-40B4-BE49-F238E27FC236}">
-                <a16:creationId xmlns:a16="http://schemas.microsoft.com/office/drawing/2014/main" id="{CF2D8F38-11A8-B475-805D-8844FE01AECA}"/>
+                <a16:creationId xmlns:a16="http://schemas.microsoft.com/office/drawing/2014/main" id="{39201B94-A686-3421-EA57-A2C3F199E677}"/>
               </a:ext>
             </a:extLst>
           </p:cNvPr>
@@ -4849,7 +4850,7 @@
           <p:cNvPr id="40" name="Textfeld 39">
             <a:extLst>
               <a:ext uri="{FF2B5EF4-FFF2-40B4-BE49-F238E27FC236}">
-                <a16:creationId xmlns:a16="http://schemas.microsoft.com/office/drawing/2014/main" id="{74AB5AD2-4897-44F9-E07D-ADED9573A8BC}"/>
+                <a16:creationId xmlns:a16="http://schemas.microsoft.com/office/drawing/2014/main" id="{B07DAD65-7776-AF83-4E4B-E93C5D627D7A}"/>
               </a:ext>
             </a:extLst>
           </p:cNvPr>
@@ -4889,7 +4890,7 @@
           <p:cNvPr id="41" name="Textfeld 40">
             <a:extLst>
               <a:ext uri="{FF2B5EF4-FFF2-40B4-BE49-F238E27FC236}">
-                <a16:creationId xmlns:a16="http://schemas.microsoft.com/office/drawing/2014/main" id="{93A3BFC3-8F6B-2C41-2301-68F8FC50C0C3}"/>
+                <a16:creationId xmlns:a16="http://schemas.microsoft.com/office/drawing/2014/main" id="{28FB4B56-3328-F1FA-AEBE-A99E40480DA0}"/>
               </a:ext>
             </a:extLst>
           </p:cNvPr>
@@ -4929,7 +4930,7 @@
           <p:cNvPr id="42" name="Textfeld 41">
             <a:extLst>
               <a:ext uri="{FF2B5EF4-FFF2-40B4-BE49-F238E27FC236}">
-                <a16:creationId xmlns:a16="http://schemas.microsoft.com/office/drawing/2014/main" id="{D9FB6672-6938-6131-7D39-1C0B25ABCB48}"/>
+                <a16:creationId xmlns:a16="http://schemas.microsoft.com/office/drawing/2014/main" id="{45AE787C-C801-1136-C1CD-009BFF2B644C}"/>
               </a:ext>
             </a:extLst>
           </p:cNvPr>
@@ -4969,7 +4970,7 @@
           <p:cNvPr id="43" name="Textfeld 42">
             <a:extLst>
               <a:ext uri="{FF2B5EF4-FFF2-40B4-BE49-F238E27FC236}">
-                <a16:creationId xmlns:a16="http://schemas.microsoft.com/office/drawing/2014/main" id="{CE9B7CCC-8763-E5B9-1AB7-5601C04CFF59}"/>
+                <a16:creationId xmlns:a16="http://schemas.microsoft.com/office/drawing/2014/main" id="{DDA64CD7-E632-C39C-FEF7-A5CBBAD5F2A3}"/>
               </a:ext>
             </a:extLst>
           </p:cNvPr>
@@ -5009,7 +5010,7 @@
           <p:cNvPr id="44" name="Textfeld 43">
             <a:extLst>
               <a:ext uri="{FF2B5EF4-FFF2-40B4-BE49-F238E27FC236}">
-                <a16:creationId xmlns:a16="http://schemas.microsoft.com/office/drawing/2014/main" id="{E850C1E8-1688-4884-C145-C90EACAC6B2C}"/>
+                <a16:creationId xmlns:a16="http://schemas.microsoft.com/office/drawing/2014/main" id="{B6770B3F-5420-D3D9-6E03-F207A2BF5069}"/>
               </a:ext>
             </a:extLst>
           </p:cNvPr>
@@ -5049,7 +5050,7 @@
           <p:cNvPr id="45" name="Textfeld 44">
             <a:extLst>
               <a:ext uri="{FF2B5EF4-FFF2-40B4-BE49-F238E27FC236}">
-                <a16:creationId xmlns:a16="http://schemas.microsoft.com/office/drawing/2014/main" id="{566482A3-18FF-60B1-59ED-8339372B8223}"/>
+                <a16:creationId xmlns:a16="http://schemas.microsoft.com/office/drawing/2014/main" id="{E5510A67-201B-397C-B6C8-6116EDCEB444}"/>
               </a:ext>
             </a:extLst>
           </p:cNvPr>
@@ -5089,7 +5090,7 @@
           <p:cNvPr id="46" name="Textfeld 45">
             <a:extLst>
               <a:ext uri="{FF2B5EF4-FFF2-40B4-BE49-F238E27FC236}">
-                <a16:creationId xmlns:a16="http://schemas.microsoft.com/office/drawing/2014/main" id="{B828E623-4489-C590-CA2D-B3BE304DD98C}"/>
+                <a16:creationId xmlns:a16="http://schemas.microsoft.com/office/drawing/2014/main" id="{55C3A97C-C7FE-3F9B-2AE3-072166BDE3A2}"/>
               </a:ext>
             </a:extLst>
           </p:cNvPr>
@@ -5129,7 +5130,7 @@
           <p:cNvPr id="47" name="Textfeld 46">
             <a:extLst>
               <a:ext uri="{FF2B5EF4-FFF2-40B4-BE49-F238E27FC236}">
-                <a16:creationId xmlns:a16="http://schemas.microsoft.com/office/drawing/2014/main" id="{877D5D6C-2A8B-AEAE-1A9E-00B3EE45BFB8}"/>
+                <a16:creationId xmlns:a16="http://schemas.microsoft.com/office/drawing/2014/main" id="{8D2446E6-47C0-20FF-5548-DA4B2472F8C1}"/>
               </a:ext>
             </a:extLst>
           </p:cNvPr>
@@ -5169,7 +5170,7 @@
           <p:cNvPr id="48" name="Textfeld 47">
             <a:extLst>
               <a:ext uri="{FF2B5EF4-FFF2-40B4-BE49-F238E27FC236}">
-                <a16:creationId xmlns:a16="http://schemas.microsoft.com/office/drawing/2014/main" id="{AE77B7CF-AF3E-3AA5-88DA-A69ED02A168A}"/>
+                <a16:creationId xmlns:a16="http://schemas.microsoft.com/office/drawing/2014/main" id="{CE2A6D9E-9107-1DEB-488E-E954CF84533F}"/>
               </a:ext>
             </a:extLst>
           </p:cNvPr>
@@ -5209,7 +5210,7 @@
           <p:cNvPr id="49" name="Textfeld 48">
             <a:extLst>
               <a:ext uri="{FF2B5EF4-FFF2-40B4-BE49-F238E27FC236}">
-                <a16:creationId xmlns:a16="http://schemas.microsoft.com/office/drawing/2014/main" id="{13A32CE5-A387-6EBB-17F4-248D819F446B}"/>
+                <a16:creationId xmlns:a16="http://schemas.microsoft.com/office/drawing/2014/main" id="{2BDA67D3-8D08-4F71-4793-4DE426FD83F7}"/>
               </a:ext>
             </a:extLst>
           </p:cNvPr>
@@ -5249,7 +5250,7 @@
           <p:cNvPr id="50" name="Textfeld 49">
             <a:extLst>
               <a:ext uri="{FF2B5EF4-FFF2-40B4-BE49-F238E27FC236}">
-                <a16:creationId xmlns:a16="http://schemas.microsoft.com/office/drawing/2014/main" id="{926ACC27-52FE-7BBB-E1F5-D500B1DD9F95}"/>
+                <a16:creationId xmlns:a16="http://schemas.microsoft.com/office/drawing/2014/main" id="{A6A047CD-5898-15BF-48D2-6C1DF5CA4DD3}"/>
               </a:ext>
             </a:extLst>
           </p:cNvPr>
@@ -5289,7 +5290,7 @@
           <p:cNvPr id="51" name="Textfeld 50">
             <a:extLst>
               <a:ext uri="{FF2B5EF4-FFF2-40B4-BE49-F238E27FC236}">
-                <a16:creationId xmlns:a16="http://schemas.microsoft.com/office/drawing/2014/main" id="{C56C98CC-4C46-6A42-024B-37C97B10B91D}"/>
+                <a16:creationId xmlns:a16="http://schemas.microsoft.com/office/drawing/2014/main" id="{21751458-9F29-1462-C1B0-BE60FED6716A}"/>
               </a:ext>
             </a:extLst>
           </p:cNvPr>
@@ -5329,7 +5330,7 @@
           <p:cNvPr id="52" name="Textfeld 51">
             <a:extLst>
               <a:ext uri="{FF2B5EF4-FFF2-40B4-BE49-F238E27FC236}">
-                <a16:creationId xmlns:a16="http://schemas.microsoft.com/office/drawing/2014/main" id="{9EBE7FB6-C580-F909-F54D-76025384C90E}"/>
+                <a16:creationId xmlns:a16="http://schemas.microsoft.com/office/drawing/2014/main" id="{B253CCC3-A6B7-9F63-E5C4-DC0DE25D917B}"/>
               </a:ext>
             </a:extLst>
           </p:cNvPr>
@@ -5369,7 +5370,7 @@
           <p:cNvPr id="53" name="Textfeld 52">
             <a:extLst>
               <a:ext uri="{FF2B5EF4-FFF2-40B4-BE49-F238E27FC236}">
-                <a16:creationId xmlns:a16="http://schemas.microsoft.com/office/drawing/2014/main" id="{A70803A7-83D2-F12D-8367-41C6172DF584}"/>
+                <a16:creationId xmlns:a16="http://schemas.microsoft.com/office/drawing/2014/main" id="{1EE46B4B-59FD-E4F0-0982-1C7BD8B53246}"/>
               </a:ext>
             </a:extLst>
           </p:cNvPr>
@@ -5409,7 +5410,7 @@
           <p:cNvPr id="54" name="Textfeld 53">
             <a:extLst>
               <a:ext uri="{FF2B5EF4-FFF2-40B4-BE49-F238E27FC236}">
-                <a16:creationId xmlns:a16="http://schemas.microsoft.com/office/drawing/2014/main" id="{AD06EFAE-51AE-619C-7648-9746730581F1}"/>
+                <a16:creationId xmlns:a16="http://schemas.microsoft.com/office/drawing/2014/main" id="{98CB04D4-FB86-811B-B6DE-2768D2BA59E6}"/>
               </a:ext>
             </a:extLst>
           </p:cNvPr>
@@ -5449,7 +5450,7 @@
           <p:cNvPr id="55" name="Textfeld 54">
             <a:extLst>
               <a:ext uri="{FF2B5EF4-FFF2-40B4-BE49-F238E27FC236}">
-                <a16:creationId xmlns:a16="http://schemas.microsoft.com/office/drawing/2014/main" id="{7B965C3E-0B9A-0EC8-1C8D-41B7EECBEF10}"/>
+                <a16:creationId xmlns:a16="http://schemas.microsoft.com/office/drawing/2014/main" id="{7AFEE397-7C89-1DBE-F8C2-47768EC9E58C}"/>
               </a:ext>
             </a:extLst>
           </p:cNvPr>
@@ -5489,7 +5490,7 @@
           <p:cNvPr id="56" name="Textfeld 55">
             <a:extLst>
               <a:ext uri="{FF2B5EF4-FFF2-40B4-BE49-F238E27FC236}">
-                <a16:creationId xmlns:a16="http://schemas.microsoft.com/office/drawing/2014/main" id="{603D3F0B-1175-1169-5FA9-3CF27FF9AA15}"/>
+                <a16:creationId xmlns:a16="http://schemas.microsoft.com/office/drawing/2014/main" id="{9198F2E0-E8C4-82C6-6CE7-12560014CE73}"/>
               </a:ext>
             </a:extLst>
           </p:cNvPr>
@@ -5529,7 +5530,7 @@
           <p:cNvPr id="57" name="Textfeld 56">
             <a:extLst>
               <a:ext uri="{FF2B5EF4-FFF2-40B4-BE49-F238E27FC236}">
-                <a16:creationId xmlns:a16="http://schemas.microsoft.com/office/drawing/2014/main" id="{80AFF1DF-C422-60E4-2648-081DC5E7F768}"/>
+                <a16:creationId xmlns:a16="http://schemas.microsoft.com/office/drawing/2014/main" id="{98F5B3B1-98A6-3B90-7999-63EDF0303DC7}"/>
               </a:ext>
             </a:extLst>
           </p:cNvPr>
@@ -5569,7 +5570,7 @@
           <p:cNvPr id="58" name="Textfeld 57">
             <a:extLst>
               <a:ext uri="{FF2B5EF4-FFF2-40B4-BE49-F238E27FC236}">
-                <a16:creationId xmlns:a16="http://schemas.microsoft.com/office/drawing/2014/main" id="{C3C1583A-BCD8-9534-2E9D-52AAF99D1D85}"/>
+                <a16:creationId xmlns:a16="http://schemas.microsoft.com/office/drawing/2014/main" id="{0F346451-6E59-023A-5564-9DBDAEA7030C}"/>
               </a:ext>
             </a:extLst>
           </p:cNvPr>
@@ -5609,7 +5610,7 @@
           <p:cNvPr id="59" name="Textfeld 58">
             <a:extLst>
               <a:ext uri="{FF2B5EF4-FFF2-40B4-BE49-F238E27FC236}">
-                <a16:creationId xmlns:a16="http://schemas.microsoft.com/office/drawing/2014/main" id="{5F7B3998-A860-3CC8-7621-956556C436AA}"/>
+                <a16:creationId xmlns:a16="http://schemas.microsoft.com/office/drawing/2014/main" id="{3F40C0CE-4332-059C-FD92-C8D1A1D1D2D5}"/>
               </a:ext>
             </a:extLst>
           </p:cNvPr>
@@ -5649,7 +5650,7 @@
           <p:cNvPr id="60" name="Textfeld 59">
             <a:extLst>
               <a:ext uri="{FF2B5EF4-FFF2-40B4-BE49-F238E27FC236}">
-                <a16:creationId xmlns:a16="http://schemas.microsoft.com/office/drawing/2014/main" id="{606A90F6-083C-8A10-53D8-CE58FA0AE915}"/>
+                <a16:creationId xmlns:a16="http://schemas.microsoft.com/office/drawing/2014/main" id="{FE91F19C-DC1D-A079-9AB7-F8EE11372D64}"/>
               </a:ext>
             </a:extLst>
           </p:cNvPr>
@@ -5689,7 +5690,7 @@
           <p:cNvPr id="61" name="Textfeld 60">
             <a:extLst>
               <a:ext uri="{FF2B5EF4-FFF2-40B4-BE49-F238E27FC236}">
-                <a16:creationId xmlns:a16="http://schemas.microsoft.com/office/drawing/2014/main" id="{613089B2-A1F5-25A4-C851-0EE2F75ED291}"/>
+                <a16:creationId xmlns:a16="http://schemas.microsoft.com/office/drawing/2014/main" id="{D49E5B64-EFD4-2E5B-1A8C-67DB0D6417A3}"/>
               </a:ext>
             </a:extLst>
           </p:cNvPr>
@@ -5729,7 +5730,7 @@
           <p:cNvPr id="62" name="Textfeld 61">
             <a:extLst>
               <a:ext uri="{FF2B5EF4-FFF2-40B4-BE49-F238E27FC236}">
-                <a16:creationId xmlns:a16="http://schemas.microsoft.com/office/drawing/2014/main" id="{3C2DB1F2-1241-9F97-C36A-04501A2FFD8A}"/>
+                <a16:creationId xmlns:a16="http://schemas.microsoft.com/office/drawing/2014/main" id="{4478F763-91D4-5CD6-571E-3723CC5B3606}"/>
               </a:ext>
             </a:extLst>
           </p:cNvPr>
@@ -5769,7 +5770,7 @@
           <p:cNvPr id="63" name="Textfeld 62">
             <a:extLst>
               <a:ext uri="{FF2B5EF4-FFF2-40B4-BE49-F238E27FC236}">
-                <a16:creationId xmlns:a16="http://schemas.microsoft.com/office/drawing/2014/main" id="{2F561B97-90EE-9A62-425B-D89657D5F383}"/>
+                <a16:creationId xmlns:a16="http://schemas.microsoft.com/office/drawing/2014/main" id="{28DB1999-5F90-829B-99C5-6EB627405821}"/>
               </a:ext>
             </a:extLst>
           </p:cNvPr>
@@ -5809,7 +5810,7 @@
           <p:cNvPr id="64" name="Textfeld 63">
             <a:extLst>
               <a:ext uri="{FF2B5EF4-FFF2-40B4-BE49-F238E27FC236}">
-                <a16:creationId xmlns:a16="http://schemas.microsoft.com/office/drawing/2014/main" id="{C2848C09-5DD3-610A-B774-76E331D271CC}"/>
+                <a16:creationId xmlns:a16="http://schemas.microsoft.com/office/drawing/2014/main" id="{BE5831DC-E2D9-D1D1-0F03-92AA012AFB79}"/>
               </a:ext>
             </a:extLst>
           </p:cNvPr>
@@ -5849,7 +5850,7 @@
           <p:cNvPr id="65" name="Textfeld 64">
             <a:extLst>
               <a:ext uri="{FF2B5EF4-FFF2-40B4-BE49-F238E27FC236}">
-                <a16:creationId xmlns:a16="http://schemas.microsoft.com/office/drawing/2014/main" id="{A81D52DA-E32A-C03F-0568-C9FFB31E03A5}"/>
+                <a16:creationId xmlns:a16="http://schemas.microsoft.com/office/drawing/2014/main" id="{AD55ABBE-0FD5-3935-868E-D996561A8C13}"/>
               </a:ext>
             </a:extLst>
           </p:cNvPr>
@@ -5889,7 +5890,7 @@
           <p:cNvPr id="66" name="Textfeld 65">
             <a:extLst>
               <a:ext uri="{FF2B5EF4-FFF2-40B4-BE49-F238E27FC236}">
-                <a16:creationId xmlns:a16="http://schemas.microsoft.com/office/drawing/2014/main" id="{388EFF51-B3B7-9EBC-A210-588DA1FC316E}"/>
+                <a16:creationId xmlns:a16="http://schemas.microsoft.com/office/drawing/2014/main" id="{4EA014CB-079C-F703-1C0B-0006A96928F9}"/>
               </a:ext>
             </a:extLst>
           </p:cNvPr>
@@ -5929,7 +5930,7 @@
           <p:cNvPr id="67" name="Textfeld 66">
             <a:extLst>
               <a:ext uri="{FF2B5EF4-FFF2-40B4-BE49-F238E27FC236}">
-                <a16:creationId xmlns:a16="http://schemas.microsoft.com/office/drawing/2014/main" id="{7C0D1975-5271-41F8-CFDD-E6C43F800F0B}"/>
+                <a16:creationId xmlns:a16="http://schemas.microsoft.com/office/drawing/2014/main" id="{64309510-EB5A-E3B4-FE84-D407B9C524DF}"/>
               </a:ext>
             </a:extLst>
           </p:cNvPr>
@@ -5969,7 +5970,7 @@
           <p:cNvPr id="68" name="Textfeld 67">
             <a:extLst>
               <a:ext uri="{FF2B5EF4-FFF2-40B4-BE49-F238E27FC236}">
-                <a16:creationId xmlns:a16="http://schemas.microsoft.com/office/drawing/2014/main" id="{0F69C2CC-7A74-5FA5-71FB-7D93E8139CCB}"/>
+                <a16:creationId xmlns:a16="http://schemas.microsoft.com/office/drawing/2014/main" id="{E0836E52-BC4C-BD49-77F1-B7BDC6CD2DD0}"/>
               </a:ext>
             </a:extLst>
           </p:cNvPr>
@@ -6009,7 +6010,7 @@
           <p:cNvPr id="69" name="Textfeld 68">
             <a:extLst>
               <a:ext uri="{FF2B5EF4-FFF2-40B4-BE49-F238E27FC236}">
-                <a16:creationId xmlns:a16="http://schemas.microsoft.com/office/drawing/2014/main" id="{C6F21180-FFF9-925F-9C09-B3F618B24115}"/>
+                <a16:creationId xmlns:a16="http://schemas.microsoft.com/office/drawing/2014/main" id="{A3823E56-4D81-DE5A-3E9F-9DD0A3E60882}"/>
               </a:ext>
             </a:extLst>
           </p:cNvPr>
@@ -6049,7 +6050,7 @@
           <p:cNvPr id="70" name="Textfeld 69">
             <a:extLst>
               <a:ext uri="{FF2B5EF4-FFF2-40B4-BE49-F238E27FC236}">
-                <a16:creationId xmlns:a16="http://schemas.microsoft.com/office/drawing/2014/main" id="{A95744F6-C9D2-0865-744F-995B92931138}"/>
+                <a16:creationId xmlns:a16="http://schemas.microsoft.com/office/drawing/2014/main" id="{0D862F0A-3DBC-903D-3A31-C5F148B7643D}"/>
               </a:ext>
             </a:extLst>
           </p:cNvPr>
@@ -6089,7 +6090,7 @@
           <p:cNvPr id="71" name="Textfeld 70">
             <a:extLst>
               <a:ext uri="{FF2B5EF4-FFF2-40B4-BE49-F238E27FC236}">
-                <a16:creationId xmlns:a16="http://schemas.microsoft.com/office/drawing/2014/main" id="{56C82A40-84DF-2B56-B305-D97D30224CEF}"/>
+                <a16:creationId xmlns:a16="http://schemas.microsoft.com/office/drawing/2014/main" id="{66ABFADF-9F29-05F1-FD62-E29BB0E3D08A}"/>
               </a:ext>
             </a:extLst>
           </p:cNvPr>
@@ -6129,7 +6130,7 @@
           <p:cNvPr id="72" name="Textfeld 71">
             <a:extLst>
               <a:ext uri="{FF2B5EF4-FFF2-40B4-BE49-F238E27FC236}">
-                <a16:creationId xmlns:a16="http://schemas.microsoft.com/office/drawing/2014/main" id="{A9D0DC85-C166-BFB4-D107-F3F0563968E3}"/>
+                <a16:creationId xmlns:a16="http://schemas.microsoft.com/office/drawing/2014/main" id="{7E49033B-93A4-64A6-E050-E34E4C456442}"/>
               </a:ext>
             </a:extLst>
           </p:cNvPr>
@@ -6169,7 +6170,7 @@
           <p:cNvPr id="73" name="Textfeld 72">
             <a:extLst>
               <a:ext uri="{FF2B5EF4-FFF2-40B4-BE49-F238E27FC236}">
-                <a16:creationId xmlns:a16="http://schemas.microsoft.com/office/drawing/2014/main" id="{92C1CA75-9DB6-CC11-C7DA-BE109033B798}"/>
+                <a16:creationId xmlns:a16="http://schemas.microsoft.com/office/drawing/2014/main" id="{CF660357-F4E5-9463-3CCD-B1C6E7FB6105}"/>
               </a:ext>
             </a:extLst>
           </p:cNvPr>
@@ -6209,7 +6210,7 @@
           <p:cNvPr id="74" name="Textfeld 73">
             <a:extLst>
               <a:ext uri="{FF2B5EF4-FFF2-40B4-BE49-F238E27FC236}">
-                <a16:creationId xmlns:a16="http://schemas.microsoft.com/office/drawing/2014/main" id="{5A7AA811-01A3-FECA-4671-7478D52E112A}"/>
+                <a16:creationId xmlns:a16="http://schemas.microsoft.com/office/drawing/2014/main" id="{6C9E558D-FBC3-149E-FBD0-61063C9A47C8}"/>
               </a:ext>
             </a:extLst>
           </p:cNvPr>
@@ -6249,7 +6250,7 @@
           <p:cNvPr id="75" name="Textfeld 74">
             <a:extLst>
               <a:ext uri="{FF2B5EF4-FFF2-40B4-BE49-F238E27FC236}">
-                <a16:creationId xmlns:a16="http://schemas.microsoft.com/office/drawing/2014/main" id="{BB35742B-E795-F505-9FAA-500A472C44C8}"/>
+                <a16:creationId xmlns:a16="http://schemas.microsoft.com/office/drawing/2014/main" id="{ACBAD5F8-78E4-0504-5BE7-7ED181B78FAB}"/>
               </a:ext>
             </a:extLst>
           </p:cNvPr>
@@ -6289,7 +6290,7 @@
           <p:cNvPr id="76" name="Textfeld 75">
             <a:extLst>
               <a:ext uri="{FF2B5EF4-FFF2-40B4-BE49-F238E27FC236}">
-                <a16:creationId xmlns:a16="http://schemas.microsoft.com/office/drawing/2014/main" id="{2BF5AF1C-0862-0E1C-757C-BD3C118FB6FE}"/>
+                <a16:creationId xmlns:a16="http://schemas.microsoft.com/office/drawing/2014/main" id="{5FFD6B49-4F5C-5E5F-5CA6-3954AE447A96}"/>
               </a:ext>
             </a:extLst>
           </p:cNvPr>
@@ -6329,7 +6330,7 @@
           <p:cNvPr id="77" name="Textfeld 76">
             <a:extLst>
               <a:ext uri="{FF2B5EF4-FFF2-40B4-BE49-F238E27FC236}">
-                <a16:creationId xmlns:a16="http://schemas.microsoft.com/office/drawing/2014/main" id="{48F23E21-DAAA-AC99-9E3D-3789E7E142D1}"/>
+                <a16:creationId xmlns:a16="http://schemas.microsoft.com/office/drawing/2014/main" id="{7FEE6556-459D-FF9E-DAAB-1C4B9D322108}"/>
               </a:ext>
             </a:extLst>
           </p:cNvPr>
@@ -6369,7 +6370,7 @@
           <p:cNvPr id="78" name="Textfeld 77">
             <a:extLst>
               <a:ext uri="{FF2B5EF4-FFF2-40B4-BE49-F238E27FC236}">
-                <a16:creationId xmlns:a16="http://schemas.microsoft.com/office/drawing/2014/main" id="{F676B21E-BDD2-DA57-CE9E-671E0990CFEE}"/>
+                <a16:creationId xmlns:a16="http://schemas.microsoft.com/office/drawing/2014/main" id="{BFDE595D-AA3C-3E4E-FEEB-027BE8C65C22}"/>
               </a:ext>
             </a:extLst>
           </p:cNvPr>
@@ -6409,7 +6410,7 @@
           <p:cNvPr id="79" name="Textfeld 78">
             <a:extLst>
               <a:ext uri="{FF2B5EF4-FFF2-40B4-BE49-F238E27FC236}">
-                <a16:creationId xmlns:a16="http://schemas.microsoft.com/office/drawing/2014/main" id="{DA9ED83C-16FF-D36B-572B-5C91DBFAF524}"/>
+                <a16:creationId xmlns:a16="http://schemas.microsoft.com/office/drawing/2014/main" id="{47ACD6C4-4FB6-A122-4933-20DF6589F213}"/>
               </a:ext>
             </a:extLst>
           </p:cNvPr>
@@ -6449,7 +6450,7 @@
           <p:cNvPr id="80" name="Textfeld 79">
             <a:extLst>
               <a:ext uri="{FF2B5EF4-FFF2-40B4-BE49-F238E27FC236}">
-                <a16:creationId xmlns:a16="http://schemas.microsoft.com/office/drawing/2014/main" id="{B7C78E2A-36B8-BDF5-F5EB-BE5C88D0BA41}"/>
+                <a16:creationId xmlns:a16="http://schemas.microsoft.com/office/drawing/2014/main" id="{0635CAF3-C0DF-C04F-7DF7-741AB84770EA}"/>
               </a:ext>
             </a:extLst>
           </p:cNvPr>
@@ -6489,7 +6490,7 @@
           <p:cNvPr id="81" name="Textfeld 80">
             <a:extLst>
               <a:ext uri="{FF2B5EF4-FFF2-40B4-BE49-F238E27FC236}">
-                <a16:creationId xmlns:a16="http://schemas.microsoft.com/office/drawing/2014/main" id="{008F5472-4A54-7802-8771-0E5489DD8EA3}"/>
+                <a16:creationId xmlns:a16="http://schemas.microsoft.com/office/drawing/2014/main" id="{E84BC990-0B9E-D395-0E8B-70CA27E7D4FF}"/>
               </a:ext>
             </a:extLst>
           </p:cNvPr>
@@ -6529,7 +6530,7 @@
           <p:cNvPr id="82" name="Textfeld 81">
             <a:extLst>
               <a:ext uri="{FF2B5EF4-FFF2-40B4-BE49-F238E27FC236}">
-                <a16:creationId xmlns:a16="http://schemas.microsoft.com/office/drawing/2014/main" id="{54DF646E-F639-FA06-AC18-BBAF8E0FFCBC}"/>
+                <a16:creationId xmlns:a16="http://schemas.microsoft.com/office/drawing/2014/main" id="{ACAD2868-DC10-4461-70DF-1B33415C253E}"/>
               </a:ext>
             </a:extLst>
           </p:cNvPr>
@@ -6569,7 +6570,7 @@
           <p:cNvPr id="83" name="Textfeld 82">
             <a:extLst>
               <a:ext uri="{FF2B5EF4-FFF2-40B4-BE49-F238E27FC236}">
-                <a16:creationId xmlns:a16="http://schemas.microsoft.com/office/drawing/2014/main" id="{8B2279ED-DA66-89DD-60E1-AE7F17695DB6}"/>
+                <a16:creationId xmlns:a16="http://schemas.microsoft.com/office/drawing/2014/main" id="{ADD8D288-B61C-2908-D273-D76AD6785090}"/>
               </a:ext>
             </a:extLst>
           </p:cNvPr>
@@ -6609,7 +6610,7 @@
           <p:cNvPr id="84" name="Textfeld 83">
             <a:extLst>
               <a:ext uri="{FF2B5EF4-FFF2-40B4-BE49-F238E27FC236}">
-                <a16:creationId xmlns:a16="http://schemas.microsoft.com/office/drawing/2014/main" id="{F490678E-DEEC-CE8E-B2A6-0AE5F698BB3F}"/>
+                <a16:creationId xmlns:a16="http://schemas.microsoft.com/office/drawing/2014/main" id="{414CAD04-D7E7-21A1-AD4F-49911F0B4573}"/>
               </a:ext>
             </a:extLst>
           </p:cNvPr>
@@ -6649,7 +6650,7 @@
           <p:cNvPr id="85" name="Textfeld 84">
             <a:extLst>
               <a:ext uri="{FF2B5EF4-FFF2-40B4-BE49-F238E27FC236}">
-                <a16:creationId xmlns:a16="http://schemas.microsoft.com/office/drawing/2014/main" id="{0FD597F5-12B1-96BC-0A42-6ACBDDBB65A0}"/>
+                <a16:creationId xmlns:a16="http://schemas.microsoft.com/office/drawing/2014/main" id="{63E98BE7-85F3-6C67-257B-64BFE9EFD27D}"/>
               </a:ext>
             </a:extLst>
           </p:cNvPr>
@@ -6689,7 +6690,7 @@
           <p:cNvPr id="86" name="Textfeld 85">
             <a:extLst>
               <a:ext uri="{FF2B5EF4-FFF2-40B4-BE49-F238E27FC236}">
-                <a16:creationId xmlns:a16="http://schemas.microsoft.com/office/drawing/2014/main" id="{AAD408F2-7FAF-29B3-78C1-EF22AE243BB2}"/>
+                <a16:creationId xmlns:a16="http://schemas.microsoft.com/office/drawing/2014/main" id="{27E21FE7-AE05-0220-A1B4-88AD14E4CD4A}"/>
               </a:ext>
             </a:extLst>
           </p:cNvPr>
@@ -6729,7 +6730,7 @@
           <p:cNvPr id="87" name="Textfeld 86">
             <a:extLst>
               <a:ext uri="{FF2B5EF4-FFF2-40B4-BE49-F238E27FC236}">
-                <a16:creationId xmlns:a16="http://schemas.microsoft.com/office/drawing/2014/main" id="{30999B16-B3ED-1BB3-04D1-7F4D7DB2F0F8}"/>
+                <a16:creationId xmlns:a16="http://schemas.microsoft.com/office/drawing/2014/main" id="{0FB94798-0299-D095-3CC9-B2E4E4EC86A7}"/>
               </a:ext>
             </a:extLst>
           </p:cNvPr>
@@ -6769,7 +6770,7 @@
           <p:cNvPr id="88" name="Textfeld 87">
             <a:extLst>
               <a:ext uri="{FF2B5EF4-FFF2-40B4-BE49-F238E27FC236}">
-                <a16:creationId xmlns:a16="http://schemas.microsoft.com/office/drawing/2014/main" id="{A0285BAB-6660-7EE4-553E-B1B8F30C4A83}"/>
+                <a16:creationId xmlns:a16="http://schemas.microsoft.com/office/drawing/2014/main" id="{5FA02EB9-996C-7960-2FB2-F227876D0053}"/>
               </a:ext>
             </a:extLst>
           </p:cNvPr>
@@ -6809,7 +6810,7 @@
           <p:cNvPr id="89" name="Textfeld 88">
             <a:extLst>
               <a:ext uri="{FF2B5EF4-FFF2-40B4-BE49-F238E27FC236}">
-                <a16:creationId xmlns:a16="http://schemas.microsoft.com/office/drawing/2014/main" id="{72143531-5B12-AA9A-3AD9-35B18DE9EC2F}"/>
+                <a16:creationId xmlns:a16="http://schemas.microsoft.com/office/drawing/2014/main" id="{378DBEA1-1B5D-C45E-2902-49941F1F035C}"/>
               </a:ext>
             </a:extLst>
           </p:cNvPr>
@@ -6849,7 +6850,7 @@
           <p:cNvPr id="90" name="Textfeld 89">
             <a:extLst>
               <a:ext uri="{FF2B5EF4-FFF2-40B4-BE49-F238E27FC236}">
-                <a16:creationId xmlns:a16="http://schemas.microsoft.com/office/drawing/2014/main" id="{6761746C-F50F-2804-89B5-D366ED230292}"/>
+                <a16:creationId xmlns:a16="http://schemas.microsoft.com/office/drawing/2014/main" id="{7205B7BC-E1B0-8FA1-0CD9-0049E2623FC8}"/>
               </a:ext>
             </a:extLst>
           </p:cNvPr>
@@ -6889,7 +6890,7 @@
           <p:cNvPr id="91" name="Textfeld 90">
             <a:extLst>
               <a:ext uri="{FF2B5EF4-FFF2-40B4-BE49-F238E27FC236}">
-                <a16:creationId xmlns:a16="http://schemas.microsoft.com/office/drawing/2014/main" id="{2D0C0005-DEEF-6942-46AC-61AD9EFD6185}"/>
+                <a16:creationId xmlns:a16="http://schemas.microsoft.com/office/drawing/2014/main" id="{9B7E61DB-33D9-DE0C-4ADC-7F970786725A}"/>
               </a:ext>
             </a:extLst>
           </p:cNvPr>
@@ -6929,7 +6930,7 @@
           <p:cNvPr id="92" name="Textfeld 91">
             <a:extLst>
               <a:ext uri="{FF2B5EF4-FFF2-40B4-BE49-F238E27FC236}">
-                <a16:creationId xmlns:a16="http://schemas.microsoft.com/office/drawing/2014/main" id="{B94554FE-F9AC-8E33-37E9-A9D34678CC48}"/>
+                <a16:creationId xmlns:a16="http://schemas.microsoft.com/office/drawing/2014/main" id="{F4558ABF-7F0A-CD62-6765-A222E4A4E606}"/>
               </a:ext>
             </a:extLst>
           </p:cNvPr>
@@ -6969,7 +6970,7 @@
           <p:cNvPr id="93" name="Textfeld 92">
             <a:extLst>
               <a:ext uri="{FF2B5EF4-FFF2-40B4-BE49-F238E27FC236}">
-                <a16:creationId xmlns:a16="http://schemas.microsoft.com/office/drawing/2014/main" id="{6FF97FB7-C4A4-1C70-CB5B-737C555E6008}"/>
+                <a16:creationId xmlns:a16="http://schemas.microsoft.com/office/drawing/2014/main" id="{B11A3991-A144-1EA7-11A2-319FC22DC7B0}"/>
               </a:ext>
             </a:extLst>
           </p:cNvPr>
@@ -7009,7 +7010,7 @@
           <p:cNvPr id="94" name="Textfeld 93">
             <a:extLst>
               <a:ext uri="{FF2B5EF4-FFF2-40B4-BE49-F238E27FC236}">
-                <a16:creationId xmlns:a16="http://schemas.microsoft.com/office/drawing/2014/main" id="{91CBB431-E3E7-2673-F53B-D2D9F843FD87}"/>
+                <a16:creationId xmlns:a16="http://schemas.microsoft.com/office/drawing/2014/main" id="{C12473F5-3302-A06A-1BEB-3003F8A7061F}"/>
               </a:ext>
             </a:extLst>
           </p:cNvPr>
@@ -7049,7 +7050,7 @@
           <p:cNvPr id="95" name="Textfeld 94">
             <a:extLst>
               <a:ext uri="{FF2B5EF4-FFF2-40B4-BE49-F238E27FC236}">
-                <a16:creationId xmlns:a16="http://schemas.microsoft.com/office/drawing/2014/main" id="{01147214-FF96-E25B-F33D-B39BDB98FE8F}"/>
+                <a16:creationId xmlns:a16="http://schemas.microsoft.com/office/drawing/2014/main" id="{1B7C8AB7-0EB3-ED1A-C99C-7FDBA0377879}"/>
               </a:ext>
             </a:extLst>
           </p:cNvPr>
@@ -7089,7 +7090,7 @@
           <p:cNvPr id="96" name="Textfeld 95">
             <a:extLst>
               <a:ext uri="{FF2B5EF4-FFF2-40B4-BE49-F238E27FC236}">
-                <a16:creationId xmlns:a16="http://schemas.microsoft.com/office/drawing/2014/main" id="{917000D4-26A1-4CC4-356E-8F1E7164F3BA}"/>
+                <a16:creationId xmlns:a16="http://schemas.microsoft.com/office/drawing/2014/main" id="{647C26E2-945E-0252-C781-81BBD7AFC4A6}"/>
               </a:ext>
             </a:extLst>
           </p:cNvPr>
@@ -7129,7 +7130,7 @@
           <p:cNvPr id="97" name="Textfeld 96">
             <a:extLst>
               <a:ext uri="{FF2B5EF4-FFF2-40B4-BE49-F238E27FC236}">
-                <a16:creationId xmlns:a16="http://schemas.microsoft.com/office/drawing/2014/main" id="{3970F4B8-26FC-0B9F-37E2-EAA1D598A640}"/>
+                <a16:creationId xmlns:a16="http://schemas.microsoft.com/office/drawing/2014/main" id="{72D4C38A-C6BE-8B92-9AD7-EDE7FD8E4408}"/>
               </a:ext>
             </a:extLst>
           </p:cNvPr>
@@ -7167,7 +7168,7 @@
     </p:spTree>
     <p:extLst>
       <p:ext uri="{BB962C8B-B14F-4D97-AF65-F5344CB8AC3E}">
-        <p14:creationId xmlns:p14="http://schemas.microsoft.com/office/powerpoint/2010/main" val="2379141967"/>
+        <p14:creationId xmlns:p14="http://schemas.microsoft.com/office/powerpoint/2010/main" val="1293950795"/>
       </p:ext>
     </p:extLst>
   </p:cSld>
@@ -7199,7 +7200,7 @@
           <p:cNvPr id="2" name="Textfeld 1">
             <a:extLst>
               <a:ext uri="{FF2B5EF4-FFF2-40B4-BE49-F238E27FC236}">
-                <a16:creationId xmlns:a16="http://schemas.microsoft.com/office/drawing/2014/main" id="{F557A38F-2414-D2B7-2F12-6025642C4F1C}"/>
+                <a16:creationId xmlns:a16="http://schemas.microsoft.com/office/drawing/2014/main" id="{865A46EF-F00B-A13A-7A0D-F192F3A0433C}"/>
               </a:ext>
             </a:extLst>
           </p:cNvPr>
@@ -7239,7 +7240,7 @@
           <p:cNvPr id="3" name="Textfeld 2">
             <a:extLst>
               <a:ext uri="{FF2B5EF4-FFF2-40B4-BE49-F238E27FC236}">
-                <a16:creationId xmlns:a16="http://schemas.microsoft.com/office/drawing/2014/main" id="{98024A75-4730-1B4E-6D49-5DA885B2ABED}"/>
+                <a16:creationId xmlns:a16="http://schemas.microsoft.com/office/drawing/2014/main" id="{A9DE9AF9-0A9A-C75F-F32A-6E318715DEA6}"/>
               </a:ext>
             </a:extLst>
           </p:cNvPr>
@@ -7279,7 +7280,7 @@
           <p:cNvPr id="4" name="Textfeld 3">
             <a:extLst>
               <a:ext uri="{FF2B5EF4-FFF2-40B4-BE49-F238E27FC236}">
-                <a16:creationId xmlns:a16="http://schemas.microsoft.com/office/drawing/2014/main" id="{B7F81D3A-8348-9959-A40C-479D950CC5EC}"/>
+                <a16:creationId xmlns:a16="http://schemas.microsoft.com/office/drawing/2014/main" id="{F3F341B7-4251-8799-FF70-A242F720F8F1}"/>
               </a:ext>
             </a:extLst>
           </p:cNvPr>
@@ -7319,7 +7320,7 @@
           <p:cNvPr id="5" name="Textfeld 4">
             <a:extLst>
               <a:ext uri="{FF2B5EF4-FFF2-40B4-BE49-F238E27FC236}">
-                <a16:creationId xmlns:a16="http://schemas.microsoft.com/office/drawing/2014/main" id="{45446F3E-D8D8-6726-FB69-ACC750623D8B}"/>
+                <a16:creationId xmlns:a16="http://schemas.microsoft.com/office/drawing/2014/main" id="{ED725749-3F18-7A91-0393-657F902870D3}"/>
               </a:ext>
             </a:extLst>
           </p:cNvPr>
@@ -7359,7 +7360,7 @@
           <p:cNvPr id="6" name="Textfeld 5">
             <a:extLst>
               <a:ext uri="{FF2B5EF4-FFF2-40B4-BE49-F238E27FC236}">
-                <a16:creationId xmlns:a16="http://schemas.microsoft.com/office/drawing/2014/main" id="{1DC068FF-25C0-F390-DCFE-077B410C23E0}"/>
+                <a16:creationId xmlns:a16="http://schemas.microsoft.com/office/drawing/2014/main" id="{1AA66AB2-6F38-1C00-74A1-723BEB85759D}"/>
               </a:ext>
             </a:extLst>
           </p:cNvPr>
@@ -7399,7 +7400,7 @@
           <p:cNvPr id="7" name="Textfeld 6">
             <a:extLst>
               <a:ext uri="{FF2B5EF4-FFF2-40B4-BE49-F238E27FC236}">
-                <a16:creationId xmlns:a16="http://schemas.microsoft.com/office/drawing/2014/main" id="{F9BEE8FC-C6D2-7242-94C5-24A9656A1683}"/>
+                <a16:creationId xmlns:a16="http://schemas.microsoft.com/office/drawing/2014/main" id="{18BF860E-826D-ECA3-92AA-AD5F28015A5D}"/>
               </a:ext>
             </a:extLst>
           </p:cNvPr>
@@ -7439,7 +7440,7 @@
           <p:cNvPr id="8" name="Textfeld 7">
             <a:extLst>
               <a:ext uri="{FF2B5EF4-FFF2-40B4-BE49-F238E27FC236}">
-                <a16:creationId xmlns:a16="http://schemas.microsoft.com/office/drawing/2014/main" id="{B20CB149-0293-FC68-00F5-547F5700396D}"/>
+                <a16:creationId xmlns:a16="http://schemas.microsoft.com/office/drawing/2014/main" id="{A3D629B9-EC8E-3C37-2BF2-CA3470DB8AE3}"/>
               </a:ext>
             </a:extLst>
           </p:cNvPr>
@@ -7479,7 +7480,7 @@
           <p:cNvPr id="9" name="Textfeld 8">
             <a:extLst>
               <a:ext uri="{FF2B5EF4-FFF2-40B4-BE49-F238E27FC236}">
-                <a16:creationId xmlns:a16="http://schemas.microsoft.com/office/drawing/2014/main" id="{0766B0D9-F9C2-E81C-CA03-357272AD0878}"/>
+                <a16:creationId xmlns:a16="http://schemas.microsoft.com/office/drawing/2014/main" id="{FC23B5CC-437A-EBEF-0469-4AFF612FED0B}"/>
               </a:ext>
             </a:extLst>
           </p:cNvPr>
@@ -7519,7 +7520,7 @@
           <p:cNvPr id="10" name="Textfeld 9">
             <a:extLst>
               <a:ext uri="{FF2B5EF4-FFF2-40B4-BE49-F238E27FC236}">
-                <a16:creationId xmlns:a16="http://schemas.microsoft.com/office/drawing/2014/main" id="{D5768F7A-905E-2785-E8E1-2E26CF0A58C8}"/>
+                <a16:creationId xmlns:a16="http://schemas.microsoft.com/office/drawing/2014/main" id="{8C588723-CBBD-5245-A34D-E26D5DE96D22}"/>
               </a:ext>
             </a:extLst>
           </p:cNvPr>
@@ -7559,7 +7560,7 @@
           <p:cNvPr id="11" name="Textfeld 10">
             <a:extLst>
               <a:ext uri="{FF2B5EF4-FFF2-40B4-BE49-F238E27FC236}">
-                <a16:creationId xmlns:a16="http://schemas.microsoft.com/office/drawing/2014/main" id="{4B3BE0A7-4200-38C2-6F42-143D20E75AB8}"/>
+                <a16:creationId xmlns:a16="http://schemas.microsoft.com/office/drawing/2014/main" id="{C01818D2-6DEB-A9C6-1CE8-40E503F37AD1}"/>
               </a:ext>
             </a:extLst>
           </p:cNvPr>
@@ -7599,7 +7600,7 @@
           <p:cNvPr id="12" name="Textfeld 11">
             <a:extLst>
               <a:ext uri="{FF2B5EF4-FFF2-40B4-BE49-F238E27FC236}">
-                <a16:creationId xmlns:a16="http://schemas.microsoft.com/office/drawing/2014/main" id="{EF807938-5052-DC9E-C663-F6C58EB157DE}"/>
+                <a16:creationId xmlns:a16="http://schemas.microsoft.com/office/drawing/2014/main" id="{F686D23B-32ED-9EF6-3D89-14CD0ADD1CE4}"/>
               </a:ext>
             </a:extLst>
           </p:cNvPr>
@@ -7639,7 +7640,7 @@
           <p:cNvPr id="13" name="Textfeld 12">
             <a:extLst>
               <a:ext uri="{FF2B5EF4-FFF2-40B4-BE49-F238E27FC236}">
-                <a16:creationId xmlns:a16="http://schemas.microsoft.com/office/drawing/2014/main" id="{54C32963-2270-7FEE-B035-DAA761503DE3}"/>
+                <a16:creationId xmlns:a16="http://schemas.microsoft.com/office/drawing/2014/main" id="{5B51F7C3-59B3-735C-9E4E-5B36B50AEDC9}"/>
               </a:ext>
             </a:extLst>
           </p:cNvPr>
@@ -7679,7 +7680,7 @@
           <p:cNvPr id="14" name="Textfeld 13">
             <a:extLst>
               <a:ext uri="{FF2B5EF4-FFF2-40B4-BE49-F238E27FC236}">
-                <a16:creationId xmlns:a16="http://schemas.microsoft.com/office/drawing/2014/main" id="{0E51E4DB-1CC8-53E5-C766-808479CCA1B7}"/>
+                <a16:creationId xmlns:a16="http://schemas.microsoft.com/office/drawing/2014/main" id="{4A9C6633-71E9-9EBC-E0F7-648E71A1C376}"/>
               </a:ext>
             </a:extLst>
           </p:cNvPr>
@@ -7719,7 +7720,7 @@
           <p:cNvPr id="15" name="Textfeld 14">
             <a:extLst>
               <a:ext uri="{FF2B5EF4-FFF2-40B4-BE49-F238E27FC236}">
-                <a16:creationId xmlns:a16="http://schemas.microsoft.com/office/drawing/2014/main" id="{C108BCDC-8B4E-19EA-BA50-A72AD1991105}"/>
+                <a16:creationId xmlns:a16="http://schemas.microsoft.com/office/drawing/2014/main" id="{AE1E7FA3-B396-DBEA-DB8A-3364120BACC4}"/>
               </a:ext>
             </a:extLst>
           </p:cNvPr>
@@ -7759,7 +7760,7 @@
           <p:cNvPr id="16" name="Textfeld 15">
             <a:extLst>
               <a:ext uri="{FF2B5EF4-FFF2-40B4-BE49-F238E27FC236}">
-                <a16:creationId xmlns:a16="http://schemas.microsoft.com/office/drawing/2014/main" id="{A6BB9B09-3AAF-C298-2C66-44235A5E1366}"/>
+                <a16:creationId xmlns:a16="http://schemas.microsoft.com/office/drawing/2014/main" id="{11314F8E-5371-091D-0B81-FE2D2311EC49}"/>
               </a:ext>
             </a:extLst>
           </p:cNvPr>
@@ -7799,7 +7800,7 @@
           <p:cNvPr id="17" name="Textfeld 16">
             <a:extLst>
               <a:ext uri="{FF2B5EF4-FFF2-40B4-BE49-F238E27FC236}">
-                <a16:creationId xmlns:a16="http://schemas.microsoft.com/office/drawing/2014/main" id="{63EB19A7-EB87-2A41-6C0F-E40C2F21FCAE}"/>
+                <a16:creationId xmlns:a16="http://schemas.microsoft.com/office/drawing/2014/main" id="{C73D60F6-8D4F-E0CB-9C82-FC3FE31621E1}"/>
               </a:ext>
             </a:extLst>
           </p:cNvPr>
@@ -7839,7 +7840,7 @@
           <p:cNvPr id="18" name="Textfeld 17">
             <a:extLst>
               <a:ext uri="{FF2B5EF4-FFF2-40B4-BE49-F238E27FC236}">
-                <a16:creationId xmlns:a16="http://schemas.microsoft.com/office/drawing/2014/main" id="{C169948B-05A4-6049-4597-8C8DC844C3BB}"/>
+                <a16:creationId xmlns:a16="http://schemas.microsoft.com/office/drawing/2014/main" id="{85F11760-5A80-D601-A44D-B15502D5192C}"/>
               </a:ext>
             </a:extLst>
           </p:cNvPr>
@@ -7879,7 +7880,7 @@
           <p:cNvPr id="19" name="Textfeld 18">
             <a:extLst>
               <a:ext uri="{FF2B5EF4-FFF2-40B4-BE49-F238E27FC236}">
-                <a16:creationId xmlns:a16="http://schemas.microsoft.com/office/drawing/2014/main" id="{9933FD26-642D-D5CC-2892-F688AD93E45D}"/>
+                <a16:creationId xmlns:a16="http://schemas.microsoft.com/office/drawing/2014/main" id="{F4417F0D-F89B-7852-1467-96B7316458D6}"/>
               </a:ext>
             </a:extLst>
           </p:cNvPr>
@@ -7919,7 +7920,7 @@
           <p:cNvPr id="20" name="Textfeld 19">
             <a:extLst>
               <a:ext uri="{FF2B5EF4-FFF2-40B4-BE49-F238E27FC236}">
-                <a16:creationId xmlns:a16="http://schemas.microsoft.com/office/drawing/2014/main" id="{601578E3-3902-3C70-C351-3911D1F296E7}"/>
+                <a16:creationId xmlns:a16="http://schemas.microsoft.com/office/drawing/2014/main" id="{9EA8EE17-A459-7E72-F5E6-7E8AF2CF3732}"/>
               </a:ext>
             </a:extLst>
           </p:cNvPr>
@@ -7959,7 +7960,7 @@
           <p:cNvPr id="21" name="Textfeld 20">
             <a:extLst>
               <a:ext uri="{FF2B5EF4-FFF2-40B4-BE49-F238E27FC236}">
-                <a16:creationId xmlns:a16="http://schemas.microsoft.com/office/drawing/2014/main" id="{9C53D2DB-CA74-A3AF-83CC-866400742C57}"/>
+                <a16:creationId xmlns:a16="http://schemas.microsoft.com/office/drawing/2014/main" id="{BF792376-C2DF-2FC0-8DC2-20BF16475865}"/>
               </a:ext>
             </a:extLst>
           </p:cNvPr>
@@ -7999,7 +8000,7 @@
           <p:cNvPr id="22" name="Textfeld 21">
             <a:extLst>
               <a:ext uri="{FF2B5EF4-FFF2-40B4-BE49-F238E27FC236}">
-                <a16:creationId xmlns:a16="http://schemas.microsoft.com/office/drawing/2014/main" id="{1EAE0D5B-7968-C166-88FD-7894DD274BEC}"/>
+                <a16:creationId xmlns:a16="http://schemas.microsoft.com/office/drawing/2014/main" id="{72CFB51F-E2B2-9659-B1B0-D45194D51BB0}"/>
               </a:ext>
             </a:extLst>
           </p:cNvPr>
@@ -8039,7 +8040,7 @@
           <p:cNvPr id="23" name="Textfeld 22">
             <a:extLst>
               <a:ext uri="{FF2B5EF4-FFF2-40B4-BE49-F238E27FC236}">
-                <a16:creationId xmlns:a16="http://schemas.microsoft.com/office/drawing/2014/main" id="{827AC5ED-54D7-CB20-B71B-B5FC9565E56D}"/>
+                <a16:creationId xmlns:a16="http://schemas.microsoft.com/office/drawing/2014/main" id="{BE5BE570-06F3-8322-8DB6-4652E91DCF27}"/>
               </a:ext>
             </a:extLst>
           </p:cNvPr>
@@ -8079,7 +8080,7 @@
           <p:cNvPr id="24" name="Textfeld 23">
             <a:extLst>
               <a:ext uri="{FF2B5EF4-FFF2-40B4-BE49-F238E27FC236}">
-                <a16:creationId xmlns:a16="http://schemas.microsoft.com/office/drawing/2014/main" id="{9D628EEB-EA6E-7C15-CECF-CF0D86E82189}"/>
+                <a16:creationId xmlns:a16="http://schemas.microsoft.com/office/drawing/2014/main" id="{FC14C78E-57C4-CED3-D0EC-C2563334640E}"/>
               </a:ext>
             </a:extLst>
           </p:cNvPr>
@@ -8119,7 +8120,7 @@
           <p:cNvPr id="25" name="Textfeld 24">
             <a:extLst>
               <a:ext uri="{FF2B5EF4-FFF2-40B4-BE49-F238E27FC236}">
-                <a16:creationId xmlns:a16="http://schemas.microsoft.com/office/drawing/2014/main" id="{804E3185-7254-F7CF-1723-1961298499D6}"/>
+                <a16:creationId xmlns:a16="http://schemas.microsoft.com/office/drawing/2014/main" id="{32A44D71-438C-BA19-F41C-A507815851F8}"/>
               </a:ext>
             </a:extLst>
           </p:cNvPr>
@@ -8159,7 +8160,7 @@
           <p:cNvPr id="26" name="Textfeld 25">
             <a:extLst>
               <a:ext uri="{FF2B5EF4-FFF2-40B4-BE49-F238E27FC236}">
-                <a16:creationId xmlns:a16="http://schemas.microsoft.com/office/drawing/2014/main" id="{C8528001-06EA-F3EB-754F-234DC83D8308}"/>
+                <a16:creationId xmlns:a16="http://schemas.microsoft.com/office/drawing/2014/main" id="{9A3996A8-CB39-09DF-9C23-A6FB5ADB7F24}"/>
               </a:ext>
             </a:extLst>
           </p:cNvPr>
@@ -8199,7 +8200,7 @@
           <p:cNvPr id="27" name="Textfeld 26">
             <a:extLst>
               <a:ext uri="{FF2B5EF4-FFF2-40B4-BE49-F238E27FC236}">
-                <a16:creationId xmlns:a16="http://schemas.microsoft.com/office/drawing/2014/main" id="{D2D9F32A-DC2C-6DBF-6A8B-E27288F0A57F}"/>
+                <a16:creationId xmlns:a16="http://schemas.microsoft.com/office/drawing/2014/main" id="{1F9723E5-331F-8838-FB21-1075948DD44C}"/>
               </a:ext>
             </a:extLst>
           </p:cNvPr>
@@ -8239,7 +8240,7 @@
           <p:cNvPr id="28" name="Textfeld 27">
             <a:extLst>
               <a:ext uri="{FF2B5EF4-FFF2-40B4-BE49-F238E27FC236}">
-                <a16:creationId xmlns:a16="http://schemas.microsoft.com/office/drawing/2014/main" id="{F1EE70FF-536F-B0E9-F962-B10AA746FD0D}"/>
+                <a16:creationId xmlns:a16="http://schemas.microsoft.com/office/drawing/2014/main" id="{734AA603-B518-C2CD-337E-1899D5853DAA}"/>
               </a:ext>
             </a:extLst>
           </p:cNvPr>
@@ -8279,7 +8280,7 @@
           <p:cNvPr id="29" name="Textfeld 28">
             <a:extLst>
               <a:ext uri="{FF2B5EF4-FFF2-40B4-BE49-F238E27FC236}">
-                <a16:creationId xmlns:a16="http://schemas.microsoft.com/office/drawing/2014/main" id="{F497D80A-22E0-81A8-CECE-99468C57463E}"/>
+                <a16:creationId xmlns:a16="http://schemas.microsoft.com/office/drawing/2014/main" id="{3E9310CD-3FE0-E07F-E14A-00F2A2AD77A9}"/>
               </a:ext>
             </a:extLst>
           </p:cNvPr>
@@ -8319,7 +8320,7 @@
           <p:cNvPr id="30" name="Textfeld 29">
             <a:extLst>
               <a:ext uri="{FF2B5EF4-FFF2-40B4-BE49-F238E27FC236}">
-                <a16:creationId xmlns:a16="http://schemas.microsoft.com/office/drawing/2014/main" id="{0E1DB27D-B864-B569-29F1-3CAB6AF7C0D6}"/>
+                <a16:creationId xmlns:a16="http://schemas.microsoft.com/office/drawing/2014/main" id="{C8F304CC-E6F1-3D69-AA9A-155D692E8B2F}"/>
               </a:ext>
             </a:extLst>
           </p:cNvPr>
@@ -8359,7 +8360,7 @@
           <p:cNvPr id="31" name="Textfeld 30">
             <a:extLst>
               <a:ext uri="{FF2B5EF4-FFF2-40B4-BE49-F238E27FC236}">
-                <a16:creationId xmlns:a16="http://schemas.microsoft.com/office/drawing/2014/main" id="{0A332985-77CF-FAC0-E947-2E94CA1D8204}"/>
+                <a16:creationId xmlns:a16="http://schemas.microsoft.com/office/drawing/2014/main" id="{E8EEB188-E944-E040-D123-5B472FCF2F7A}"/>
               </a:ext>
             </a:extLst>
           </p:cNvPr>
@@ -8399,7 +8400,7 @@
           <p:cNvPr id="32" name="Textfeld 31">
             <a:extLst>
               <a:ext uri="{FF2B5EF4-FFF2-40B4-BE49-F238E27FC236}">
-                <a16:creationId xmlns:a16="http://schemas.microsoft.com/office/drawing/2014/main" id="{E56F69E1-2268-237E-0D96-C6DFC0B29C34}"/>
+                <a16:creationId xmlns:a16="http://schemas.microsoft.com/office/drawing/2014/main" id="{218ECC83-CE1C-4A46-162F-5B2E7C31BEA9}"/>
               </a:ext>
             </a:extLst>
           </p:cNvPr>
@@ -8439,7 +8440,7 @@
           <p:cNvPr id="33" name="Textfeld 32">
             <a:extLst>
               <a:ext uri="{FF2B5EF4-FFF2-40B4-BE49-F238E27FC236}">
-                <a16:creationId xmlns:a16="http://schemas.microsoft.com/office/drawing/2014/main" id="{3E476448-9163-4165-A5CF-A0C5BA8707D1}"/>
+                <a16:creationId xmlns:a16="http://schemas.microsoft.com/office/drawing/2014/main" id="{A77340D5-5D70-D502-C5DE-D053466C2C18}"/>
               </a:ext>
             </a:extLst>
           </p:cNvPr>
@@ -8479,7 +8480,7 @@
           <p:cNvPr id="34" name="Textfeld 33">
             <a:extLst>
               <a:ext uri="{FF2B5EF4-FFF2-40B4-BE49-F238E27FC236}">
-                <a16:creationId xmlns:a16="http://schemas.microsoft.com/office/drawing/2014/main" id="{92346A08-D9D3-A780-7BF8-293E163E9363}"/>
+                <a16:creationId xmlns:a16="http://schemas.microsoft.com/office/drawing/2014/main" id="{4C69F67E-E902-3DE9-897F-908D5C376E50}"/>
               </a:ext>
             </a:extLst>
           </p:cNvPr>
@@ -8519,7 +8520,7 @@
           <p:cNvPr id="35" name="Textfeld 34">
             <a:extLst>
               <a:ext uri="{FF2B5EF4-FFF2-40B4-BE49-F238E27FC236}">
-                <a16:creationId xmlns:a16="http://schemas.microsoft.com/office/drawing/2014/main" id="{F79ED12D-BDF6-2F1E-C7BA-EA0B5869DCE4}"/>
+                <a16:creationId xmlns:a16="http://schemas.microsoft.com/office/drawing/2014/main" id="{0E35114A-620A-6F62-AD23-83B2D8258CDC}"/>
               </a:ext>
             </a:extLst>
           </p:cNvPr>
@@ -8559,7 +8560,7 @@
           <p:cNvPr id="36" name="Textfeld 35">
             <a:extLst>
               <a:ext uri="{FF2B5EF4-FFF2-40B4-BE49-F238E27FC236}">
-                <a16:creationId xmlns:a16="http://schemas.microsoft.com/office/drawing/2014/main" id="{104FECF1-52DB-3FFA-BC60-F59A3BFA0DDD}"/>
+                <a16:creationId xmlns:a16="http://schemas.microsoft.com/office/drawing/2014/main" id="{B8C81882-C86C-5C59-F6A4-508EC4383145}"/>
               </a:ext>
             </a:extLst>
           </p:cNvPr>
@@ -8599,7 +8600,7 @@
           <p:cNvPr id="37" name="Textfeld 36">
             <a:extLst>
               <a:ext uri="{FF2B5EF4-FFF2-40B4-BE49-F238E27FC236}">
-                <a16:creationId xmlns:a16="http://schemas.microsoft.com/office/drawing/2014/main" id="{C653563A-09F9-0AA7-11D4-11CABE303084}"/>
+                <a16:creationId xmlns:a16="http://schemas.microsoft.com/office/drawing/2014/main" id="{EA0D4DF5-6716-4E16-A856-668B82A9C42A}"/>
               </a:ext>
             </a:extLst>
           </p:cNvPr>
@@ -8639,7 +8640,7 @@
           <p:cNvPr id="38" name="Textfeld 37">
             <a:extLst>
               <a:ext uri="{FF2B5EF4-FFF2-40B4-BE49-F238E27FC236}">
-                <a16:creationId xmlns:a16="http://schemas.microsoft.com/office/drawing/2014/main" id="{C94C817F-2DA5-E66D-27A9-2243C825170E}"/>
+                <a16:creationId xmlns:a16="http://schemas.microsoft.com/office/drawing/2014/main" id="{F87CEFD3-183B-6805-34FF-8BE53D0B496E}"/>
               </a:ext>
             </a:extLst>
           </p:cNvPr>
@@ -8679,7 +8680,7 @@
           <p:cNvPr id="39" name="Textfeld 38">
             <a:extLst>
               <a:ext uri="{FF2B5EF4-FFF2-40B4-BE49-F238E27FC236}">
-                <a16:creationId xmlns:a16="http://schemas.microsoft.com/office/drawing/2014/main" id="{7F86961F-2C16-CE70-F6ED-3E5F746CB634}"/>
+                <a16:creationId xmlns:a16="http://schemas.microsoft.com/office/drawing/2014/main" id="{07C6BFC1-942B-E083-800A-93A86F4CE343}"/>
               </a:ext>
             </a:extLst>
           </p:cNvPr>
@@ -8719,7 +8720,7 @@
           <p:cNvPr id="40" name="Textfeld 39">
             <a:extLst>
               <a:ext uri="{FF2B5EF4-FFF2-40B4-BE49-F238E27FC236}">
-                <a16:creationId xmlns:a16="http://schemas.microsoft.com/office/drawing/2014/main" id="{528D9735-FE9B-BB7D-48E8-4C215A257699}"/>
+                <a16:creationId xmlns:a16="http://schemas.microsoft.com/office/drawing/2014/main" id="{6BB56C78-146B-9406-4825-0992C9FD8097}"/>
               </a:ext>
             </a:extLst>
           </p:cNvPr>
@@ -8759,7 +8760,7 @@
           <p:cNvPr id="41" name="Textfeld 40">
             <a:extLst>
               <a:ext uri="{FF2B5EF4-FFF2-40B4-BE49-F238E27FC236}">
-                <a16:creationId xmlns:a16="http://schemas.microsoft.com/office/drawing/2014/main" id="{AC15531C-0D56-13A9-8D99-0097F101565A}"/>
+                <a16:creationId xmlns:a16="http://schemas.microsoft.com/office/drawing/2014/main" id="{018E0234-EEAC-F84E-6E60-368B948A6F11}"/>
               </a:ext>
             </a:extLst>
           </p:cNvPr>
@@ -8799,7 +8800,7 @@
           <p:cNvPr id="42" name="Textfeld 41">
             <a:extLst>
               <a:ext uri="{FF2B5EF4-FFF2-40B4-BE49-F238E27FC236}">
-                <a16:creationId xmlns:a16="http://schemas.microsoft.com/office/drawing/2014/main" id="{EF508353-71FE-E1E4-7EA3-1D27F6747B81}"/>
+                <a16:creationId xmlns:a16="http://schemas.microsoft.com/office/drawing/2014/main" id="{886C26E9-264E-2B64-0901-1D7A4979B5B8}"/>
               </a:ext>
             </a:extLst>
           </p:cNvPr>
@@ -8839,7 +8840,7 @@
           <p:cNvPr id="43" name="Textfeld 42">
             <a:extLst>
               <a:ext uri="{FF2B5EF4-FFF2-40B4-BE49-F238E27FC236}">
-                <a16:creationId xmlns:a16="http://schemas.microsoft.com/office/drawing/2014/main" id="{DD6F0FF0-5DA1-2465-2D29-CEC8E67449EC}"/>
+                <a16:creationId xmlns:a16="http://schemas.microsoft.com/office/drawing/2014/main" id="{E1D90C8F-9750-B461-1132-C8F37747AA56}"/>
               </a:ext>
             </a:extLst>
           </p:cNvPr>
@@ -8879,7 +8880,7 @@
           <p:cNvPr id="44" name="Textfeld 43">
             <a:extLst>
               <a:ext uri="{FF2B5EF4-FFF2-40B4-BE49-F238E27FC236}">
-                <a16:creationId xmlns:a16="http://schemas.microsoft.com/office/drawing/2014/main" id="{4D5C39B5-A43A-2BC9-F79B-DCCEE5E589E6}"/>
+                <a16:creationId xmlns:a16="http://schemas.microsoft.com/office/drawing/2014/main" id="{402CF180-A3C6-3110-6B15-84C50B0A44F2}"/>
               </a:ext>
             </a:extLst>
           </p:cNvPr>
@@ -8919,7 +8920,7 @@
           <p:cNvPr id="45" name="Textfeld 44">
             <a:extLst>
               <a:ext uri="{FF2B5EF4-FFF2-40B4-BE49-F238E27FC236}">
-                <a16:creationId xmlns:a16="http://schemas.microsoft.com/office/drawing/2014/main" id="{16B92664-BD7E-ECD1-26C8-DF543D51342D}"/>
+                <a16:creationId xmlns:a16="http://schemas.microsoft.com/office/drawing/2014/main" id="{E9E31742-CE9D-D9CE-CCE9-5EA1F7880C14}"/>
               </a:ext>
             </a:extLst>
           </p:cNvPr>
@@ -8959,7 +8960,7 @@
           <p:cNvPr id="46" name="Textfeld 45">
             <a:extLst>
               <a:ext uri="{FF2B5EF4-FFF2-40B4-BE49-F238E27FC236}">
-                <a16:creationId xmlns:a16="http://schemas.microsoft.com/office/drawing/2014/main" id="{1CDFDDBD-0CF6-6014-2E31-E6A5E8218DAA}"/>
+                <a16:creationId xmlns:a16="http://schemas.microsoft.com/office/drawing/2014/main" id="{E06D545A-D541-8DF9-3241-ECD0957C48E9}"/>
               </a:ext>
             </a:extLst>
           </p:cNvPr>
@@ -8999,7 +9000,7 @@
           <p:cNvPr id="47" name="Textfeld 46">
             <a:extLst>
               <a:ext uri="{FF2B5EF4-FFF2-40B4-BE49-F238E27FC236}">
-                <a16:creationId xmlns:a16="http://schemas.microsoft.com/office/drawing/2014/main" id="{0239E8FB-77A9-AEF2-1AD1-37224109BA5B}"/>
+                <a16:creationId xmlns:a16="http://schemas.microsoft.com/office/drawing/2014/main" id="{0D100392-D001-A1FF-783E-A5E917D3FBF7}"/>
               </a:ext>
             </a:extLst>
           </p:cNvPr>
@@ -9039,7 +9040,7 @@
           <p:cNvPr id="48" name="Textfeld 47">
             <a:extLst>
               <a:ext uri="{FF2B5EF4-FFF2-40B4-BE49-F238E27FC236}">
-                <a16:creationId xmlns:a16="http://schemas.microsoft.com/office/drawing/2014/main" id="{9F77CD82-83B1-59D5-25F2-2BB2FFA2A3DA}"/>
+                <a16:creationId xmlns:a16="http://schemas.microsoft.com/office/drawing/2014/main" id="{2A90F798-87C1-6B75-373E-B72BABDAC8F7}"/>
               </a:ext>
             </a:extLst>
           </p:cNvPr>
@@ -9079,7 +9080,7 @@
           <p:cNvPr id="49" name="Textfeld 48">
             <a:extLst>
               <a:ext uri="{FF2B5EF4-FFF2-40B4-BE49-F238E27FC236}">
-                <a16:creationId xmlns:a16="http://schemas.microsoft.com/office/drawing/2014/main" id="{1D0F8F9E-569A-3D57-A623-BB99709382FE}"/>
+                <a16:creationId xmlns:a16="http://schemas.microsoft.com/office/drawing/2014/main" id="{9C533625-519C-0974-5897-FE550025F47D}"/>
               </a:ext>
             </a:extLst>
           </p:cNvPr>
@@ -9119,7 +9120,7 @@
           <p:cNvPr id="50" name="Textfeld 49">
             <a:extLst>
               <a:ext uri="{FF2B5EF4-FFF2-40B4-BE49-F238E27FC236}">
-                <a16:creationId xmlns:a16="http://schemas.microsoft.com/office/drawing/2014/main" id="{2349861D-EC9D-CCE7-4862-7101780ACF4E}"/>
+                <a16:creationId xmlns:a16="http://schemas.microsoft.com/office/drawing/2014/main" id="{7D006F64-CF8A-9DC0-C7DD-A9386F57CC36}"/>
               </a:ext>
             </a:extLst>
           </p:cNvPr>
@@ -9159,7 +9160,7 @@
           <p:cNvPr id="51" name="Textfeld 50">
             <a:extLst>
               <a:ext uri="{FF2B5EF4-FFF2-40B4-BE49-F238E27FC236}">
-                <a16:creationId xmlns:a16="http://schemas.microsoft.com/office/drawing/2014/main" id="{DE0291BF-E249-9F51-9968-23F6F5862B3B}"/>
+                <a16:creationId xmlns:a16="http://schemas.microsoft.com/office/drawing/2014/main" id="{CEA6B965-D2C1-0481-08CC-21A6978B0378}"/>
               </a:ext>
             </a:extLst>
           </p:cNvPr>
@@ -9199,7 +9200,7 @@
           <p:cNvPr id="52" name="Textfeld 51">
             <a:extLst>
               <a:ext uri="{FF2B5EF4-FFF2-40B4-BE49-F238E27FC236}">
-                <a16:creationId xmlns:a16="http://schemas.microsoft.com/office/drawing/2014/main" id="{5F4CAFD4-0F30-0568-803B-976300DF76C4}"/>
+                <a16:creationId xmlns:a16="http://schemas.microsoft.com/office/drawing/2014/main" id="{8AFA2E00-14F6-7BCF-C0BC-F96909D53FEF}"/>
               </a:ext>
             </a:extLst>
           </p:cNvPr>
@@ -9239,7 +9240,7 @@
           <p:cNvPr id="53" name="Textfeld 52">
             <a:extLst>
               <a:ext uri="{FF2B5EF4-FFF2-40B4-BE49-F238E27FC236}">
-                <a16:creationId xmlns:a16="http://schemas.microsoft.com/office/drawing/2014/main" id="{65BB7DF2-C6D2-420D-1F05-AF95848231A1}"/>
+                <a16:creationId xmlns:a16="http://schemas.microsoft.com/office/drawing/2014/main" id="{1D4428EE-81F4-2977-65CD-4D9FC39FB1B3}"/>
               </a:ext>
             </a:extLst>
           </p:cNvPr>
@@ -9279,7 +9280,7 @@
           <p:cNvPr id="54" name="Textfeld 53">
             <a:extLst>
               <a:ext uri="{FF2B5EF4-FFF2-40B4-BE49-F238E27FC236}">
-                <a16:creationId xmlns:a16="http://schemas.microsoft.com/office/drawing/2014/main" id="{FD1F518E-9737-3ECA-C55F-AEAEAF5ECD5D}"/>
+                <a16:creationId xmlns:a16="http://schemas.microsoft.com/office/drawing/2014/main" id="{F7EC18CD-26C1-E9B2-61A6-82FF7776AE59}"/>
               </a:ext>
             </a:extLst>
           </p:cNvPr>
@@ -9319,7 +9320,7 @@
           <p:cNvPr id="55" name="Textfeld 54">
             <a:extLst>
               <a:ext uri="{FF2B5EF4-FFF2-40B4-BE49-F238E27FC236}">
-                <a16:creationId xmlns:a16="http://schemas.microsoft.com/office/drawing/2014/main" id="{D738EC7A-BFA6-3187-F7B7-56448260D7D2}"/>
+                <a16:creationId xmlns:a16="http://schemas.microsoft.com/office/drawing/2014/main" id="{10A14169-3F3C-7A64-D423-9A7F843D3111}"/>
               </a:ext>
             </a:extLst>
           </p:cNvPr>
@@ -9359,7 +9360,7 @@
           <p:cNvPr id="56" name="Textfeld 55">
             <a:extLst>
               <a:ext uri="{FF2B5EF4-FFF2-40B4-BE49-F238E27FC236}">
-                <a16:creationId xmlns:a16="http://schemas.microsoft.com/office/drawing/2014/main" id="{742B6E01-B1D5-631D-7E85-91BB6A273047}"/>
+                <a16:creationId xmlns:a16="http://schemas.microsoft.com/office/drawing/2014/main" id="{9B3BB2F1-868A-6088-A799-2FCCB81B4694}"/>
               </a:ext>
             </a:extLst>
           </p:cNvPr>
@@ -9399,7 +9400,7 @@
           <p:cNvPr id="57" name="Textfeld 56">
             <a:extLst>
               <a:ext uri="{FF2B5EF4-FFF2-40B4-BE49-F238E27FC236}">
-                <a16:creationId xmlns:a16="http://schemas.microsoft.com/office/drawing/2014/main" id="{C403A20D-7ED5-411B-8712-06554755569B}"/>
+                <a16:creationId xmlns:a16="http://schemas.microsoft.com/office/drawing/2014/main" id="{4A7373E6-29DF-4344-51BB-765DC02D294E}"/>
               </a:ext>
             </a:extLst>
           </p:cNvPr>
@@ -9439,7 +9440,7 @@
           <p:cNvPr id="58" name="Textfeld 57">
             <a:extLst>
               <a:ext uri="{FF2B5EF4-FFF2-40B4-BE49-F238E27FC236}">
-                <a16:creationId xmlns:a16="http://schemas.microsoft.com/office/drawing/2014/main" id="{159C6C40-AC9D-BDD8-21DB-B57D5961128F}"/>
+                <a16:creationId xmlns:a16="http://schemas.microsoft.com/office/drawing/2014/main" id="{5ECDD84A-CD4B-3104-AE18-B77DF599FDC3}"/>
               </a:ext>
             </a:extLst>
           </p:cNvPr>
@@ -9479,7 +9480,7 @@
           <p:cNvPr id="59" name="Textfeld 58">
             <a:extLst>
               <a:ext uri="{FF2B5EF4-FFF2-40B4-BE49-F238E27FC236}">
-                <a16:creationId xmlns:a16="http://schemas.microsoft.com/office/drawing/2014/main" id="{E7FFA56B-D7E0-ACB8-0147-69B01C476EDB}"/>
+                <a16:creationId xmlns:a16="http://schemas.microsoft.com/office/drawing/2014/main" id="{93A23685-DDC7-3C12-8CAB-311B4651874C}"/>
               </a:ext>
             </a:extLst>
           </p:cNvPr>
@@ -9519,7 +9520,7 @@
           <p:cNvPr id="60" name="Textfeld 59">
             <a:extLst>
               <a:ext uri="{FF2B5EF4-FFF2-40B4-BE49-F238E27FC236}">
-                <a16:creationId xmlns:a16="http://schemas.microsoft.com/office/drawing/2014/main" id="{127F6AB1-0395-C314-2006-9821E2CECBC9}"/>
+                <a16:creationId xmlns:a16="http://schemas.microsoft.com/office/drawing/2014/main" id="{FAAA7D55-2044-483C-5C66-7743BA7C766F}"/>
               </a:ext>
             </a:extLst>
           </p:cNvPr>
@@ -9559,7 +9560,7 @@
           <p:cNvPr id="61" name="Textfeld 60">
             <a:extLst>
               <a:ext uri="{FF2B5EF4-FFF2-40B4-BE49-F238E27FC236}">
-                <a16:creationId xmlns:a16="http://schemas.microsoft.com/office/drawing/2014/main" id="{CDC8D882-24F1-25AA-3B24-B0C4D0C5BB99}"/>
+                <a16:creationId xmlns:a16="http://schemas.microsoft.com/office/drawing/2014/main" id="{65C1FABE-2429-8FA2-FFDF-0A90AAE08C9D}"/>
               </a:ext>
             </a:extLst>
           </p:cNvPr>
@@ -9599,7 +9600,7 @@
           <p:cNvPr id="62" name="Textfeld 61">
             <a:extLst>
               <a:ext uri="{FF2B5EF4-FFF2-40B4-BE49-F238E27FC236}">
-                <a16:creationId xmlns:a16="http://schemas.microsoft.com/office/drawing/2014/main" id="{F6F6B8B1-0B89-BA88-FF01-1E0454D0495C}"/>
+                <a16:creationId xmlns:a16="http://schemas.microsoft.com/office/drawing/2014/main" id="{D21AEEED-2974-87E2-DE47-DFC0B885B6F4}"/>
               </a:ext>
             </a:extLst>
           </p:cNvPr>
@@ -9639,7 +9640,7 @@
           <p:cNvPr id="63" name="Textfeld 62">
             <a:extLst>
               <a:ext uri="{FF2B5EF4-FFF2-40B4-BE49-F238E27FC236}">
-                <a16:creationId xmlns:a16="http://schemas.microsoft.com/office/drawing/2014/main" id="{F0B1A556-4623-0814-3F7D-DA1A68F045E9}"/>
+                <a16:creationId xmlns:a16="http://schemas.microsoft.com/office/drawing/2014/main" id="{83DF6B89-1D92-5B9E-510C-445473F46754}"/>
               </a:ext>
             </a:extLst>
           </p:cNvPr>
@@ -9679,7 +9680,7 @@
           <p:cNvPr id="64" name="Textfeld 63">
             <a:extLst>
               <a:ext uri="{FF2B5EF4-FFF2-40B4-BE49-F238E27FC236}">
-                <a16:creationId xmlns:a16="http://schemas.microsoft.com/office/drawing/2014/main" id="{B352A9AF-E188-EFE8-BB4A-DB0469C7EADD}"/>
+                <a16:creationId xmlns:a16="http://schemas.microsoft.com/office/drawing/2014/main" id="{A8E2B276-82F9-82AC-ECE9-6D0F2FF43008}"/>
               </a:ext>
             </a:extLst>
           </p:cNvPr>
@@ -9719,7 +9720,7 @@
           <p:cNvPr id="65" name="Textfeld 64">
             <a:extLst>
               <a:ext uri="{FF2B5EF4-FFF2-40B4-BE49-F238E27FC236}">
-                <a16:creationId xmlns:a16="http://schemas.microsoft.com/office/drawing/2014/main" id="{CEA587EE-E6ED-AB20-39C4-11DDFDAE0C52}"/>
+                <a16:creationId xmlns:a16="http://schemas.microsoft.com/office/drawing/2014/main" id="{3F07A8A4-6AD2-780E-6862-263DFA364928}"/>
               </a:ext>
             </a:extLst>
           </p:cNvPr>
@@ -9759,7 +9760,7 @@
           <p:cNvPr id="66" name="Textfeld 65">
             <a:extLst>
               <a:ext uri="{FF2B5EF4-FFF2-40B4-BE49-F238E27FC236}">
-                <a16:creationId xmlns:a16="http://schemas.microsoft.com/office/drawing/2014/main" id="{F2AC9376-7FBB-1221-8C19-F5EF03AA2407}"/>
+                <a16:creationId xmlns:a16="http://schemas.microsoft.com/office/drawing/2014/main" id="{A6EEE8B3-B605-2B94-CB54-AABAFDB5CFFB}"/>
               </a:ext>
             </a:extLst>
           </p:cNvPr>
@@ -9799,7 +9800,7 @@
           <p:cNvPr id="67" name="Textfeld 66">
             <a:extLst>
               <a:ext uri="{FF2B5EF4-FFF2-40B4-BE49-F238E27FC236}">
-                <a16:creationId xmlns:a16="http://schemas.microsoft.com/office/drawing/2014/main" id="{18629E27-C2EA-F635-B4CA-D5479E42AB10}"/>
+                <a16:creationId xmlns:a16="http://schemas.microsoft.com/office/drawing/2014/main" id="{A3F778DE-DD78-E28E-01C0-086C078AAEFD}"/>
               </a:ext>
             </a:extLst>
           </p:cNvPr>
@@ -9839,7 +9840,7 @@
           <p:cNvPr id="68" name="Textfeld 67">
             <a:extLst>
               <a:ext uri="{FF2B5EF4-FFF2-40B4-BE49-F238E27FC236}">
-                <a16:creationId xmlns:a16="http://schemas.microsoft.com/office/drawing/2014/main" id="{32999882-183A-1DEA-A7E1-03CA47DBB9DB}"/>
+                <a16:creationId xmlns:a16="http://schemas.microsoft.com/office/drawing/2014/main" id="{4EB591A8-8940-C292-22F4-417D6EDD26D1}"/>
               </a:ext>
             </a:extLst>
           </p:cNvPr>
@@ -9879,7 +9880,7 @@
           <p:cNvPr id="69" name="Textfeld 68">
             <a:extLst>
               <a:ext uri="{FF2B5EF4-FFF2-40B4-BE49-F238E27FC236}">
-                <a16:creationId xmlns:a16="http://schemas.microsoft.com/office/drawing/2014/main" id="{0EF62488-5D62-DC96-9615-FEEA7B90F676}"/>
+                <a16:creationId xmlns:a16="http://schemas.microsoft.com/office/drawing/2014/main" id="{A16DA797-2DD6-8768-0FD5-C12660A93CD1}"/>
               </a:ext>
             </a:extLst>
           </p:cNvPr>
@@ -9919,7 +9920,7 @@
           <p:cNvPr id="70" name="Textfeld 69">
             <a:extLst>
               <a:ext uri="{FF2B5EF4-FFF2-40B4-BE49-F238E27FC236}">
-                <a16:creationId xmlns:a16="http://schemas.microsoft.com/office/drawing/2014/main" id="{0039D956-175F-F33E-8280-62F8E1336070}"/>
+                <a16:creationId xmlns:a16="http://schemas.microsoft.com/office/drawing/2014/main" id="{848EE71D-8989-7A2D-788C-C49238A5A90D}"/>
               </a:ext>
             </a:extLst>
           </p:cNvPr>
@@ -9959,7 +9960,7 @@
           <p:cNvPr id="71" name="Textfeld 70">
             <a:extLst>
               <a:ext uri="{FF2B5EF4-FFF2-40B4-BE49-F238E27FC236}">
-                <a16:creationId xmlns:a16="http://schemas.microsoft.com/office/drawing/2014/main" id="{691786BA-241C-CB71-3704-EDE484E231E3}"/>
+                <a16:creationId xmlns:a16="http://schemas.microsoft.com/office/drawing/2014/main" id="{2A87D7B4-8B0A-D1AE-C007-5AE0F34BDF45}"/>
               </a:ext>
             </a:extLst>
           </p:cNvPr>
@@ -9999,7 +10000,7 @@
           <p:cNvPr id="72" name="Textfeld 71">
             <a:extLst>
               <a:ext uri="{FF2B5EF4-FFF2-40B4-BE49-F238E27FC236}">
-                <a16:creationId xmlns:a16="http://schemas.microsoft.com/office/drawing/2014/main" id="{A03DC45A-17B4-331A-ABAB-1EEB11EB8230}"/>
+                <a16:creationId xmlns:a16="http://schemas.microsoft.com/office/drawing/2014/main" id="{6085458D-7E36-7B66-1AC2-DA12EF0B20DC}"/>
               </a:ext>
             </a:extLst>
           </p:cNvPr>
@@ -10039,7 +10040,7 @@
           <p:cNvPr id="73" name="Textfeld 72">
             <a:extLst>
               <a:ext uri="{FF2B5EF4-FFF2-40B4-BE49-F238E27FC236}">
-                <a16:creationId xmlns:a16="http://schemas.microsoft.com/office/drawing/2014/main" id="{85DFF1FC-A921-5C0D-A2BF-F65784214B44}"/>
+                <a16:creationId xmlns:a16="http://schemas.microsoft.com/office/drawing/2014/main" id="{9387ECD0-01DD-AAD7-20E2-4139AD4A4F49}"/>
               </a:ext>
             </a:extLst>
           </p:cNvPr>
@@ -10079,7 +10080,7 @@
           <p:cNvPr id="74" name="Textfeld 73">
             <a:extLst>
               <a:ext uri="{FF2B5EF4-FFF2-40B4-BE49-F238E27FC236}">
-                <a16:creationId xmlns:a16="http://schemas.microsoft.com/office/drawing/2014/main" id="{B881E3A9-5C21-1F8C-C8B8-2B3EA165BFC7}"/>
+                <a16:creationId xmlns:a16="http://schemas.microsoft.com/office/drawing/2014/main" id="{94D283A2-C84B-3BB1-8134-3997CD17B33C}"/>
               </a:ext>
             </a:extLst>
           </p:cNvPr>
@@ -10119,7 +10120,7 @@
           <p:cNvPr id="75" name="Textfeld 74">
             <a:extLst>
               <a:ext uri="{FF2B5EF4-FFF2-40B4-BE49-F238E27FC236}">
-                <a16:creationId xmlns:a16="http://schemas.microsoft.com/office/drawing/2014/main" id="{F31B9D5A-CF16-80B9-E4A7-8E51B1A65E80}"/>
+                <a16:creationId xmlns:a16="http://schemas.microsoft.com/office/drawing/2014/main" id="{56C8DE8F-89C9-4DFC-9F82-75D6C0E50012}"/>
               </a:ext>
             </a:extLst>
           </p:cNvPr>
@@ -10159,7 +10160,7 @@
           <p:cNvPr id="76" name="Textfeld 75">
             <a:extLst>
               <a:ext uri="{FF2B5EF4-FFF2-40B4-BE49-F238E27FC236}">
-                <a16:creationId xmlns:a16="http://schemas.microsoft.com/office/drawing/2014/main" id="{E13B246F-BA1A-5000-1935-1B32F3B26ABD}"/>
+                <a16:creationId xmlns:a16="http://schemas.microsoft.com/office/drawing/2014/main" id="{235C552C-6737-FA97-4534-610CBE57221D}"/>
               </a:ext>
             </a:extLst>
           </p:cNvPr>
@@ -10199,7 +10200,7 @@
           <p:cNvPr id="77" name="Textfeld 76">
             <a:extLst>
               <a:ext uri="{FF2B5EF4-FFF2-40B4-BE49-F238E27FC236}">
-                <a16:creationId xmlns:a16="http://schemas.microsoft.com/office/drawing/2014/main" id="{380C8146-27C6-67FD-2047-FFFEC4BE1951}"/>
+                <a16:creationId xmlns:a16="http://schemas.microsoft.com/office/drawing/2014/main" id="{81D59789-BB58-C7E0-E854-223A7D705CE3}"/>
               </a:ext>
             </a:extLst>
           </p:cNvPr>
@@ -10239,7 +10240,7 @@
           <p:cNvPr id="78" name="Textfeld 77">
             <a:extLst>
               <a:ext uri="{FF2B5EF4-FFF2-40B4-BE49-F238E27FC236}">
-                <a16:creationId xmlns:a16="http://schemas.microsoft.com/office/drawing/2014/main" id="{E6A4180B-D550-AEF7-63BD-F4FDCC759CF7}"/>
+                <a16:creationId xmlns:a16="http://schemas.microsoft.com/office/drawing/2014/main" id="{286223CB-15D7-F636-1FC1-6B8B4C24A92B}"/>
               </a:ext>
             </a:extLst>
           </p:cNvPr>
@@ -10279,7 +10280,7 @@
           <p:cNvPr id="79" name="Textfeld 78">
             <a:extLst>
               <a:ext uri="{FF2B5EF4-FFF2-40B4-BE49-F238E27FC236}">
-                <a16:creationId xmlns:a16="http://schemas.microsoft.com/office/drawing/2014/main" id="{2C681712-4FA8-5D65-06F9-20ED1A02138E}"/>
+                <a16:creationId xmlns:a16="http://schemas.microsoft.com/office/drawing/2014/main" id="{D4735C66-C693-DC5A-0BAA-2BF38B087FA2}"/>
               </a:ext>
             </a:extLst>
           </p:cNvPr>
@@ -10319,7 +10320,7 @@
           <p:cNvPr id="80" name="Textfeld 79">
             <a:extLst>
               <a:ext uri="{FF2B5EF4-FFF2-40B4-BE49-F238E27FC236}">
-                <a16:creationId xmlns:a16="http://schemas.microsoft.com/office/drawing/2014/main" id="{E81740BD-E30B-332E-2FD1-79071E76518F}"/>
+                <a16:creationId xmlns:a16="http://schemas.microsoft.com/office/drawing/2014/main" id="{8114A7EA-FC75-E368-86EE-82E354F15F08}"/>
               </a:ext>
             </a:extLst>
           </p:cNvPr>
@@ -10359,7 +10360,7 @@
           <p:cNvPr id="81" name="Textfeld 80">
             <a:extLst>
               <a:ext uri="{FF2B5EF4-FFF2-40B4-BE49-F238E27FC236}">
-                <a16:creationId xmlns:a16="http://schemas.microsoft.com/office/drawing/2014/main" id="{CA84D32C-91AB-56F5-0855-2F7BA648F4F8}"/>
+                <a16:creationId xmlns:a16="http://schemas.microsoft.com/office/drawing/2014/main" id="{0092B624-A52B-8868-2F7A-3A575BAAD655}"/>
               </a:ext>
             </a:extLst>
           </p:cNvPr>
@@ -10399,7 +10400,7 @@
           <p:cNvPr id="82" name="Textfeld 81">
             <a:extLst>
               <a:ext uri="{FF2B5EF4-FFF2-40B4-BE49-F238E27FC236}">
-                <a16:creationId xmlns:a16="http://schemas.microsoft.com/office/drawing/2014/main" id="{80339DB2-DB42-9CB6-1097-CAB363A6CE34}"/>
+                <a16:creationId xmlns:a16="http://schemas.microsoft.com/office/drawing/2014/main" id="{F53D9FE2-3ACB-C260-F17C-5AC78D69265D}"/>
               </a:ext>
             </a:extLst>
           </p:cNvPr>
@@ -10439,7 +10440,7 @@
           <p:cNvPr id="83" name="Textfeld 82">
             <a:extLst>
               <a:ext uri="{FF2B5EF4-FFF2-40B4-BE49-F238E27FC236}">
-                <a16:creationId xmlns:a16="http://schemas.microsoft.com/office/drawing/2014/main" id="{554BF0AC-973F-E30D-EB19-C69118E1D304}"/>
+                <a16:creationId xmlns:a16="http://schemas.microsoft.com/office/drawing/2014/main" id="{9A76D1DB-2B4D-9FE4-6015-377E541C3211}"/>
               </a:ext>
             </a:extLst>
           </p:cNvPr>
@@ -10479,7 +10480,7 @@
           <p:cNvPr id="84" name="Textfeld 83">
             <a:extLst>
               <a:ext uri="{FF2B5EF4-FFF2-40B4-BE49-F238E27FC236}">
-                <a16:creationId xmlns:a16="http://schemas.microsoft.com/office/drawing/2014/main" id="{B725B70A-3DB0-31FF-BCCA-D1FF8C35B134}"/>
+                <a16:creationId xmlns:a16="http://schemas.microsoft.com/office/drawing/2014/main" id="{47980435-615E-2D11-2231-C74882C7E2DC}"/>
               </a:ext>
             </a:extLst>
           </p:cNvPr>
@@ -10519,7 +10520,7 @@
           <p:cNvPr id="85" name="Textfeld 84">
             <a:extLst>
               <a:ext uri="{FF2B5EF4-FFF2-40B4-BE49-F238E27FC236}">
-                <a16:creationId xmlns:a16="http://schemas.microsoft.com/office/drawing/2014/main" id="{1381EFCA-37C5-FCC9-02A1-D61A8CB5D0C3}"/>
+                <a16:creationId xmlns:a16="http://schemas.microsoft.com/office/drawing/2014/main" id="{4C7A8474-8F62-D3CF-4BFB-1ACA8CF9BE9D}"/>
               </a:ext>
             </a:extLst>
           </p:cNvPr>
@@ -10559,7 +10560,7 @@
           <p:cNvPr id="86" name="Textfeld 85">
             <a:extLst>
               <a:ext uri="{FF2B5EF4-FFF2-40B4-BE49-F238E27FC236}">
-                <a16:creationId xmlns:a16="http://schemas.microsoft.com/office/drawing/2014/main" id="{95BA08F5-9235-107E-A46B-BEDFFB0D707C}"/>
+                <a16:creationId xmlns:a16="http://schemas.microsoft.com/office/drawing/2014/main" id="{A02A4569-5BB3-2104-328E-4D1C2D59B550}"/>
               </a:ext>
             </a:extLst>
           </p:cNvPr>
@@ -10599,7 +10600,7 @@
           <p:cNvPr id="87" name="Textfeld 86">
             <a:extLst>
               <a:ext uri="{FF2B5EF4-FFF2-40B4-BE49-F238E27FC236}">
-                <a16:creationId xmlns:a16="http://schemas.microsoft.com/office/drawing/2014/main" id="{1EC43A4A-17FE-E63C-FE94-6B74D330B01D}"/>
+                <a16:creationId xmlns:a16="http://schemas.microsoft.com/office/drawing/2014/main" id="{34C30625-5C39-2645-44A0-8F2585174042}"/>
               </a:ext>
             </a:extLst>
           </p:cNvPr>
@@ -10639,7 +10640,7 @@
           <p:cNvPr id="88" name="Textfeld 87">
             <a:extLst>
               <a:ext uri="{FF2B5EF4-FFF2-40B4-BE49-F238E27FC236}">
-                <a16:creationId xmlns:a16="http://schemas.microsoft.com/office/drawing/2014/main" id="{FBF40989-B227-4A8B-59B4-6A8E757E8D55}"/>
+                <a16:creationId xmlns:a16="http://schemas.microsoft.com/office/drawing/2014/main" id="{EE9F9B9B-4E7B-F8E3-8E2D-570F177D4317}"/>
               </a:ext>
             </a:extLst>
           </p:cNvPr>
@@ -10679,7 +10680,7 @@
           <p:cNvPr id="89" name="Textfeld 88">
             <a:extLst>
               <a:ext uri="{FF2B5EF4-FFF2-40B4-BE49-F238E27FC236}">
-                <a16:creationId xmlns:a16="http://schemas.microsoft.com/office/drawing/2014/main" id="{E1468864-7032-48BE-6C1F-AB006E3C3416}"/>
+                <a16:creationId xmlns:a16="http://schemas.microsoft.com/office/drawing/2014/main" id="{B8EE15EF-D036-AFCF-BE82-54283C6DEDCF}"/>
               </a:ext>
             </a:extLst>
           </p:cNvPr>
@@ -10719,7 +10720,7 @@
           <p:cNvPr id="90" name="Textfeld 89">
             <a:extLst>
               <a:ext uri="{FF2B5EF4-FFF2-40B4-BE49-F238E27FC236}">
-                <a16:creationId xmlns:a16="http://schemas.microsoft.com/office/drawing/2014/main" id="{4ED5153E-C9EA-B442-D241-C655A5667085}"/>
+                <a16:creationId xmlns:a16="http://schemas.microsoft.com/office/drawing/2014/main" id="{39345984-2DAF-EE4F-2334-318C6B7D2BEE}"/>
               </a:ext>
             </a:extLst>
           </p:cNvPr>
@@ -10759,7 +10760,7 @@
           <p:cNvPr id="91" name="Textfeld 90">
             <a:extLst>
               <a:ext uri="{FF2B5EF4-FFF2-40B4-BE49-F238E27FC236}">
-                <a16:creationId xmlns:a16="http://schemas.microsoft.com/office/drawing/2014/main" id="{EAE78AD9-138D-D833-B800-0274F6F726F2}"/>
+                <a16:creationId xmlns:a16="http://schemas.microsoft.com/office/drawing/2014/main" id="{ED5C7B4D-8E33-F869-A98B-1B847CF2CA6D}"/>
               </a:ext>
             </a:extLst>
           </p:cNvPr>
@@ -10799,7 +10800,7 @@
           <p:cNvPr id="92" name="Textfeld 91">
             <a:extLst>
               <a:ext uri="{FF2B5EF4-FFF2-40B4-BE49-F238E27FC236}">
-                <a16:creationId xmlns:a16="http://schemas.microsoft.com/office/drawing/2014/main" id="{394A3CC5-32E2-2D9E-3ED2-8FE5A8BF26DB}"/>
+                <a16:creationId xmlns:a16="http://schemas.microsoft.com/office/drawing/2014/main" id="{EDD84243-4424-5610-3089-A8505A7E837B}"/>
               </a:ext>
             </a:extLst>
           </p:cNvPr>
@@ -10839,7 +10840,7 @@
           <p:cNvPr id="93" name="Textfeld 92">
             <a:extLst>
               <a:ext uri="{FF2B5EF4-FFF2-40B4-BE49-F238E27FC236}">
-                <a16:creationId xmlns:a16="http://schemas.microsoft.com/office/drawing/2014/main" id="{4B54C84E-23E7-7587-F71E-6624A348966C}"/>
+                <a16:creationId xmlns:a16="http://schemas.microsoft.com/office/drawing/2014/main" id="{8A23749B-21AF-CF4B-A9B3-8EE1A4BF92EA}"/>
               </a:ext>
             </a:extLst>
           </p:cNvPr>
@@ -10879,7 +10880,7 @@
           <p:cNvPr id="94" name="Textfeld 93">
             <a:extLst>
               <a:ext uri="{FF2B5EF4-FFF2-40B4-BE49-F238E27FC236}">
-                <a16:creationId xmlns:a16="http://schemas.microsoft.com/office/drawing/2014/main" id="{C5A43B46-44BE-9935-C7A1-410C5B988003}"/>
+                <a16:creationId xmlns:a16="http://schemas.microsoft.com/office/drawing/2014/main" id="{9A6C4815-88AE-91E9-C1D5-549C7D0F50DB}"/>
               </a:ext>
             </a:extLst>
           </p:cNvPr>
@@ -10919,7 +10920,7 @@
           <p:cNvPr id="95" name="Textfeld 94">
             <a:extLst>
               <a:ext uri="{FF2B5EF4-FFF2-40B4-BE49-F238E27FC236}">
-                <a16:creationId xmlns:a16="http://schemas.microsoft.com/office/drawing/2014/main" id="{243FEBD1-685F-2014-278C-2A72CC4308FD}"/>
+                <a16:creationId xmlns:a16="http://schemas.microsoft.com/office/drawing/2014/main" id="{C2DC17BE-1FC9-B91A-1CAC-7FE73B755C23}"/>
               </a:ext>
             </a:extLst>
           </p:cNvPr>
@@ -10959,7 +10960,7 @@
           <p:cNvPr id="96" name="Textfeld 95">
             <a:extLst>
               <a:ext uri="{FF2B5EF4-FFF2-40B4-BE49-F238E27FC236}">
-                <a16:creationId xmlns:a16="http://schemas.microsoft.com/office/drawing/2014/main" id="{D6160831-811A-6826-35F7-C1E4761838DD}"/>
+                <a16:creationId xmlns:a16="http://schemas.microsoft.com/office/drawing/2014/main" id="{A2388C2B-019A-605B-B19F-BA098FAE5BF5}"/>
               </a:ext>
             </a:extLst>
           </p:cNvPr>
@@ -10999,7 +11000,7 @@
           <p:cNvPr id="97" name="Textfeld 96">
             <a:extLst>
               <a:ext uri="{FF2B5EF4-FFF2-40B4-BE49-F238E27FC236}">
-                <a16:creationId xmlns:a16="http://schemas.microsoft.com/office/drawing/2014/main" id="{EB920B4C-3CBC-12BA-21FD-88095FFEC1DE}"/>
+                <a16:creationId xmlns:a16="http://schemas.microsoft.com/office/drawing/2014/main" id="{077156EF-C952-CD4B-132B-3F845393A08D}"/>
               </a:ext>
             </a:extLst>
           </p:cNvPr>
@@ -11037,7 +11038,7 @@
     </p:spTree>
     <p:extLst>
       <p:ext uri="{BB962C8B-B14F-4D97-AF65-F5344CB8AC3E}">
-        <p14:creationId xmlns:p14="http://schemas.microsoft.com/office/powerpoint/2010/main" val="4186362309"/>
+        <p14:creationId xmlns:p14="http://schemas.microsoft.com/office/powerpoint/2010/main" val="2187162751"/>
       </p:ext>
     </p:extLst>
   </p:cSld>
@@ -11069,7 +11070,7 @@
           <p:cNvPr id="2" name="Textfeld 1">
             <a:extLst>
               <a:ext uri="{FF2B5EF4-FFF2-40B4-BE49-F238E27FC236}">
-                <a16:creationId xmlns:a16="http://schemas.microsoft.com/office/drawing/2014/main" id="{5F6DC86F-9577-1D05-0048-13664D72823E}"/>
+                <a16:creationId xmlns:a16="http://schemas.microsoft.com/office/drawing/2014/main" id="{EA1FF40C-3574-2421-D9EA-68D5532AFCEA}"/>
               </a:ext>
             </a:extLst>
           </p:cNvPr>
@@ -11109,7 +11110,7 @@
           <p:cNvPr id="3" name="Textfeld 2">
             <a:extLst>
               <a:ext uri="{FF2B5EF4-FFF2-40B4-BE49-F238E27FC236}">
-                <a16:creationId xmlns:a16="http://schemas.microsoft.com/office/drawing/2014/main" id="{7644C9DA-14D1-417E-2D1F-032533E173AD}"/>
+                <a16:creationId xmlns:a16="http://schemas.microsoft.com/office/drawing/2014/main" id="{FB761A7C-A02E-6BA9-081A-A3E4DCACC60A}"/>
               </a:ext>
             </a:extLst>
           </p:cNvPr>
@@ -11149,7 +11150,7 @@
           <p:cNvPr id="4" name="Textfeld 3">
             <a:extLst>
               <a:ext uri="{FF2B5EF4-FFF2-40B4-BE49-F238E27FC236}">
-                <a16:creationId xmlns:a16="http://schemas.microsoft.com/office/drawing/2014/main" id="{2E1A1CC3-1F76-5004-0A1F-52A0F73B9457}"/>
+                <a16:creationId xmlns:a16="http://schemas.microsoft.com/office/drawing/2014/main" id="{5D7C1F67-A54F-B5A4-E1D3-89115E119AB3}"/>
               </a:ext>
             </a:extLst>
           </p:cNvPr>
@@ -11189,7 +11190,7 @@
           <p:cNvPr id="5" name="Textfeld 4">
             <a:extLst>
               <a:ext uri="{FF2B5EF4-FFF2-40B4-BE49-F238E27FC236}">
-                <a16:creationId xmlns:a16="http://schemas.microsoft.com/office/drawing/2014/main" id="{D1118A99-1386-A41B-64A3-9D66769F80AF}"/>
+                <a16:creationId xmlns:a16="http://schemas.microsoft.com/office/drawing/2014/main" id="{7C132315-BC5E-C714-3A59-2DE44B3778FB}"/>
               </a:ext>
             </a:extLst>
           </p:cNvPr>
@@ -11229,7 +11230,7 @@
           <p:cNvPr id="6" name="Textfeld 5">
             <a:extLst>
               <a:ext uri="{FF2B5EF4-FFF2-40B4-BE49-F238E27FC236}">
-                <a16:creationId xmlns:a16="http://schemas.microsoft.com/office/drawing/2014/main" id="{FD44762C-A3DC-46C7-8C8A-1C95E3ED978B}"/>
+                <a16:creationId xmlns:a16="http://schemas.microsoft.com/office/drawing/2014/main" id="{AAE26BE1-A10B-F578-98D4-6C3EBCFB6EA2}"/>
               </a:ext>
             </a:extLst>
           </p:cNvPr>
@@ -11269,7 +11270,7 @@
           <p:cNvPr id="7" name="Textfeld 6">
             <a:extLst>
               <a:ext uri="{FF2B5EF4-FFF2-40B4-BE49-F238E27FC236}">
-                <a16:creationId xmlns:a16="http://schemas.microsoft.com/office/drawing/2014/main" id="{67093C1B-4775-EA46-7483-9E01022A4D74}"/>
+                <a16:creationId xmlns:a16="http://schemas.microsoft.com/office/drawing/2014/main" id="{38B7FFD1-D93B-DF1D-3C53-582278FB350C}"/>
               </a:ext>
             </a:extLst>
           </p:cNvPr>
@@ -11309,7 +11310,7 @@
           <p:cNvPr id="8" name="Textfeld 7">
             <a:extLst>
               <a:ext uri="{FF2B5EF4-FFF2-40B4-BE49-F238E27FC236}">
-                <a16:creationId xmlns:a16="http://schemas.microsoft.com/office/drawing/2014/main" id="{F64E4A59-D2A6-7247-BF80-8785EC72FFF1}"/>
+                <a16:creationId xmlns:a16="http://schemas.microsoft.com/office/drawing/2014/main" id="{73831B56-A459-6192-CFC0-8D4D745BBC0E}"/>
               </a:ext>
             </a:extLst>
           </p:cNvPr>
@@ -11349,7 +11350,7 @@
           <p:cNvPr id="9" name="Textfeld 8">
             <a:extLst>
               <a:ext uri="{FF2B5EF4-FFF2-40B4-BE49-F238E27FC236}">
-                <a16:creationId xmlns:a16="http://schemas.microsoft.com/office/drawing/2014/main" id="{51E179A4-BE34-7858-BA2E-6CB3638F4C80}"/>
+                <a16:creationId xmlns:a16="http://schemas.microsoft.com/office/drawing/2014/main" id="{2B495A7C-F6C9-A158-9810-100C5CEE13CD}"/>
               </a:ext>
             </a:extLst>
           </p:cNvPr>
@@ -11389,7 +11390,7 @@
           <p:cNvPr id="10" name="Textfeld 9">
             <a:extLst>
               <a:ext uri="{FF2B5EF4-FFF2-40B4-BE49-F238E27FC236}">
-                <a16:creationId xmlns:a16="http://schemas.microsoft.com/office/drawing/2014/main" id="{5623D7E9-57F2-416C-A545-33FF354742EA}"/>
+                <a16:creationId xmlns:a16="http://schemas.microsoft.com/office/drawing/2014/main" id="{4346C6B1-9D05-E21A-B8DE-551B132278A8}"/>
               </a:ext>
             </a:extLst>
           </p:cNvPr>
@@ -11429,7 +11430,7 @@
           <p:cNvPr id="11" name="Textfeld 10">
             <a:extLst>
               <a:ext uri="{FF2B5EF4-FFF2-40B4-BE49-F238E27FC236}">
-                <a16:creationId xmlns:a16="http://schemas.microsoft.com/office/drawing/2014/main" id="{E5B31EC3-DF8E-EAB2-209F-8201A9F0DB56}"/>
+                <a16:creationId xmlns:a16="http://schemas.microsoft.com/office/drawing/2014/main" id="{A3DCEE61-2AFD-FC4C-757B-40631DBB5269}"/>
               </a:ext>
             </a:extLst>
           </p:cNvPr>
@@ -11469,7 +11470,7 @@
           <p:cNvPr id="12" name="Textfeld 11">
             <a:extLst>
               <a:ext uri="{FF2B5EF4-FFF2-40B4-BE49-F238E27FC236}">
-                <a16:creationId xmlns:a16="http://schemas.microsoft.com/office/drawing/2014/main" id="{80E371B7-9602-A329-2AEC-57AA90305576}"/>
+                <a16:creationId xmlns:a16="http://schemas.microsoft.com/office/drawing/2014/main" id="{111D0A1A-2D67-2389-4E99-D52834AB0D23}"/>
               </a:ext>
             </a:extLst>
           </p:cNvPr>
@@ -11509,7 +11510,7 @@
           <p:cNvPr id="13" name="Textfeld 12">
             <a:extLst>
               <a:ext uri="{FF2B5EF4-FFF2-40B4-BE49-F238E27FC236}">
-                <a16:creationId xmlns:a16="http://schemas.microsoft.com/office/drawing/2014/main" id="{1AD43C89-CC1E-B49E-C038-D3D566FBCA81}"/>
+                <a16:creationId xmlns:a16="http://schemas.microsoft.com/office/drawing/2014/main" id="{6434FDDB-0C3E-8A10-9755-CB9F9A76E171}"/>
               </a:ext>
             </a:extLst>
           </p:cNvPr>
@@ -11549,7 +11550,7 @@
           <p:cNvPr id="14" name="Textfeld 13">
             <a:extLst>
               <a:ext uri="{FF2B5EF4-FFF2-40B4-BE49-F238E27FC236}">
-                <a16:creationId xmlns:a16="http://schemas.microsoft.com/office/drawing/2014/main" id="{823167F0-2BAB-3320-1B92-C2D9E8000BA0}"/>
+                <a16:creationId xmlns:a16="http://schemas.microsoft.com/office/drawing/2014/main" id="{AD7D6A15-32AA-7F53-4C74-0D54ED525278}"/>
               </a:ext>
             </a:extLst>
           </p:cNvPr>
@@ -11589,7 +11590,7 @@
           <p:cNvPr id="15" name="Textfeld 14">
             <a:extLst>
               <a:ext uri="{FF2B5EF4-FFF2-40B4-BE49-F238E27FC236}">
-                <a16:creationId xmlns:a16="http://schemas.microsoft.com/office/drawing/2014/main" id="{9A896E5D-908A-9236-15C3-C886E0165D43}"/>
+                <a16:creationId xmlns:a16="http://schemas.microsoft.com/office/drawing/2014/main" id="{364BDF4E-9DB3-E9AE-0AEF-7B9E6EEA934C}"/>
               </a:ext>
             </a:extLst>
           </p:cNvPr>
@@ -11629,7 +11630,7 @@
           <p:cNvPr id="16" name="Textfeld 15">
             <a:extLst>
               <a:ext uri="{FF2B5EF4-FFF2-40B4-BE49-F238E27FC236}">
-                <a16:creationId xmlns:a16="http://schemas.microsoft.com/office/drawing/2014/main" id="{8DA248E2-B615-6324-B0CB-8FCAB8E17695}"/>
+                <a16:creationId xmlns:a16="http://schemas.microsoft.com/office/drawing/2014/main" id="{6506DE6D-4253-C844-EE48-A9EE64CC4FAF}"/>
               </a:ext>
             </a:extLst>
           </p:cNvPr>
@@ -11669,7 +11670,7 @@
           <p:cNvPr id="17" name="Textfeld 16">
             <a:extLst>
               <a:ext uri="{FF2B5EF4-FFF2-40B4-BE49-F238E27FC236}">
-                <a16:creationId xmlns:a16="http://schemas.microsoft.com/office/drawing/2014/main" id="{8F331A09-F326-003E-9D20-FFFAF69A475C}"/>
+                <a16:creationId xmlns:a16="http://schemas.microsoft.com/office/drawing/2014/main" id="{9631203D-8679-0570-D16B-4D427B6A64ED}"/>
               </a:ext>
             </a:extLst>
           </p:cNvPr>
@@ -11707,7 +11708,7 @@
     </p:spTree>
     <p:extLst>
       <p:ext uri="{BB962C8B-B14F-4D97-AF65-F5344CB8AC3E}">
-        <p14:creationId xmlns:p14="http://schemas.microsoft.com/office/powerpoint/2010/main" val="4157960090"/>
+        <p14:creationId xmlns:p14="http://schemas.microsoft.com/office/powerpoint/2010/main" val="1728830172"/>
       </p:ext>
     </p:extLst>
   </p:cSld>
@@ -11739,7 +11740,7 @@
           <p:cNvPr id="2" name="Textfeld 1">
             <a:extLst>
               <a:ext uri="{FF2B5EF4-FFF2-40B4-BE49-F238E27FC236}">
-                <a16:creationId xmlns:a16="http://schemas.microsoft.com/office/drawing/2014/main" id="{F9F63B00-F039-6F5C-2DE5-78E284D5D753}"/>
+                <a16:creationId xmlns:a16="http://schemas.microsoft.com/office/drawing/2014/main" id="{621BA0E6-CFDA-FA08-72EE-BBC30991C4E9}"/>
               </a:ext>
             </a:extLst>
           </p:cNvPr>
@@ -11779,7 +11780,7 @@
           <p:cNvPr id="3" name="Textfeld 2">
             <a:extLst>
               <a:ext uri="{FF2B5EF4-FFF2-40B4-BE49-F238E27FC236}">
-                <a16:creationId xmlns:a16="http://schemas.microsoft.com/office/drawing/2014/main" id="{A63E2F44-BBB0-9275-C5B9-B81179B30D0B}"/>
+                <a16:creationId xmlns:a16="http://schemas.microsoft.com/office/drawing/2014/main" id="{E12BF7CD-68D0-C19D-C3B2-CC3544A8D9EB}"/>
               </a:ext>
             </a:extLst>
           </p:cNvPr>
@@ -11819,7 +11820,7 @@
           <p:cNvPr id="4" name="Textfeld 3">
             <a:extLst>
               <a:ext uri="{FF2B5EF4-FFF2-40B4-BE49-F238E27FC236}">
-                <a16:creationId xmlns:a16="http://schemas.microsoft.com/office/drawing/2014/main" id="{17E66BB2-53C9-E4A3-7CAE-B910E8BD52F5}"/>
+                <a16:creationId xmlns:a16="http://schemas.microsoft.com/office/drawing/2014/main" id="{FAABA420-6E4A-7BFD-C994-A0665F5F10D0}"/>
               </a:ext>
             </a:extLst>
           </p:cNvPr>
@@ -11859,7 +11860,7 @@
           <p:cNvPr id="5" name="Textfeld 4">
             <a:extLst>
               <a:ext uri="{FF2B5EF4-FFF2-40B4-BE49-F238E27FC236}">
-                <a16:creationId xmlns:a16="http://schemas.microsoft.com/office/drawing/2014/main" id="{D220EBB2-D38D-BEE1-9AA9-292D2F1C94DA}"/>
+                <a16:creationId xmlns:a16="http://schemas.microsoft.com/office/drawing/2014/main" id="{F8F3EA17-D865-9AE4-A600-D12F7FCA00F1}"/>
               </a:ext>
             </a:extLst>
           </p:cNvPr>
@@ -11899,7 +11900,7 @@
           <p:cNvPr id="6" name="Textfeld 5">
             <a:extLst>
               <a:ext uri="{FF2B5EF4-FFF2-40B4-BE49-F238E27FC236}">
-                <a16:creationId xmlns:a16="http://schemas.microsoft.com/office/drawing/2014/main" id="{08E0E903-F8DD-5436-C888-61D923E25E86}"/>
+                <a16:creationId xmlns:a16="http://schemas.microsoft.com/office/drawing/2014/main" id="{D18D1F92-AD13-DCE9-D7CD-4C09EBC344AF}"/>
               </a:ext>
             </a:extLst>
           </p:cNvPr>
@@ -11939,7 +11940,7 @@
           <p:cNvPr id="7" name="Textfeld 6">
             <a:extLst>
               <a:ext uri="{FF2B5EF4-FFF2-40B4-BE49-F238E27FC236}">
-                <a16:creationId xmlns:a16="http://schemas.microsoft.com/office/drawing/2014/main" id="{5A6E8E49-FF9A-880F-91C1-DA3DC6752B31}"/>
+                <a16:creationId xmlns:a16="http://schemas.microsoft.com/office/drawing/2014/main" id="{2F486A1C-90BA-E4D8-3D57-EF774E954A63}"/>
               </a:ext>
             </a:extLst>
           </p:cNvPr>
@@ -11988,7 +11989,7 @@
           <p:cNvPr id="8" name="Textfeld 7">
             <a:extLst>
               <a:ext uri="{FF2B5EF4-FFF2-40B4-BE49-F238E27FC236}">
-                <a16:creationId xmlns:a16="http://schemas.microsoft.com/office/drawing/2014/main" id="{06F7B812-955A-378B-961E-FF0AD942A2FD}"/>
+                <a16:creationId xmlns:a16="http://schemas.microsoft.com/office/drawing/2014/main" id="{09D1A3C1-8C99-902C-1E53-31F678796CB3}"/>
               </a:ext>
             </a:extLst>
           </p:cNvPr>
@@ -12026,7 +12027,1597 @@
     </p:spTree>
     <p:extLst>
       <p:ext uri="{BB962C8B-B14F-4D97-AF65-F5344CB8AC3E}">
-        <p14:creationId xmlns:p14="http://schemas.microsoft.com/office/powerpoint/2010/main" val="314374929"/>
+        <p14:creationId xmlns:p14="http://schemas.microsoft.com/office/powerpoint/2010/main" val="1208615615"/>
+      </p:ext>
+    </p:extLst>
+  </p:cSld>
+  <p:clrMapOvr>
+    <a:masterClrMapping/>
+  </p:clrMapOvr>
+</p:sld>
+</file>
+
+<file path=ppt/slides/slide5.xml><?xml version="1.0" encoding="utf-8"?>
+<p:sld xmlns:a="http://schemas.openxmlformats.org/drawingml/2006/main" xmlns:r="http://schemas.openxmlformats.org/officeDocument/2006/relationships" xmlns:p="http://schemas.openxmlformats.org/presentationml/2006/main">
+  <p:cSld>
+    <p:spTree>
+      <p:nvGrpSpPr>
+        <p:cNvPr id="1" name=""/>
+        <p:cNvGrpSpPr/>
+        <p:nvPr/>
+      </p:nvGrpSpPr>
+      <p:grpSpPr>
+        <a:xfrm>
+          <a:off x="0" y="0"/>
+          <a:ext cx="0" cy="0"/>
+          <a:chOff x="0" y="0"/>
+          <a:chExt cx="0" cy="0"/>
+        </a:xfrm>
+      </p:grpSpPr>
+      <p:sp>
+        <p:nvSpPr>
+          <p:cNvPr id="2" name="Textfeld 1">
+            <a:extLst>
+              <a:ext uri="{FF2B5EF4-FFF2-40B4-BE49-F238E27FC236}">
+                <a16:creationId xmlns:a16="http://schemas.microsoft.com/office/drawing/2014/main" id="{7C3AFB4E-7C5B-1E11-448D-F629F34F83F3}"/>
+              </a:ext>
+            </a:extLst>
+          </p:cNvPr>
+          <p:cNvSpPr txBox="1"/>
+          <p:nvPr/>
+        </p:nvSpPr>
+        <p:spPr>
+          <a:xfrm>
+            <a:off x="254000" y="203200"/>
+            <a:ext cx="5842000" cy="304800"/>
+          </a:xfrm>
+          <a:prstGeom prst="rect">
+            <a:avLst/>
+          </a:prstGeom>
+          <a:noFill/>
+        </p:spPr>
+        <p:txBody>
+          <a:bodyPr vert="horz" wrap="none" lIns="0" tIns="0" rIns="0" bIns="0" rtlCol="0">
+            <a:noAutofit/>
+          </a:bodyPr>
+          <a:lstStyle/>
+          <a:p>
+            <a:r>
+              <a:rPr lang="de-DE" sz="1200">
+                <a:solidFill>
+                  <a:srgbClr val="000000"/>
+                </a:solidFill>
+                <a:latin typeface="Aptos" panose="020B0004020202020204" pitchFamily="34" charset="0"/>
+              </a:rPr>
+              <a:t>HHHH HHHH</a:t>
+            </a:r>
+          </a:p>
+        </p:txBody>
+      </p:sp>
+      <p:sp>
+        <p:nvSpPr>
+          <p:cNvPr id="3" name="Textfeld 2">
+            <a:extLst>
+              <a:ext uri="{FF2B5EF4-FFF2-40B4-BE49-F238E27FC236}">
+                <a16:creationId xmlns:a16="http://schemas.microsoft.com/office/drawing/2014/main" id="{AAD8F4C0-617C-7F24-F03F-50E092CDC9BE}"/>
+              </a:ext>
+            </a:extLst>
+          </p:cNvPr>
+          <p:cNvSpPr txBox="1"/>
+          <p:nvPr/>
+        </p:nvSpPr>
+        <p:spPr>
+          <a:xfrm>
+            <a:off x="254000" y="704850"/>
+            <a:ext cx="5842000" cy="330200"/>
+          </a:xfrm>
+          <a:prstGeom prst="rect">
+            <a:avLst/>
+          </a:prstGeom>
+          <a:noFill/>
+        </p:spPr>
+        <p:txBody>
+          <a:bodyPr vert="horz" wrap="none" lIns="0" tIns="0" rIns="0" bIns="0" rtlCol="0">
+            <a:noAutofit/>
+          </a:bodyPr>
+          <a:lstStyle/>
+          <a:p>
+            <a:r>
+              <a:rPr lang="de-DE" sz="1300">
+                <a:solidFill>
+                  <a:srgbClr val="000000"/>
+                </a:solidFill>
+                <a:latin typeface="Aptos" panose="020B0004020202020204" pitchFamily="34" charset="0"/>
+              </a:rPr>
+              <a:t>HHHH HHHH</a:t>
+            </a:r>
+          </a:p>
+        </p:txBody>
+      </p:sp>
+      <p:sp>
+        <p:nvSpPr>
+          <p:cNvPr id="4" name="Textfeld 3">
+            <a:extLst>
+              <a:ext uri="{FF2B5EF4-FFF2-40B4-BE49-F238E27FC236}">
+                <a16:creationId xmlns:a16="http://schemas.microsoft.com/office/drawing/2014/main" id="{03E2CADC-F4FA-919B-D3AE-AE2327F03873}"/>
+              </a:ext>
+            </a:extLst>
+          </p:cNvPr>
+          <p:cNvSpPr txBox="1"/>
+          <p:nvPr/>
+        </p:nvSpPr>
+        <p:spPr>
+          <a:xfrm>
+            <a:off x="254000" y="1206500"/>
+            <a:ext cx="5842000" cy="355600"/>
+          </a:xfrm>
+          <a:prstGeom prst="rect">
+            <a:avLst/>
+          </a:prstGeom>
+          <a:noFill/>
+        </p:spPr>
+        <p:txBody>
+          <a:bodyPr vert="horz" wrap="none" lIns="0" tIns="0" rIns="0" bIns="0" rtlCol="0">
+            <a:noAutofit/>
+          </a:bodyPr>
+          <a:lstStyle/>
+          <a:p>
+            <a:r>
+              <a:rPr lang="de-DE" sz="1400">
+                <a:solidFill>
+                  <a:srgbClr val="000000"/>
+                </a:solidFill>
+                <a:latin typeface="Aptos" panose="020B0004020202020204" pitchFamily="34" charset="0"/>
+              </a:rPr>
+              <a:t>HHHH HHHH</a:t>
+            </a:r>
+          </a:p>
+        </p:txBody>
+      </p:sp>
+      <p:sp>
+        <p:nvSpPr>
+          <p:cNvPr id="5" name="Textfeld 4">
+            <a:extLst>
+              <a:ext uri="{FF2B5EF4-FFF2-40B4-BE49-F238E27FC236}">
+                <a16:creationId xmlns:a16="http://schemas.microsoft.com/office/drawing/2014/main" id="{A5BDFEA4-B1C2-4316-D826-812BBD6F96F7}"/>
+              </a:ext>
+            </a:extLst>
+          </p:cNvPr>
+          <p:cNvSpPr txBox="1"/>
+          <p:nvPr/>
+        </p:nvSpPr>
+        <p:spPr>
+          <a:xfrm>
+            <a:off x="254000" y="1708150"/>
+            <a:ext cx="5842000" cy="381000"/>
+          </a:xfrm>
+          <a:prstGeom prst="rect">
+            <a:avLst/>
+          </a:prstGeom>
+          <a:noFill/>
+        </p:spPr>
+        <p:txBody>
+          <a:bodyPr vert="horz" wrap="none" lIns="0" tIns="0" rIns="0" bIns="0" rtlCol="0">
+            <a:noAutofit/>
+          </a:bodyPr>
+          <a:lstStyle/>
+          <a:p>
+            <a:r>
+              <a:rPr lang="de-DE" sz="1500">
+                <a:solidFill>
+                  <a:srgbClr val="000000"/>
+                </a:solidFill>
+                <a:latin typeface="Aptos" panose="020B0004020202020204" pitchFamily="34" charset="0"/>
+              </a:rPr>
+              <a:t>HHHH HHHH</a:t>
+            </a:r>
+          </a:p>
+        </p:txBody>
+      </p:sp>
+      <p:sp>
+        <p:nvSpPr>
+          <p:cNvPr id="6" name="Textfeld 5">
+            <a:extLst>
+              <a:ext uri="{FF2B5EF4-FFF2-40B4-BE49-F238E27FC236}">
+                <a16:creationId xmlns:a16="http://schemas.microsoft.com/office/drawing/2014/main" id="{50A3BCE2-9242-38A4-F7CA-CDF041748299}"/>
+              </a:ext>
+            </a:extLst>
+          </p:cNvPr>
+          <p:cNvSpPr txBox="1"/>
+          <p:nvPr/>
+        </p:nvSpPr>
+        <p:spPr>
+          <a:xfrm>
+            <a:off x="254000" y="2209800"/>
+            <a:ext cx="5842000" cy="406400"/>
+          </a:xfrm>
+          <a:prstGeom prst="rect">
+            <a:avLst/>
+          </a:prstGeom>
+          <a:noFill/>
+        </p:spPr>
+        <p:txBody>
+          <a:bodyPr vert="horz" wrap="none" lIns="0" tIns="0" rIns="0" bIns="0" rtlCol="0">
+            <a:noAutofit/>
+          </a:bodyPr>
+          <a:lstStyle/>
+          <a:p>
+            <a:r>
+              <a:rPr lang="de-DE" sz="1600">
+                <a:solidFill>
+                  <a:srgbClr val="000000"/>
+                </a:solidFill>
+                <a:latin typeface="Aptos" panose="020B0004020202020204" pitchFamily="34" charset="0"/>
+              </a:rPr>
+              <a:t>HHHH HHHH</a:t>
+            </a:r>
+          </a:p>
+        </p:txBody>
+      </p:sp>
+      <p:sp>
+        <p:nvSpPr>
+          <p:cNvPr id="7" name="Textfeld 6">
+            <a:extLst>
+              <a:ext uri="{FF2B5EF4-FFF2-40B4-BE49-F238E27FC236}">
+                <a16:creationId xmlns:a16="http://schemas.microsoft.com/office/drawing/2014/main" id="{DAD07B89-D425-1CD0-EAF5-34E76381C93D}"/>
+              </a:ext>
+            </a:extLst>
+          </p:cNvPr>
+          <p:cNvSpPr txBox="1"/>
+          <p:nvPr/>
+        </p:nvSpPr>
+        <p:spPr>
+          <a:xfrm>
+            <a:off x="254000" y="2711450"/>
+            <a:ext cx="5842000" cy="431800"/>
+          </a:xfrm>
+          <a:prstGeom prst="rect">
+            <a:avLst/>
+          </a:prstGeom>
+          <a:noFill/>
+        </p:spPr>
+        <p:txBody>
+          <a:bodyPr vert="horz" wrap="none" lIns="0" tIns="0" rIns="0" bIns="0" rtlCol="0">
+            <a:noAutofit/>
+          </a:bodyPr>
+          <a:lstStyle/>
+          <a:p>
+            <a:r>
+              <a:rPr lang="de-DE" sz="1700">
+                <a:solidFill>
+                  <a:srgbClr val="000000"/>
+                </a:solidFill>
+                <a:latin typeface="Aptos" panose="020B0004020202020204" pitchFamily="34" charset="0"/>
+              </a:rPr>
+              <a:t>HHHH HHHH</a:t>
+            </a:r>
+          </a:p>
+        </p:txBody>
+      </p:sp>
+      <p:sp>
+        <p:nvSpPr>
+          <p:cNvPr id="8" name="Textfeld 7">
+            <a:extLst>
+              <a:ext uri="{FF2B5EF4-FFF2-40B4-BE49-F238E27FC236}">
+                <a16:creationId xmlns:a16="http://schemas.microsoft.com/office/drawing/2014/main" id="{5CFF6242-BBBF-B2C1-C7AA-A7352FF5BD60}"/>
+              </a:ext>
+            </a:extLst>
+          </p:cNvPr>
+          <p:cNvSpPr txBox="1"/>
+          <p:nvPr/>
+        </p:nvSpPr>
+        <p:spPr>
+          <a:xfrm>
+            <a:off x="254000" y="3213100"/>
+            <a:ext cx="5842000" cy="457200"/>
+          </a:xfrm>
+          <a:prstGeom prst="rect">
+            <a:avLst/>
+          </a:prstGeom>
+          <a:noFill/>
+        </p:spPr>
+        <p:txBody>
+          <a:bodyPr vert="horz" wrap="none" lIns="0" tIns="0" rIns="0" bIns="0" rtlCol="0">
+            <a:noAutofit/>
+          </a:bodyPr>
+          <a:lstStyle/>
+          <a:p>
+            <a:r>
+              <a:rPr lang="de-DE">
+                <a:solidFill>
+                  <a:srgbClr val="000000"/>
+                </a:solidFill>
+                <a:latin typeface="Aptos" panose="020B0004020202020204" pitchFamily="34" charset="0"/>
+              </a:rPr>
+              <a:t>HHHH HHHH</a:t>
+            </a:r>
+          </a:p>
+        </p:txBody>
+      </p:sp>
+      <p:sp>
+        <p:nvSpPr>
+          <p:cNvPr id="9" name="Textfeld 8">
+            <a:extLst>
+              <a:ext uri="{FF2B5EF4-FFF2-40B4-BE49-F238E27FC236}">
+                <a16:creationId xmlns:a16="http://schemas.microsoft.com/office/drawing/2014/main" id="{BB0DF8D8-B769-A98E-A4E1-74A020994990}"/>
+              </a:ext>
+            </a:extLst>
+          </p:cNvPr>
+          <p:cNvSpPr txBox="1"/>
+          <p:nvPr/>
+        </p:nvSpPr>
+        <p:spPr>
+          <a:xfrm>
+            <a:off x="254000" y="3714750"/>
+            <a:ext cx="5842000" cy="482600"/>
+          </a:xfrm>
+          <a:prstGeom prst="rect">
+            <a:avLst/>
+          </a:prstGeom>
+          <a:noFill/>
+        </p:spPr>
+        <p:txBody>
+          <a:bodyPr vert="horz" wrap="none" lIns="0" tIns="0" rIns="0" bIns="0" rtlCol="0">
+            <a:noAutofit/>
+          </a:bodyPr>
+          <a:lstStyle/>
+          <a:p>
+            <a:r>
+              <a:rPr lang="de-DE" sz="1900">
+                <a:solidFill>
+                  <a:srgbClr val="000000"/>
+                </a:solidFill>
+                <a:latin typeface="Aptos" panose="020B0004020202020204" pitchFamily="34" charset="0"/>
+              </a:rPr>
+              <a:t>HHHH HHHH</a:t>
+            </a:r>
+          </a:p>
+        </p:txBody>
+      </p:sp>
+      <p:sp>
+        <p:nvSpPr>
+          <p:cNvPr id="10" name="Textfeld 9">
+            <a:extLst>
+              <a:ext uri="{FF2B5EF4-FFF2-40B4-BE49-F238E27FC236}">
+                <a16:creationId xmlns:a16="http://schemas.microsoft.com/office/drawing/2014/main" id="{BDA553FE-B66F-4E65-87C5-5B81853E6FCE}"/>
+              </a:ext>
+            </a:extLst>
+          </p:cNvPr>
+          <p:cNvSpPr txBox="1"/>
+          <p:nvPr/>
+        </p:nvSpPr>
+        <p:spPr>
+          <a:xfrm>
+            <a:off x="254000" y="4216400"/>
+            <a:ext cx="5842000" cy="508000"/>
+          </a:xfrm>
+          <a:prstGeom prst="rect">
+            <a:avLst/>
+          </a:prstGeom>
+          <a:noFill/>
+        </p:spPr>
+        <p:txBody>
+          <a:bodyPr vert="horz" wrap="none" lIns="0" tIns="0" rIns="0" bIns="0" rtlCol="0">
+            <a:noAutofit/>
+          </a:bodyPr>
+          <a:lstStyle/>
+          <a:p>
+            <a:r>
+              <a:rPr lang="de-DE" sz="2000">
+                <a:solidFill>
+                  <a:srgbClr val="000000"/>
+                </a:solidFill>
+                <a:latin typeface="Aptos" panose="020B0004020202020204" pitchFamily="34" charset="0"/>
+              </a:rPr>
+              <a:t>HHHH HHHH</a:t>
+            </a:r>
+          </a:p>
+        </p:txBody>
+      </p:sp>
+      <p:sp>
+        <p:nvSpPr>
+          <p:cNvPr id="11" name="Textfeld 10">
+            <a:extLst>
+              <a:ext uri="{FF2B5EF4-FFF2-40B4-BE49-F238E27FC236}">
+                <a16:creationId xmlns:a16="http://schemas.microsoft.com/office/drawing/2014/main" id="{86E29660-45C3-BFFF-473D-53125CE83C69}"/>
+              </a:ext>
+            </a:extLst>
+          </p:cNvPr>
+          <p:cNvSpPr txBox="1"/>
+          <p:nvPr/>
+        </p:nvSpPr>
+        <p:spPr>
+          <a:xfrm>
+            <a:off x="254000" y="4718050"/>
+            <a:ext cx="5842000" cy="533400"/>
+          </a:xfrm>
+          <a:prstGeom prst="rect">
+            <a:avLst/>
+          </a:prstGeom>
+          <a:noFill/>
+        </p:spPr>
+        <p:txBody>
+          <a:bodyPr vert="horz" wrap="none" lIns="0" tIns="0" rIns="0" bIns="0" rtlCol="0">
+            <a:noAutofit/>
+          </a:bodyPr>
+          <a:lstStyle/>
+          <a:p>
+            <a:r>
+              <a:rPr lang="de-DE" sz="2100">
+                <a:solidFill>
+                  <a:srgbClr val="000000"/>
+                </a:solidFill>
+                <a:latin typeface="Aptos" panose="020B0004020202020204" pitchFamily="34" charset="0"/>
+              </a:rPr>
+              <a:t>HHHH HHHH</a:t>
+            </a:r>
+          </a:p>
+        </p:txBody>
+      </p:sp>
+      <p:sp>
+        <p:nvSpPr>
+          <p:cNvPr id="12" name="Textfeld 11">
+            <a:extLst>
+              <a:ext uri="{FF2B5EF4-FFF2-40B4-BE49-F238E27FC236}">
+                <a16:creationId xmlns:a16="http://schemas.microsoft.com/office/drawing/2014/main" id="{C1D52DF0-14DB-5849-C69B-93DEF71EF2FB}"/>
+              </a:ext>
+            </a:extLst>
+          </p:cNvPr>
+          <p:cNvSpPr txBox="1"/>
+          <p:nvPr/>
+        </p:nvSpPr>
+        <p:spPr>
+          <a:xfrm>
+            <a:off x="254000" y="5219700"/>
+            <a:ext cx="5842000" cy="558800"/>
+          </a:xfrm>
+          <a:prstGeom prst="rect">
+            <a:avLst/>
+          </a:prstGeom>
+          <a:noFill/>
+        </p:spPr>
+        <p:txBody>
+          <a:bodyPr vert="horz" wrap="none" lIns="0" tIns="0" rIns="0" bIns="0" rtlCol="0">
+            <a:noAutofit/>
+          </a:bodyPr>
+          <a:lstStyle/>
+          <a:p>
+            <a:r>
+              <a:rPr lang="de-DE" sz="2200">
+                <a:solidFill>
+                  <a:srgbClr val="000000"/>
+                </a:solidFill>
+                <a:latin typeface="Aptos" panose="020B0004020202020204" pitchFamily="34" charset="0"/>
+              </a:rPr>
+              <a:t>HHHH HHHH</a:t>
+            </a:r>
+          </a:p>
+        </p:txBody>
+      </p:sp>
+      <p:sp>
+        <p:nvSpPr>
+          <p:cNvPr id="13" name="Textfeld 12">
+            <a:extLst>
+              <a:ext uri="{FF2B5EF4-FFF2-40B4-BE49-F238E27FC236}">
+                <a16:creationId xmlns:a16="http://schemas.microsoft.com/office/drawing/2014/main" id="{1F0CBD68-217C-CA37-03E7-2F6C829FA190}"/>
+              </a:ext>
+            </a:extLst>
+          </p:cNvPr>
+          <p:cNvSpPr txBox="1"/>
+          <p:nvPr/>
+        </p:nvSpPr>
+        <p:spPr>
+          <a:xfrm>
+            <a:off x="254000" y="5721350"/>
+            <a:ext cx="5842000" cy="584200"/>
+          </a:xfrm>
+          <a:prstGeom prst="rect">
+            <a:avLst/>
+          </a:prstGeom>
+          <a:noFill/>
+        </p:spPr>
+        <p:txBody>
+          <a:bodyPr vert="horz" wrap="none" lIns="0" tIns="0" rIns="0" bIns="0" rtlCol="0">
+            <a:noAutofit/>
+          </a:bodyPr>
+          <a:lstStyle/>
+          <a:p>
+            <a:r>
+              <a:rPr lang="de-DE" sz="2300">
+                <a:solidFill>
+                  <a:srgbClr val="000000"/>
+                </a:solidFill>
+                <a:latin typeface="Aptos" panose="020B0004020202020204" pitchFamily="34" charset="0"/>
+              </a:rPr>
+              <a:t>HHHH HHHH</a:t>
+            </a:r>
+          </a:p>
+        </p:txBody>
+      </p:sp>
+      <p:sp>
+        <p:nvSpPr>
+          <p:cNvPr id="14" name="Textfeld 13">
+            <a:extLst>
+              <a:ext uri="{FF2B5EF4-FFF2-40B4-BE49-F238E27FC236}">
+                <a16:creationId xmlns:a16="http://schemas.microsoft.com/office/drawing/2014/main" id="{84A328DC-DB69-4997-F859-79F638308447}"/>
+              </a:ext>
+            </a:extLst>
+          </p:cNvPr>
+          <p:cNvSpPr txBox="1"/>
+          <p:nvPr/>
+        </p:nvSpPr>
+        <p:spPr>
+          <a:xfrm>
+            <a:off x="254000" y="6223000"/>
+            <a:ext cx="5842000" cy="609600"/>
+          </a:xfrm>
+          <a:prstGeom prst="rect">
+            <a:avLst/>
+          </a:prstGeom>
+          <a:noFill/>
+        </p:spPr>
+        <p:txBody>
+          <a:bodyPr vert="horz" wrap="none" lIns="0" tIns="0" rIns="0" bIns="0" rtlCol="0">
+            <a:noAutofit/>
+          </a:bodyPr>
+          <a:lstStyle/>
+          <a:p>
+            <a:r>
+              <a:rPr lang="de-DE" sz="2400">
+                <a:solidFill>
+                  <a:srgbClr val="000000"/>
+                </a:solidFill>
+                <a:latin typeface="Aptos" panose="020B0004020202020204" pitchFamily="34" charset="0"/>
+              </a:rPr>
+              <a:t>HHHH HHHH</a:t>
+            </a:r>
+          </a:p>
+        </p:txBody>
+      </p:sp>
+      <p:sp>
+        <p:nvSpPr>
+          <p:cNvPr id="15" name="Textfeld 14">
+            <a:extLst>
+              <a:ext uri="{FF2B5EF4-FFF2-40B4-BE49-F238E27FC236}">
+                <a16:creationId xmlns:a16="http://schemas.microsoft.com/office/drawing/2014/main" id="{9C469C69-A98C-ACF8-6866-274AA0A6D7EE}"/>
+              </a:ext>
+            </a:extLst>
+          </p:cNvPr>
+          <p:cNvSpPr txBox="1"/>
+          <p:nvPr/>
+        </p:nvSpPr>
+        <p:spPr>
+          <a:xfrm>
+            <a:off x="4191000" y="203200"/>
+            <a:ext cx="5842000" cy="304800"/>
+          </a:xfrm>
+          <a:prstGeom prst="rect">
+            <a:avLst/>
+          </a:prstGeom>
+          <a:noFill/>
+        </p:spPr>
+        <p:txBody>
+          <a:bodyPr vert="horz" wrap="none" lIns="0" tIns="0" rIns="0" bIns="0" rtlCol="0">
+            <a:noAutofit/>
+          </a:bodyPr>
+          <a:lstStyle/>
+          <a:p>
+            <a:r>
+              <a:rPr lang="de-DE" sz="1200">
+                <a:solidFill>
+                  <a:srgbClr val="000000"/>
+                </a:solidFill>
+                <a:latin typeface="Arial" panose="020B0604020202020204" pitchFamily="34" charset="0"/>
+              </a:rPr>
+              <a:t>HHHH HHHH</a:t>
+            </a:r>
+          </a:p>
+        </p:txBody>
+      </p:sp>
+      <p:sp>
+        <p:nvSpPr>
+          <p:cNvPr id="16" name="Textfeld 15">
+            <a:extLst>
+              <a:ext uri="{FF2B5EF4-FFF2-40B4-BE49-F238E27FC236}">
+                <a16:creationId xmlns:a16="http://schemas.microsoft.com/office/drawing/2014/main" id="{77467314-8C9C-2567-7030-9A07E9502A87}"/>
+              </a:ext>
+            </a:extLst>
+          </p:cNvPr>
+          <p:cNvSpPr txBox="1"/>
+          <p:nvPr/>
+        </p:nvSpPr>
+        <p:spPr>
+          <a:xfrm>
+            <a:off x="4191000" y="704850"/>
+            <a:ext cx="5842000" cy="330200"/>
+          </a:xfrm>
+          <a:prstGeom prst="rect">
+            <a:avLst/>
+          </a:prstGeom>
+          <a:noFill/>
+        </p:spPr>
+        <p:txBody>
+          <a:bodyPr vert="horz" wrap="none" lIns="0" tIns="0" rIns="0" bIns="0" rtlCol="0">
+            <a:noAutofit/>
+          </a:bodyPr>
+          <a:lstStyle/>
+          <a:p>
+            <a:r>
+              <a:rPr lang="de-DE" sz="1300">
+                <a:solidFill>
+                  <a:srgbClr val="000000"/>
+                </a:solidFill>
+                <a:latin typeface="Arial" panose="020B0604020202020204" pitchFamily="34" charset="0"/>
+              </a:rPr>
+              <a:t>HHHH HHHH</a:t>
+            </a:r>
+          </a:p>
+        </p:txBody>
+      </p:sp>
+      <p:sp>
+        <p:nvSpPr>
+          <p:cNvPr id="17" name="Textfeld 16">
+            <a:extLst>
+              <a:ext uri="{FF2B5EF4-FFF2-40B4-BE49-F238E27FC236}">
+                <a16:creationId xmlns:a16="http://schemas.microsoft.com/office/drawing/2014/main" id="{DF67F197-BE0A-6F70-B73C-7985F5086074}"/>
+              </a:ext>
+            </a:extLst>
+          </p:cNvPr>
+          <p:cNvSpPr txBox="1"/>
+          <p:nvPr/>
+        </p:nvSpPr>
+        <p:spPr>
+          <a:xfrm>
+            <a:off x="4191000" y="1206500"/>
+            <a:ext cx="5842000" cy="355600"/>
+          </a:xfrm>
+          <a:prstGeom prst="rect">
+            <a:avLst/>
+          </a:prstGeom>
+          <a:noFill/>
+        </p:spPr>
+        <p:txBody>
+          <a:bodyPr vert="horz" wrap="none" lIns="0" tIns="0" rIns="0" bIns="0" rtlCol="0">
+            <a:noAutofit/>
+          </a:bodyPr>
+          <a:lstStyle/>
+          <a:p>
+            <a:r>
+              <a:rPr lang="de-DE" sz="1400">
+                <a:solidFill>
+                  <a:srgbClr val="000000"/>
+                </a:solidFill>
+                <a:latin typeface="Arial" panose="020B0604020202020204" pitchFamily="34" charset="0"/>
+              </a:rPr>
+              <a:t>HHHH HHHH</a:t>
+            </a:r>
+          </a:p>
+        </p:txBody>
+      </p:sp>
+      <p:sp>
+        <p:nvSpPr>
+          <p:cNvPr id="18" name="Textfeld 17">
+            <a:extLst>
+              <a:ext uri="{FF2B5EF4-FFF2-40B4-BE49-F238E27FC236}">
+                <a16:creationId xmlns:a16="http://schemas.microsoft.com/office/drawing/2014/main" id="{ABA9C9EF-41CE-ECF0-5238-1BB6000DEE99}"/>
+              </a:ext>
+            </a:extLst>
+          </p:cNvPr>
+          <p:cNvSpPr txBox="1"/>
+          <p:nvPr/>
+        </p:nvSpPr>
+        <p:spPr>
+          <a:xfrm>
+            <a:off x="4191000" y="1708150"/>
+            <a:ext cx="5842000" cy="381000"/>
+          </a:xfrm>
+          <a:prstGeom prst="rect">
+            <a:avLst/>
+          </a:prstGeom>
+          <a:noFill/>
+        </p:spPr>
+        <p:txBody>
+          <a:bodyPr vert="horz" wrap="none" lIns="0" tIns="0" rIns="0" bIns="0" rtlCol="0">
+            <a:noAutofit/>
+          </a:bodyPr>
+          <a:lstStyle/>
+          <a:p>
+            <a:r>
+              <a:rPr lang="de-DE" sz="1500">
+                <a:solidFill>
+                  <a:srgbClr val="000000"/>
+                </a:solidFill>
+                <a:latin typeface="Arial" panose="020B0604020202020204" pitchFamily="34" charset="0"/>
+              </a:rPr>
+              <a:t>HHHH HHHH</a:t>
+            </a:r>
+          </a:p>
+        </p:txBody>
+      </p:sp>
+      <p:sp>
+        <p:nvSpPr>
+          <p:cNvPr id="19" name="Textfeld 18">
+            <a:extLst>
+              <a:ext uri="{FF2B5EF4-FFF2-40B4-BE49-F238E27FC236}">
+                <a16:creationId xmlns:a16="http://schemas.microsoft.com/office/drawing/2014/main" id="{148F1828-D907-B711-79F6-F3F025505856}"/>
+              </a:ext>
+            </a:extLst>
+          </p:cNvPr>
+          <p:cNvSpPr txBox="1"/>
+          <p:nvPr/>
+        </p:nvSpPr>
+        <p:spPr>
+          <a:xfrm>
+            <a:off x="4191000" y="2209800"/>
+            <a:ext cx="5842000" cy="406400"/>
+          </a:xfrm>
+          <a:prstGeom prst="rect">
+            <a:avLst/>
+          </a:prstGeom>
+          <a:noFill/>
+        </p:spPr>
+        <p:txBody>
+          <a:bodyPr vert="horz" wrap="none" lIns="0" tIns="0" rIns="0" bIns="0" rtlCol="0">
+            <a:noAutofit/>
+          </a:bodyPr>
+          <a:lstStyle/>
+          <a:p>
+            <a:r>
+              <a:rPr lang="de-DE" sz="1600">
+                <a:solidFill>
+                  <a:srgbClr val="000000"/>
+                </a:solidFill>
+                <a:latin typeface="Arial" panose="020B0604020202020204" pitchFamily="34" charset="0"/>
+              </a:rPr>
+              <a:t>HHHH HHHH</a:t>
+            </a:r>
+          </a:p>
+        </p:txBody>
+      </p:sp>
+      <p:sp>
+        <p:nvSpPr>
+          <p:cNvPr id="20" name="Textfeld 19">
+            <a:extLst>
+              <a:ext uri="{FF2B5EF4-FFF2-40B4-BE49-F238E27FC236}">
+                <a16:creationId xmlns:a16="http://schemas.microsoft.com/office/drawing/2014/main" id="{B5719FEF-4E3C-2158-FE65-F2D7391022B2}"/>
+              </a:ext>
+            </a:extLst>
+          </p:cNvPr>
+          <p:cNvSpPr txBox="1"/>
+          <p:nvPr/>
+        </p:nvSpPr>
+        <p:spPr>
+          <a:xfrm>
+            <a:off x="4191000" y="2711450"/>
+            <a:ext cx="5842000" cy="431800"/>
+          </a:xfrm>
+          <a:prstGeom prst="rect">
+            <a:avLst/>
+          </a:prstGeom>
+          <a:noFill/>
+        </p:spPr>
+        <p:txBody>
+          <a:bodyPr vert="horz" wrap="none" lIns="0" tIns="0" rIns="0" bIns="0" rtlCol="0">
+            <a:noAutofit/>
+          </a:bodyPr>
+          <a:lstStyle/>
+          <a:p>
+            <a:r>
+              <a:rPr lang="de-DE" sz="1700">
+                <a:solidFill>
+                  <a:srgbClr val="000000"/>
+                </a:solidFill>
+                <a:latin typeface="Arial" panose="020B0604020202020204" pitchFamily="34" charset="0"/>
+              </a:rPr>
+              <a:t>HHHH HHHH</a:t>
+            </a:r>
+          </a:p>
+        </p:txBody>
+      </p:sp>
+      <p:sp>
+        <p:nvSpPr>
+          <p:cNvPr id="21" name="Textfeld 20">
+            <a:extLst>
+              <a:ext uri="{FF2B5EF4-FFF2-40B4-BE49-F238E27FC236}">
+                <a16:creationId xmlns:a16="http://schemas.microsoft.com/office/drawing/2014/main" id="{000D072D-E725-AD6F-72E4-F4C53705A0F9}"/>
+              </a:ext>
+            </a:extLst>
+          </p:cNvPr>
+          <p:cNvSpPr txBox="1"/>
+          <p:nvPr/>
+        </p:nvSpPr>
+        <p:spPr>
+          <a:xfrm>
+            <a:off x="4191000" y="3213100"/>
+            <a:ext cx="5842000" cy="457200"/>
+          </a:xfrm>
+          <a:prstGeom prst="rect">
+            <a:avLst/>
+          </a:prstGeom>
+          <a:noFill/>
+        </p:spPr>
+        <p:txBody>
+          <a:bodyPr vert="horz" wrap="none" lIns="0" tIns="0" rIns="0" bIns="0" rtlCol="0">
+            <a:noAutofit/>
+          </a:bodyPr>
+          <a:lstStyle/>
+          <a:p>
+            <a:r>
+              <a:rPr lang="de-DE">
+                <a:solidFill>
+                  <a:srgbClr val="000000"/>
+                </a:solidFill>
+                <a:latin typeface="Arial" panose="020B0604020202020204" pitchFamily="34" charset="0"/>
+              </a:rPr>
+              <a:t>HHHH HHHH</a:t>
+            </a:r>
+          </a:p>
+        </p:txBody>
+      </p:sp>
+      <p:sp>
+        <p:nvSpPr>
+          <p:cNvPr id="22" name="Textfeld 21">
+            <a:extLst>
+              <a:ext uri="{FF2B5EF4-FFF2-40B4-BE49-F238E27FC236}">
+                <a16:creationId xmlns:a16="http://schemas.microsoft.com/office/drawing/2014/main" id="{BCD5C7DF-9A9B-30F8-CFE3-618DC2AF6CB3}"/>
+              </a:ext>
+            </a:extLst>
+          </p:cNvPr>
+          <p:cNvSpPr txBox="1"/>
+          <p:nvPr/>
+        </p:nvSpPr>
+        <p:spPr>
+          <a:xfrm>
+            <a:off x="4191000" y="3714750"/>
+            <a:ext cx="5842000" cy="482600"/>
+          </a:xfrm>
+          <a:prstGeom prst="rect">
+            <a:avLst/>
+          </a:prstGeom>
+          <a:noFill/>
+        </p:spPr>
+        <p:txBody>
+          <a:bodyPr vert="horz" wrap="none" lIns="0" tIns="0" rIns="0" bIns="0" rtlCol="0">
+            <a:noAutofit/>
+          </a:bodyPr>
+          <a:lstStyle/>
+          <a:p>
+            <a:r>
+              <a:rPr lang="de-DE" sz="1900">
+                <a:solidFill>
+                  <a:srgbClr val="000000"/>
+                </a:solidFill>
+                <a:latin typeface="Arial" panose="020B0604020202020204" pitchFamily="34" charset="0"/>
+              </a:rPr>
+              <a:t>HHHH HHHH</a:t>
+            </a:r>
+          </a:p>
+        </p:txBody>
+      </p:sp>
+      <p:sp>
+        <p:nvSpPr>
+          <p:cNvPr id="23" name="Textfeld 22">
+            <a:extLst>
+              <a:ext uri="{FF2B5EF4-FFF2-40B4-BE49-F238E27FC236}">
+                <a16:creationId xmlns:a16="http://schemas.microsoft.com/office/drawing/2014/main" id="{85D86B06-3C87-83EE-F999-E7D365F2B12A}"/>
+              </a:ext>
+            </a:extLst>
+          </p:cNvPr>
+          <p:cNvSpPr txBox="1"/>
+          <p:nvPr/>
+        </p:nvSpPr>
+        <p:spPr>
+          <a:xfrm>
+            <a:off x="4191000" y="4216400"/>
+            <a:ext cx="5842000" cy="508000"/>
+          </a:xfrm>
+          <a:prstGeom prst="rect">
+            <a:avLst/>
+          </a:prstGeom>
+          <a:noFill/>
+        </p:spPr>
+        <p:txBody>
+          <a:bodyPr vert="horz" wrap="none" lIns="0" tIns="0" rIns="0" bIns="0" rtlCol="0">
+            <a:noAutofit/>
+          </a:bodyPr>
+          <a:lstStyle/>
+          <a:p>
+            <a:r>
+              <a:rPr lang="de-DE" sz="2000">
+                <a:solidFill>
+                  <a:srgbClr val="000000"/>
+                </a:solidFill>
+                <a:latin typeface="Arial" panose="020B0604020202020204" pitchFamily="34" charset="0"/>
+              </a:rPr>
+              <a:t>HHHH HHHH</a:t>
+            </a:r>
+          </a:p>
+        </p:txBody>
+      </p:sp>
+      <p:sp>
+        <p:nvSpPr>
+          <p:cNvPr id="24" name="Textfeld 23">
+            <a:extLst>
+              <a:ext uri="{FF2B5EF4-FFF2-40B4-BE49-F238E27FC236}">
+                <a16:creationId xmlns:a16="http://schemas.microsoft.com/office/drawing/2014/main" id="{B01E58B4-286C-ADD5-94FD-FC46E8E8B7C3}"/>
+              </a:ext>
+            </a:extLst>
+          </p:cNvPr>
+          <p:cNvSpPr txBox="1"/>
+          <p:nvPr/>
+        </p:nvSpPr>
+        <p:spPr>
+          <a:xfrm>
+            <a:off x="4191000" y="4718050"/>
+            <a:ext cx="5842000" cy="533400"/>
+          </a:xfrm>
+          <a:prstGeom prst="rect">
+            <a:avLst/>
+          </a:prstGeom>
+          <a:noFill/>
+        </p:spPr>
+        <p:txBody>
+          <a:bodyPr vert="horz" wrap="none" lIns="0" tIns="0" rIns="0" bIns="0" rtlCol="0">
+            <a:noAutofit/>
+          </a:bodyPr>
+          <a:lstStyle/>
+          <a:p>
+            <a:r>
+              <a:rPr lang="de-DE" sz="2100">
+                <a:solidFill>
+                  <a:srgbClr val="000000"/>
+                </a:solidFill>
+                <a:latin typeface="Arial" panose="020B0604020202020204" pitchFamily="34" charset="0"/>
+              </a:rPr>
+              <a:t>HHHH HHHH</a:t>
+            </a:r>
+          </a:p>
+        </p:txBody>
+      </p:sp>
+      <p:sp>
+        <p:nvSpPr>
+          <p:cNvPr id="25" name="Textfeld 24">
+            <a:extLst>
+              <a:ext uri="{FF2B5EF4-FFF2-40B4-BE49-F238E27FC236}">
+                <a16:creationId xmlns:a16="http://schemas.microsoft.com/office/drawing/2014/main" id="{99B8E24D-CAB9-B22E-8D8C-F7347549A227}"/>
+              </a:ext>
+            </a:extLst>
+          </p:cNvPr>
+          <p:cNvSpPr txBox="1"/>
+          <p:nvPr/>
+        </p:nvSpPr>
+        <p:spPr>
+          <a:xfrm>
+            <a:off x="4191000" y="5219700"/>
+            <a:ext cx="5842000" cy="558800"/>
+          </a:xfrm>
+          <a:prstGeom prst="rect">
+            <a:avLst/>
+          </a:prstGeom>
+          <a:noFill/>
+        </p:spPr>
+        <p:txBody>
+          <a:bodyPr vert="horz" wrap="none" lIns="0" tIns="0" rIns="0" bIns="0" rtlCol="0">
+            <a:noAutofit/>
+          </a:bodyPr>
+          <a:lstStyle/>
+          <a:p>
+            <a:r>
+              <a:rPr lang="de-DE" sz="2200">
+                <a:solidFill>
+                  <a:srgbClr val="000000"/>
+                </a:solidFill>
+                <a:latin typeface="Arial" panose="020B0604020202020204" pitchFamily="34" charset="0"/>
+              </a:rPr>
+              <a:t>HHHH HHHH</a:t>
+            </a:r>
+          </a:p>
+        </p:txBody>
+      </p:sp>
+      <p:sp>
+        <p:nvSpPr>
+          <p:cNvPr id="26" name="Textfeld 25">
+            <a:extLst>
+              <a:ext uri="{FF2B5EF4-FFF2-40B4-BE49-F238E27FC236}">
+                <a16:creationId xmlns:a16="http://schemas.microsoft.com/office/drawing/2014/main" id="{8132991A-82F6-FEEE-7FF8-4370D313554C}"/>
+              </a:ext>
+            </a:extLst>
+          </p:cNvPr>
+          <p:cNvSpPr txBox="1"/>
+          <p:nvPr/>
+        </p:nvSpPr>
+        <p:spPr>
+          <a:xfrm>
+            <a:off x="4191000" y="5721350"/>
+            <a:ext cx="5842000" cy="584200"/>
+          </a:xfrm>
+          <a:prstGeom prst="rect">
+            <a:avLst/>
+          </a:prstGeom>
+          <a:noFill/>
+        </p:spPr>
+        <p:txBody>
+          <a:bodyPr vert="horz" wrap="none" lIns="0" tIns="0" rIns="0" bIns="0" rtlCol="0">
+            <a:noAutofit/>
+          </a:bodyPr>
+          <a:lstStyle/>
+          <a:p>
+            <a:r>
+              <a:rPr lang="de-DE" sz="2300">
+                <a:solidFill>
+                  <a:srgbClr val="000000"/>
+                </a:solidFill>
+                <a:latin typeface="Arial" panose="020B0604020202020204" pitchFamily="34" charset="0"/>
+              </a:rPr>
+              <a:t>HHHH HHHH</a:t>
+            </a:r>
+          </a:p>
+        </p:txBody>
+      </p:sp>
+      <p:sp>
+        <p:nvSpPr>
+          <p:cNvPr id="27" name="Textfeld 26">
+            <a:extLst>
+              <a:ext uri="{FF2B5EF4-FFF2-40B4-BE49-F238E27FC236}">
+                <a16:creationId xmlns:a16="http://schemas.microsoft.com/office/drawing/2014/main" id="{CDA5DE60-A0BB-F1BF-245F-E423ACC1FFEE}"/>
+              </a:ext>
+            </a:extLst>
+          </p:cNvPr>
+          <p:cNvSpPr txBox="1"/>
+          <p:nvPr/>
+        </p:nvSpPr>
+        <p:spPr>
+          <a:xfrm>
+            <a:off x="4191000" y="6223000"/>
+            <a:ext cx="5842000" cy="609600"/>
+          </a:xfrm>
+          <a:prstGeom prst="rect">
+            <a:avLst/>
+          </a:prstGeom>
+          <a:noFill/>
+        </p:spPr>
+        <p:txBody>
+          <a:bodyPr vert="horz" wrap="none" lIns="0" tIns="0" rIns="0" bIns="0" rtlCol="0">
+            <a:noAutofit/>
+          </a:bodyPr>
+          <a:lstStyle/>
+          <a:p>
+            <a:r>
+              <a:rPr lang="de-DE" sz="2400">
+                <a:solidFill>
+                  <a:srgbClr val="000000"/>
+                </a:solidFill>
+                <a:latin typeface="Arial" panose="020B0604020202020204" pitchFamily="34" charset="0"/>
+              </a:rPr>
+              <a:t>HHHH HHHH</a:t>
+            </a:r>
+          </a:p>
+        </p:txBody>
+      </p:sp>
+      <p:sp>
+        <p:nvSpPr>
+          <p:cNvPr id="28" name="Textfeld 27">
+            <a:extLst>
+              <a:ext uri="{FF2B5EF4-FFF2-40B4-BE49-F238E27FC236}">
+                <a16:creationId xmlns:a16="http://schemas.microsoft.com/office/drawing/2014/main" id="{1E20CE4A-C8F5-03D8-DE25-E27CEF210EBF}"/>
+              </a:ext>
+            </a:extLst>
+          </p:cNvPr>
+          <p:cNvSpPr txBox="1"/>
+          <p:nvPr/>
+        </p:nvSpPr>
+        <p:spPr>
+          <a:xfrm>
+            <a:off x="8128000" y="203200"/>
+            <a:ext cx="5842000" cy="304800"/>
+          </a:xfrm>
+          <a:prstGeom prst="rect">
+            <a:avLst/>
+          </a:prstGeom>
+          <a:noFill/>
+        </p:spPr>
+        <p:txBody>
+          <a:bodyPr vert="horz" wrap="none" lIns="0" tIns="0" rIns="0" bIns="0" rtlCol="0">
+            <a:noAutofit/>
+          </a:bodyPr>
+          <a:lstStyle/>
+          <a:p>
+            <a:r>
+              <a:rPr lang="de-DE" sz="1200">
+                <a:solidFill>
+                  <a:srgbClr val="000000"/>
+                </a:solidFill>
+                <a:latin typeface="Times New Roman" panose="02020603050405020304" pitchFamily="18" charset="0"/>
+              </a:rPr>
+              <a:t>HHHH HHHH</a:t>
+            </a:r>
+          </a:p>
+        </p:txBody>
+      </p:sp>
+      <p:sp>
+        <p:nvSpPr>
+          <p:cNvPr id="29" name="Textfeld 28">
+            <a:extLst>
+              <a:ext uri="{FF2B5EF4-FFF2-40B4-BE49-F238E27FC236}">
+                <a16:creationId xmlns:a16="http://schemas.microsoft.com/office/drawing/2014/main" id="{AFE79C8F-452F-BA8B-0FA4-0BD7DED8D025}"/>
+              </a:ext>
+            </a:extLst>
+          </p:cNvPr>
+          <p:cNvSpPr txBox="1"/>
+          <p:nvPr/>
+        </p:nvSpPr>
+        <p:spPr>
+          <a:xfrm>
+            <a:off x="8128000" y="704850"/>
+            <a:ext cx="5842000" cy="330200"/>
+          </a:xfrm>
+          <a:prstGeom prst="rect">
+            <a:avLst/>
+          </a:prstGeom>
+          <a:noFill/>
+        </p:spPr>
+        <p:txBody>
+          <a:bodyPr vert="horz" wrap="none" lIns="0" tIns="0" rIns="0" bIns="0" rtlCol="0">
+            <a:noAutofit/>
+          </a:bodyPr>
+          <a:lstStyle/>
+          <a:p>
+            <a:r>
+              <a:rPr lang="de-DE" sz="1300">
+                <a:solidFill>
+                  <a:srgbClr val="000000"/>
+                </a:solidFill>
+                <a:latin typeface="Times New Roman" panose="02020603050405020304" pitchFamily="18" charset="0"/>
+              </a:rPr>
+              <a:t>HHHH HHHH</a:t>
+            </a:r>
+          </a:p>
+        </p:txBody>
+      </p:sp>
+      <p:sp>
+        <p:nvSpPr>
+          <p:cNvPr id="30" name="Textfeld 29">
+            <a:extLst>
+              <a:ext uri="{FF2B5EF4-FFF2-40B4-BE49-F238E27FC236}">
+                <a16:creationId xmlns:a16="http://schemas.microsoft.com/office/drawing/2014/main" id="{B5D0FEA0-936D-07B1-CC43-B840848F61BE}"/>
+              </a:ext>
+            </a:extLst>
+          </p:cNvPr>
+          <p:cNvSpPr txBox="1"/>
+          <p:nvPr/>
+        </p:nvSpPr>
+        <p:spPr>
+          <a:xfrm>
+            <a:off x="8128000" y="1206500"/>
+            <a:ext cx="5842000" cy="355600"/>
+          </a:xfrm>
+          <a:prstGeom prst="rect">
+            <a:avLst/>
+          </a:prstGeom>
+          <a:noFill/>
+        </p:spPr>
+        <p:txBody>
+          <a:bodyPr vert="horz" wrap="none" lIns="0" tIns="0" rIns="0" bIns="0" rtlCol="0">
+            <a:noAutofit/>
+          </a:bodyPr>
+          <a:lstStyle/>
+          <a:p>
+            <a:r>
+              <a:rPr lang="de-DE" sz="1400">
+                <a:solidFill>
+                  <a:srgbClr val="000000"/>
+                </a:solidFill>
+                <a:latin typeface="Times New Roman" panose="02020603050405020304" pitchFamily="18" charset="0"/>
+              </a:rPr>
+              <a:t>HHHH HHHH</a:t>
+            </a:r>
+          </a:p>
+        </p:txBody>
+      </p:sp>
+      <p:sp>
+        <p:nvSpPr>
+          <p:cNvPr id="31" name="Textfeld 30">
+            <a:extLst>
+              <a:ext uri="{FF2B5EF4-FFF2-40B4-BE49-F238E27FC236}">
+                <a16:creationId xmlns:a16="http://schemas.microsoft.com/office/drawing/2014/main" id="{CACC111A-91CF-B491-9819-5365A72F0F70}"/>
+              </a:ext>
+            </a:extLst>
+          </p:cNvPr>
+          <p:cNvSpPr txBox="1"/>
+          <p:nvPr/>
+        </p:nvSpPr>
+        <p:spPr>
+          <a:xfrm>
+            <a:off x="8128000" y="1708150"/>
+            <a:ext cx="5842000" cy="381000"/>
+          </a:xfrm>
+          <a:prstGeom prst="rect">
+            <a:avLst/>
+          </a:prstGeom>
+          <a:noFill/>
+        </p:spPr>
+        <p:txBody>
+          <a:bodyPr vert="horz" wrap="none" lIns="0" tIns="0" rIns="0" bIns="0" rtlCol="0">
+            <a:noAutofit/>
+          </a:bodyPr>
+          <a:lstStyle/>
+          <a:p>
+            <a:r>
+              <a:rPr lang="de-DE" sz="1500">
+                <a:solidFill>
+                  <a:srgbClr val="000000"/>
+                </a:solidFill>
+                <a:latin typeface="Times New Roman" panose="02020603050405020304" pitchFamily="18" charset="0"/>
+              </a:rPr>
+              <a:t>HHHH HHHH</a:t>
+            </a:r>
+          </a:p>
+        </p:txBody>
+      </p:sp>
+      <p:sp>
+        <p:nvSpPr>
+          <p:cNvPr id="32" name="Textfeld 31">
+            <a:extLst>
+              <a:ext uri="{FF2B5EF4-FFF2-40B4-BE49-F238E27FC236}">
+                <a16:creationId xmlns:a16="http://schemas.microsoft.com/office/drawing/2014/main" id="{0F660A54-1185-BFE7-30A9-6350DACE9723}"/>
+              </a:ext>
+            </a:extLst>
+          </p:cNvPr>
+          <p:cNvSpPr txBox="1"/>
+          <p:nvPr/>
+        </p:nvSpPr>
+        <p:spPr>
+          <a:xfrm>
+            <a:off x="8128000" y="2209800"/>
+            <a:ext cx="5842000" cy="406400"/>
+          </a:xfrm>
+          <a:prstGeom prst="rect">
+            <a:avLst/>
+          </a:prstGeom>
+          <a:noFill/>
+        </p:spPr>
+        <p:txBody>
+          <a:bodyPr vert="horz" wrap="none" lIns="0" tIns="0" rIns="0" bIns="0" rtlCol="0">
+            <a:noAutofit/>
+          </a:bodyPr>
+          <a:lstStyle/>
+          <a:p>
+            <a:r>
+              <a:rPr lang="de-DE" sz="1600">
+                <a:solidFill>
+                  <a:srgbClr val="000000"/>
+                </a:solidFill>
+                <a:latin typeface="Times New Roman" panose="02020603050405020304" pitchFamily="18" charset="0"/>
+              </a:rPr>
+              <a:t>HHHH HHHH</a:t>
+            </a:r>
+          </a:p>
+        </p:txBody>
+      </p:sp>
+      <p:sp>
+        <p:nvSpPr>
+          <p:cNvPr id="33" name="Textfeld 32">
+            <a:extLst>
+              <a:ext uri="{FF2B5EF4-FFF2-40B4-BE49-F238E27FC236}">
+                <a16:creationId xmlns:a16="http://schemas.microsoft.com/office/drawing/2014/main" id="{7EC63B0C-871A-3F2C-5754-F2C48DF340E8}"/>
+              </a:ext>
+            </a:extLst>
+          </p:cNvPr>
+          <p:cNvSpPr txBox="1"/>
+          <p:nvPr/>
+        </p:nvSpPr>
+        <p:spPr>
+          <a:xfrm>
+            <a:off x="8128000" y="2711450"/>
+            <a:ext cx="5842000" cy="431800"/>
+          </a:xfrm>
+          <a:prstGeom prst="rect">
+            <a:avLst/>
+          </a:prstGeom>
+          <a:noFill/>
+        </p:spPr>
+        <p:txBody>
+          <a:bodyPr vert="horz" wrap="none" lIns="0" tIns="0" rIns="0" bIns="0" rtlCol="0">
+            <a:noAutofit/>
+          </a:bodyPr>
+          <a:lstStyle/>
+          <a:p>
+            <a:r>
+              <a:rPr lang="de-DE" sz="1700">
+                <a:solidFill>
+                  <a:srgbClr val="000000"/>
+                </a:solidFill>
+                <a:latin typeface="Times New Roman" panose="02020603050405020304" pitchFamily="18" charset="0"/>
+              </a:rPr>
+              <a:t>HHHH HHHH</a:t>
+            </a:r>
+          </a:p>
+        </p:txBody>
+      </p:sp>
+      <p:sp>
+        <p:nvSpPr>
+          <p:cNvPr id="34" name="Textfeld 33">
+            <a:extLst>
+              <a:ext uri="{FF2B5EF4-FFF2-40B4-BE49-F238E27FC236}">
+                <a16:creationId xmlns:a16="http://schemas.microsoft.com/office/drawing/2014/main" id="{AC587B7C-E68E-4795-A1F8-09CB4FB730C2}"/>
+              </a:ext>
+            </a:extLst>
+          </p:cNvPr>
+          <p:cNvSpPr txBox="1"/>
+          <p:nvPr/>
+        </p:nvSpPr>
+        <p:spPr>
+          <a:xfrm>
+            <a:off x="8128000" y="3213100"/>
+            <a:ext cx="5842000" cy="457200"/>
+          </a:xfrm>
+          <a:prstGeom prst="rect">
+            <a:avLst/>
+          </a:prstGeom>
+          <a:noFill/>
+        </p:spPr>
+        <p:txBody>
+          <a:bodyPr vert="horz" wrap="none" lIns="0" tIns="0" rIns="0" bIns="0" rtlCol="0">
+            <a:noAutofit/>
+          </a:bodyPr>
+          <a:lstStyle/>
+          <a:p>
+            <a:r>
+              <a:rPr lang="de-DE">
+                <a:solidFill>
+                  <a:srgbClr val="000000"/>
+                </a:solidFill>
+                <a:latin typeface="Times New Roman" panose="02020603050405020304" pitchFamily="18" charset="0"/>
+              </a:rPr>
+              <a:t>HHHH HHHH</a:t>
+            </a:r>
+          </a:p>
+        </p:txBody>
+      </p:sp>
+      <p:sp>
+        <p:nvSpPr>
+          <p:cNvPr id="35" name="Textfeld 34">
+            <a:extLst>
+              <a:ext uri="{FF2B5EF4-FFF2-40B4-BE49-F238E27FC236}">
+                <a16:creationId xmlns:a16="http://schemas.microsoft.com/office/drawing/2014/main" id="{4151B455-4209-8501-5C31-C3B52DA0B4F7}"/>
+              </a:ext>
+            </a:extLst>
+          </p:cNvPr>
+          <p:cNvSpPr txBox="1"/>
+          <p:nvPr/>
+        </p:nvSpPr>
+        <p:spPr>
+          <a:xfrm>
+            <a:off x="8128000" y="3714750"/>
+            <a:ext cx="5842000" cy="482600"/>
+          </a:xfrm>
+          <a:prstGeom prst="rect">
+            <a:avLst/>
+          </a:prstGeom>
+          <a:noFill/>
+        </p:spPr>
+        <p:txBody>
+          <a:bodyPr vert="horz" wrap="none" lIns="0" tIns="0" rIns="0" bIns="0" rtlCol="0">
+            <a:noAutofit/>
+          </a:bodyPr>
+          <a:lstStyle/>
+          <a:p>
+            <a:r>
+              <a:rPr lang="de-DE" sz="1900">
+                <a:solidFill>
+                  <a:srgbClr val="000000"/>
+                </a:solidFill>
+                <a:latin typeface="Times New Roman" panose="02020603050405020304" pitchFamily="18" charset="0"/>
+              </a:rPr>
+              <a:t>HHHH HHHH</a:t>
+            </a:r>
+          </a:p>
+        </p:txBody>
+      </p:sp>
+      <p:sp>
+        <p:nvSpPr>
+          <p:cNvPr id="36" name="Textfeld 35">
+            <a:extLst>
+              <a:ext uri="{FF2B5EF4-FFF2-40B4-BE49-F238E27FC236}">
+                <a16:creationId xmlns:a16="http://schemas.microsoft.com/office/drawing/2014/main" id="{205D12BA-B4CB-E052-D3F8-44F3D38727D8}"/>
+              </a:ext>
+            </a:extLst>
+          </p:cNvPr>
+          <p:cNvSpPr txBox="1"/>
+          <p:nvPr/>
+        </p:nvSpPr>
+        <p:spPr>
+          <a:xfrm>
+            <a:off x="8128000" y="4216400"/>
+            <a:ext cx="5842000" cy="508000"/>
+          </a:xfrm>
+          <a:prstGeom prst="rect">
+            <a:avLst/>
+          </a:prstGeom>
+          <a:noFill/>
+        </p:spPr>
+        <p:txBody>
+          <a:bodyPr vert="horz" wrap="none" lIns="0" tIns="0" rIns="0" bIns="0" rtlCol="0">
+            <a:noAutofit/>
+          </a:bodyPr>
+          <a:lstStyle/>
+          <a:p>
+            <a:r>
+              <a:rPr lang="de-DE" sz="2000">
+                <a:solidFill>
+                  <a:srgbClr val="000000"/>
+                </a:solidFill>
+                <a:latin typeface="Times New Roman" panose="02020603050405020304" pitchFamily="18" charset="0"/>
+              </a:rPr>
+              <a:t>HHHH HHHH</a:t>
+            </a:r>
+          </a:p>
+        </p:txBody>
+      </p:sp>
+      <p:sp>
+        <p:nvSpPr>
+          <p:cNvPr id="37" name="Textfeld 36">
+            <a:extLst>
+              <a:ext uri="{FF2B5EF4-FFF2-40B4-BE49-F238E27FC236}">
+                <a16:creationId xmlns:a16="http://schemas.microsoft.com/office/drawing/2014/main" id="{39B8C45E-5091-F04E-6A48-327AE6B93352}"/>
+              </a:ext>
+            </a:extLst>
+          </p:cNvPr>
+          <p:cNvSpPr txBox="1"/>
+          <p:nvPr/>
+        </p:nvSpPr>
+        <p:spPr>
+          <a:xfrm>
+            <a:off x="8128000" y="4718050"/>
+            <a:ext cx="5842000" cy="533400"/>
+          </a:xfrm>
+          <a:prstGeom prst="rect">
+            <a:avLst/>
+          </a:prstGeom>
+          <a:noFill/>
+        </p:spPr>
+        <p:txBody>
+          <a:bodyPr vert="horz" wrap="none" lIns="0" tIns="0" rIns="0" bIns="0" rtlCol="0">
+            <a:noAutofit/>
+          </a:bodyPr>
+          <a:lstStyle/>
+          <a:p>
+            <a:r>
+              <a:rPr lang="de-DE" sz="2100">
+                <a:solidFill>
+                  <a:srgbClr val="000000"/>
+                </a:solidFill>
+                <a:latin typeface="Times New Roman" panose="02020603050405020304" pitchFamily="18" charset="0"/>
+              </a:rPr>
+              <a:t>HHHH HHHH</a:t>
+            </a:r>
+          </a:p>
+        </p:txBody>
+      </p:sp>
+      <p:sp>
+        <p:nvSpPr>
+          <p:cNvPr id="38" name="Textfeld 37">
+            <a:extLst>
+              <a:ext uri="{FF2B5EF4-FFF2-40B4-BE49-F238E27FC236}">
+                <a16:creationId xmlns:a16="http://schemas.microsoft.com/office/drawing/2014/main" id="{FB751F2B-76CE-DB19-67BD-1C41AB571362}"/>
+              </a:ext>
+            </a:extLst>
+          </p:cNvPr>
+          <p:cNvSpPr txBox="1"/>
+          <p:nvPr/>
+        </p:nvSpPr>
+        <p:spPr>
+          <a:xfrm>
+            <a:off x="8128000" y="5219700"/>
+            <a:ext cx="5842000" cy="558800"/>
+          </a:xfrm>
+          <a:prstGeom prst="rect">
+            <a:avLst/>
+          </a:prstGeom>
+          <a:noFill/>
+        </p:spPr>
+        <p:txBody>
+          <a:bodyPr vert="horz" wrap="none" lIns="0" tIns="0" rIns="0" bIns="0" rtlCol="0">
+            <a:noAutofit/>
+          </a:bodyPr>
+          <a:lstStyle/>
+          <a:p>
+            <a:r>
+              <a:rPr lang="de-DE" sz="2200">
+                <a:solidFill>
+                  <a:srgbClr val="000000"/>
+                </a:solidFill>
+                <a:latin typeface="Times New Roman" panose="02020603050405020304" pitchFamily="18" charset="0"/>
+              </a:rPr>
+              <a:t>HHHH HHHH</a:t>
+            </a:r>
+          </a:p>
+        </p:txBody>
+      </p:sp>
+      <p:sp>
+        <p:nvSpPr>
+          <p:cNvPr id="39" name="Textfeld 38">
+            <a:extLst>
+              <a:ext uri="{FF2B5EF4-FFF2-40B4-BE49-F238E27FC236}">
+                <a16:creationId xmlns:a16="http://schemas.microsoft.com/office/drawing/2014/main" id="{039CCA2F-FC71-D8A7-60CC-299A4070C877}"/>
+              </a:ext>
+            </a:extLst>
+          </p:cNvPr>
+          <p:cNvSpPr txBox="1"/>
+          <p:nvPr/>
+        </p:nvSpPr>
+        <p:spPr>
+          <a:xfrm>
+            <a:off x="8128000" y="5721350"/>
+            <a:ext cx="5842000" cy="584200"/>
+          </a:xfrm>
+          <a:prstGeom prst="rect">
+            <a:avLst/>
+          </a:prstGeom>
+          <a:noFill/>
+        </p:spPr>
+        <p:txBody>
+          <a:bodyPr vert="horz" wrap="none" lIns="0" tIns="0" rIns="0" bIns="0" rtlCol="0">
+            <a:noAutofit/>
+          </a:bodyPr>
+          <a:lstStyle/>
+          <a:p>
+            <a:r>
+              <a:rPr lang="de-DE" sz="2300">
+                <a:solidFill>
+                  <a:srgbClr val="000000"/>
+                </a:solidFill>
+                <a:latin typeface="Times New Roman" panose="02020603050405020304" pitchFamily="18" charset="0"/>
+              </a:rPr>
+              <a:t>HHHH HHHH</a:t>
+            </a:r>
+          </a:p>
+        </p:txBody>
+      </p:sp>
+      <p:sp>
+        <p:nvSpPr>
+          <p:cNvPr id="40" name="Textfeld 39">
+            <a:extLst>
+              <a:ext uri="{FF2B5EF4-FFF2-40B4-BE49-F238E27FC236}">
+                <a16:creationId xmlns:a16="http://schemas.microsoft.com/office/drawing/2014/main" id="{62194652-BB4E-F7F2-AC12-E07C80EA5B4A}"/>
+              </a:ext>
+            </a:extLst>
+          </p:cNvPr>
+          <p:cNvSpPr txBox="1"/>
+          <p:nvPr/>
+        </p:nvSpPr>
+        <p:spPr>
+          <a:xfrm>
+            <a:off x="8128000" y="6223000"/>
+            <a:ext cx="5842000" cy="609600"/>
+          </a:xfrm>
+          <a:prstGeom prst="rect">
+            <a:avLst/>
+          </a:prstGeom>
+          <a:noFill/>
+        </p:spPr>
+        <p:txBody>
+          <a:bodyPr vert="horz" wrap="none" lIns="0" tIns="0" rIns="0" bIns="0" rtlCol="0">
+            <a:noAutofit/>
+          </a:bodyPr>
+          <a:lstStyle/>
+          <a:p>
+            <a:r>
+              <a:rPr lang="de-DE" sz="2400">
+                <a:solidFill>
+                  <a:srgbClr val="000000"/>
+                </a:solidFill>
+                <a:latin typeface="Times New Roman" panose="02020603050405020304" pitchFamily="18" charset="0"/>
+              </a:rPr>
+              <a:t>HHHH HHHH</a:t>
+            </a:r>
+          </a:p>
+        </p:txBody>
+      </p:sp>
+    </p:spTree>
+    <p:extLst>
+      <p:ext uri="{BB962C8B-B14F-4D97-AF65-F5344CB8AC3E}">
+        <p14:creationId xmlns:p14="http://schemas.microsoft.com/office/powerpoint/2010/main" val="4060244654"/>
       </p:ext>
     </p:extLst>
   </p:cSld>

</xml_diff>